<commit_message>
Deck: site URL and QR code, cleaned notes, highlighted transcripts, module slide, DFIR build; render deck and site
Co-Authored-By: Claude Opus 5.5 <noreply@anthropic.com>
</commit_message>
<xml_diff>
--- a/docs/files/crt-essentials.pptx
+++ b/docs/files/crt-essentials.pptx
@@ -5,7 +5,7 @@
     <p:sldMasterId id="2147483648" r:id="rId1"/>
   </p:sldMasterIdLst>
   <p:notesMasterIdLst>
-    <p:notesMasterId r:id="rId62"/>
+    <p:notesMasterId r:id="rId63"/>
   </p:notesMasterIdLst>
   <p:sldIdLst>
     <p:sldId id="256" r:id="rId2"/>
@@ -68,6 +68,7 @@
     <p:sldId id="313" r:id="rId59"/>
     <p:sldId id="314" r:id="rId60"/>
     <p:sldId id="315" r:id="rId61"/>
+    <p:sldId id="316" r:id="rId62"/>
   </p:sldIdLst>
   <p:sldSz cx="12192000" cy="6858000"/>
   <p:notesSz cx="6858000" cy="9144000"/>
@@ -583,7 +584,7 @@
             </a:pPr>
             <a:r>
               <a:rPr/>
-              <a:t>Timing is the proposed pacing budget from outline.md section 3. Demonstrations are included within each section’s allocation.</a:t>
+              <a:t>https://dzampino.github.io/crt-essentials-2026/</a:t>
             </a:r>
           </a:p>
         </p:txBody>
@@ -665,7 +666,7 @@
             </a:pPr>
             <a:r>
               <a:rPr/>
-              <a:t>NIST SP 800-63B-4 section 3.1.1.2: minimum 15 characters when a password is used as a single-factor authenticator, 8 when used only as part of MFA; support at least 64 characters; compare against a blocklist; SHALL NOT impose other composition rules; SHALL NOT require periodic changes, but force a change on evidence of compromise. https://pages.nist.gov/800-63-4/sp800-63b.html Have I Been Pwned, Pwned Passwords: https://haveibeenpwned.com/Passwords</a:t>
+              <a:t>RFC 5280, Internet X.509 PKI Certificate and CRL Profile: https://www.rfc-editor.org/rfc/rfc5280.html</a:t>
             </a:r>
           </a:p>
         </p:txBody>
@@ -687,7 +688,7 @@
           <a:p>
             <a:fld id="{18BDFEC3-8487-43E8-A154-7C12CBC1FFF2}" type="slidenum">
               <a:rPr lang="en-US"/>
-              <a:t>12</a:t>
+              <a:t>15</a:t>
             </a:fld>
             <a:endParaRPr lang="en-US"/>
           </a:p>
@@ -747,7 +748,7 @@
             </a:pPr>
             <a:r>
               <a:rPr/>
-              <a:t>Proposed wording for the sub-points.</a:t>
+              <a:t>RFC 5280 section 4.1 (fields) and 4.2 (extensions).</a:t>
             </a:r>
           </a:p>
           <a:p>
@@ -761,7 +762,7 @@
             </a:pPr>
             <a:r>
               <a:rPr/>
-              <a:t>RFC 5280, Internet X.509 PKI Certificate and CRL Profile: https://www.rfc-editor.org/rfc/rfc5280.html</a:t>
+              <a:t>RFC 9525 section 2: “The Common Name RDN MUST NOT be used to identify a service.” Names are matched against the SAN. https://www.rfc-editor.org/rfc/rfc9525.html</a:t>
             </a:r>
           </a:p>
         </p:txBody>
@@ -783,7 +784,7 @@
           <a:p>
             <a:fld id="{18BDFEC3-8487-43E8-A154-7C12CBC1FFF2}" type="slidenum">
               <a:rPr lang="en-US"/>
-              <a:t>15</a:t>
+              <a:t>16</a:t>
             </a:fld>
             <a:endParaRPr lang="en-US"/>
           </a:p>
@@ -843,7 +844,7 @@
             </a:pPr>
             <a:r>
               <a:rPr/>
-              <a:t>RFC 5280 section 4.1 (fields) and 4.2 (extensions).</a:t>
+              <a:t>Inspect it with openssl x509, certutil -dump or XCA.</a:t>
             </a:r>
           </a:p>
           <a:p>
@@ -857,7 +858,7 @@
             </a:pPr>
             <a:r>
               <a:rPr/>
-              <a:t>RFC 9525 section 2: “The Common Name RDN MUST NOT be used to identify a service.” Names are matched against the SAN. https://www.rfc-editor.org/rfc/rfc9525.html</a:t>
+              <a:t>Output trimmed and condensed from: openssl x509 -in training-leaf.pem -noout -text (OpenSSL 3.5). The full subject also has ST=Wisconsin, C=US.</a:t>
             </a:r>
           </a:p>
           <a:p>
@@ -871,7 +872,21 @@
             </a:pPr>
             <a:r>
               <a:rPr/>
-              <a:t>Companion site: field reference with OIDs.</a:t>
+              <a:t>Fictional training certificates for the fictional Squeaky Curds Co-op; .example is reserved (RFC 2606), so the names do not exist. No private keys are included. Do not install the training root.</a:t>
+            </a:r>
+          </a:p>
+          <a:p>
+            <a:pPr lvl="0" indent="0" marL="0">
+              <a:buNone/>
+            </a:pPr>
+          </a:p>
+          <a:p>
+            <a:pPr lvl="0" indent="0" marL="0">
+              <a:buNone/>
+            </a:pPr>
+            <a:r>
+              <a:rPr/>
+              <a:t>XCA, a graphical certificate and key manager: https://hohnstaedt.de/xca/</a:t>
             </a:r>
           </a:p>
         </p:txBody>
@@ -893,7 +908,7 @@
           <a:p>
             <a:fld id="{18BDFEC3-8487-43E8-A154-7C12CBC1FFF2}" type="slidenum">
               <a:rPr lang="en-US"/>
-              <a:t>16</a:t>
+              <a:t>17</a:t>
             </a:fld>
             <a:endParaRPr lang="en-US"/>
           </a:p>
@@ -953,7 +968,7 @@
             </a:pPr>
             <a:r>
               <a:rPr/>
-              <a:t>Output trimmed and condensed from: openssl x509 -in training-leaf.pem -noout -text (OpenSSL 3.5).</a:t>
+              <a:t>The training sample is a two-level chain: the root signs the leaf directly. Public CAs issue from intermediates.</a:t>
             </a:r>
           </a:p>
           <a:p>
@@ -967,7 +982,7 @@
             </a:pPr>
             <a:r>
               <a:rPr/>
-              <a:t>The sample files are fictional training certificates; no private keys are included. Do not install the training root. Download them from the companion site.</a:t>
+              <a:t>RFC 5280 section 6 (certification path validation).</a:t>
             </a:r>
           </a:p>
         </p:txBody>
@@ -989,7 +1004,7 @@
           <a:p>
             <a:fld id="{18BDFEC3-8487-43E8-A154-7C12CBC1FFF2}" type="slidenum">
               <a:rPr lang="en-US"/>
-              <a:t>17</a:t>
+              <a:t>18</a:t>
             </a:fld>
             <a:endParaRPr lang="en-US"/>
           </a:p>
@@ -1049,7 +1064,7 @@
             </a:pPr>
             <a:r>
               <a:rPr/>
-              <a:t>The training sample is a two-level chain: the root signs the leaf directly. Public CAs issue from intermediates.</a:t>
+              <a:t>RFC 7468 (PEM textual encodings), RFC 7292 (PKCS #12), RFC 5652 (CMS, the basis of .p7b), RFC 2986 (PKCS #10).</a:t>
             </a:r>
           </a:p>
           <a:p>
@@ -1063,7 +1078,21 @@
             </a:pPr>
             <a:r>
               <a:rPr/>
-              <a:t>RFC 5280 section 6 (certification path validation).</a:t>
+              <a:t>training-leaf.pem and training-leaf.der are the same certificate: both have SHA-256 fingerprint D1:B7:D4:59:…:C0:E5. certutil -dump reads both.</a:t>
+            </a:r>
+          </a:p>
+          <a:p>
+            <a:pPr lvl="0" indent="0" marL="0">
+              <a:buNone/>
+            </a:pPr>
+          </a:p>
+          <a:p>
+            <a:pPr lvl="0" indent="0" marL="0">
+              <a:buNone/>
+            </a:pPr>
+            <a:r>
+              <a:rPr/>
+              <a:t>OpenSSL on Windows: it comes with Git for Windows, or winget install ShiningLight.OpenSSL.Light (other builds: https://github.com/openssl/openssl/wiki/Binaries).</a:t>
             </a:r>
           </a:p>
         </p:txBody>
@@ -1085,7 +1114,7 @@
           <a:p>
             <a:fld id="{18BDFEC3-8487-43E8-A154-7C12CBC1FFF2}" type="slidenum">
               <a:rPr lang="en-US"/>
-              <a:t>18</a:t>
+              <a:t>19</a:t>
             </a:fld>
             <a:endParaRPr lang="en-US"/>
           </a:p>
@@ -1145,7 +1174,7 @@
             </a:pPr>
             <a:r>
               <a:rPr/>
-              <a:t>RFC 7468 (PEM textual encodings), RFC 7292 (PKCS #12), RFC 5652 (CMS, the basis of .p7b), RFC 2986 (PKCS #10).</a:t>
+              <a:t>RFC 2986 (PKCS #10): https://www.rfc-editor.org/rfc/rfc2986.html certreq: https://learn.microsoft.com/en-us/windows-server/administration/windows-commands/certreq_1 RFC 8555 (ACME): https://www.rfc-editor.org/rfc/rfc8555.html</a:t>
             </a:r>
           </a:p>
           <a:p>
@@ -1159,7 +1188,7 @@
             </a:pPr>
             <a:r>
               <a:rPr/>
-              <a:t>training-leaf.pem and training-leaf.der are the same certificate: both have SHA-256 fingerprint 3B:44:01:67:…:17:E2. certutil -dump reads both.</a:t>
+              <a:t>The training CSR’s public key matches the training leaf: openssl req -in training-request.csr -noout -verify reports “Certificate request self-signature verify OK”.</a:t>
             </a:r>
           </a:p>
         </p:txBody>
@@ -1181,7 +1210,7 @@
           <a:p>
             <a:fld id="{18BDFEC3-8487-43E8-A154-7C12CBC1FFF2}" type="slidenum">
               <a:rPr lang="en-US"/>
-              <a:t>19</a:t>
+              <a:t>20</a:t>
             </a:fld>
             <a:endParaRPr lang="en-US"/>
           </a:p>
@@ -1241,35 +1270,7 @@
             </a:pPr>
             <a:r>
               <a:rPr/>
-              <a:t>RFC 2986 (PKCS #10): https://www.rfc-editor.org/rfc/rfc2986.html certreq: https://learn.microsoft.com/en-us/windows-server/administration/windows-commands/certreq_1 RFC 8555 (ACME): https://www.rfc-editor.org/rfc/rfc8555.html</a:t>
-            </a:r>
-          </a:p>
-          <a:p>
-            <a:pPr lvl="0" indent="0" marL="0">
-              <a:buNone/>
-            </a:pPr>
-          </a:p>
-          <a:p>
-            <a:pPr lvl="0" indent="0" marL="0">
-              <a:buNone/>
-            </a:pPr>
-            <a:r>
-              <a:rPr/>
-              <a:t>The training CSR’s public key matches the training leaf: openssl req -in training-request.csr -noout -verify reports “Certificate request self-signature verify OK”.</a:t>
-            </a:r>
-          </a:p>
-          <a:p>
-            <a:pPr lvl="0" indent="0" marL="0">
-              <a:buNone/>
-            </a:pPr>
-          </a:p>
-          <a:p>
-            <a:pPr lvl="0" indent="0" marL="0">
-              <a:buNone/>
-            </a:pPr>
-            <a:r>
-              <a:rPr/>
-              <a:t>Companion site: CSR, AD CS and ACME examples.</a:t>
+              <a:t>A common incident-response finding: a missing intermediate works in one browser (which cached or fetched it) and fails in another client.</a:t>
             </a:r>
           </a:p>
         </p:txBody>
@@ -1291,7 +1292,7 @@
           <a:p>
             <a:fld id="{18BDFEC3-8487-43E8-A154-7C12CBC1FFF2}" type="slidenum">
               <a:rPr lang="en-US"/>
-              <a:t>20</a:t>
+              <a:t>21</a:t>
             </a:fld>
             <a:endParaRPr lang="en-US"/>
           </a:p>
@@ -1351,7 +1352,7 @@
             </a:pPr>
             <a:r>
               <a:rPr/>
-              <a:t>Proposed wording for the sub-points.</a:t>
+              <a:t>Each row was produced against the training files with openssl verify (OpenSSL 3.5); the commands are on the companion site.</a:t>
             </a:r>
           </a:p>
           <a:p>
@@ -1365,7 +1366,7 @@
             </a:pPr>
             <a:r>
               <a:rPr/>
-              <a:t>A common incident-response finding: a missing intermediate works in one browser (which cached or fetched it) and fails in another client.</a:t>
+              <a:t>Revocation: Let’s Encrypt ended its OCSP service on August 6, 2025 and publishes revocation through CRLs only: https://letsencrypt.org/2025/08/06/ocsp-service-has-reached-end-of-life Chrome uses CRLSets rather than online checks for most certificates: https://www.chromium.org/Home/chromium-security/crlsets/</a:t>
             </a:r>
           </a:p>
         </p:txBody>
@@ -1387,7 +1388,7 @@
           <a:p>
             <a:fld id="{18BDFEC3-8487-43E8-A154-7C12CBC1FFF2}" type="slidenum">
               <a:rPr lang="en-US"/>
-              <a:t>21</a:t>
+              <a:t>22</a:t>
             </a:fld>
             <a:endParaRPr lang="en-US"/>
           </a:p>
@@ -1447,7 +1448,7 @@
             </a:pPr>
             <a:r>
               <a:rPr/>
-              <a:t>Each row was produced against the training files with openssl verify (OpenSSL 3.5.7); commands are on the companion site.</a:t>
+              <a:t>CA/Browser Forum Baseline Requirements section 1.2.2, from ballot SC-081v3 (passed April 2025): https://cabforum.org/working-groups/server/baseline-requirements/requirements/</a:t>
             </a:r>
           </a:p>
           <a:p>
@@ -1461,7 +1462,7 @@
             </a:pPr>
             <a:r>
               <a:rPr/>
-              <a:t>Revocation: Let’s Encrypt ended its OCSP service on August 6, 2025 and publishes revocation through CRLs only: https://letsencrypt.org/2025/08/06/ocsp-service-has-reached-end-of-life Chrome uses CRLSets rather than online checks for most certificates: https://www.chromium.org/Home/chromium-security/crlsets/</a:t>
+              <a:t>These limits apply to publicly trusted TLS certificates. Internal CAs set their own policy; the training root is not a statement of public Web PKI issuance policy.</a:t>
             </a:r>
           </a:p>
         </p:txBody>
@@ -1483,7 +1484,7 @@
           <a:p>
             <a:fld id="{18BDFEC3-8487-43E8-A154-7C12CBC1FFF2}" type="slidenum">
               <a:rPr lang="en-US"/>
-              <a:t>22</a:t>
+              <a:t>23</a:t>
             </a:fld>
             <a:endParaRPr lang="en-US"/>
           </a:p>
@@ -1543,7 +1544,7 @@
             </a:pPr>
             <a:r>
               <a:rPr/>
-              <a:t>CA/Browser Forum Baseline Requirements section 1.2.2, from ballot SC-081v3 (passed April 2025): https://cabforum.org/working-groups/server/baseline-requirements/requirements/</a:t>
+              <a:t>RFC 5598, Internet Mail Architecture: https://www.rfc-editor.org/rfc/rfc5598.html RFC 5321, SMTP: https://www.rfc-editor.org/rfc/rfc5321.html</a:t>
             </a:r>
           </a:p>
           <a:p>
@@ -1557,7 +1558,7 @@
             </a:pPr>
             <a:r>
               <a:rPr/>
-              <a:t>These limits apply to publicly trusted TLS certificates. Internal CAs set their own policy; the training root is not a statement of public Web PKI issuance policy.</a:t>
+              <a:t>RFC 6409 section 4.3: the MSA must reject unauthenticated mail by default “unless it has already independently established authentication or authorization (such as being within a protected subnetwork)”. Section 3.1: “A site MAY choose to use port 25 for message submission.” Printers, scanners and applications relaying through an IP-restricted connector are the everyday example. https://www.rfc-editor.org/rfc/rfc6409.html</a:t>
             </a:r>
           </a:p>
         </p:txBody>
@@ -1579,7 +1580,7 @@
           <a:p>
             <a:fld id="{18BDFEC3-8487-43E8-A154-7C12CBC1FFF2}" type="slidenum">
               <a:rPr lang="en-US"/>
-              <a:t>23</a:t>
+              <a:t>26</a:t>
             </a:fld>
             <a:endParaRPr lang="en-US"/>
           </a:p>
@@ -1639,21 +1640,7 @@
             </a:pPr>
             <a:r>
               <a:rPr/>
-              <a:t>Proposed wording, drawn from outline.md section 1.</a:t>
-            </a:r>
-          </a:p>
-          <a:p>
-            <a:pPr lvl="0" indent="0" marL="0">
-              <a:buNone/>
-            </a:pPr>
-          </a:p>
-          <a:p>
-            <a:pPr lvl="0" indent="0" marL="0">
-              <a:buNone/>
-            </a:pPr>
-            <a:r>
-              <a:rPr/>
-              <a:t>The companion site holds the calculators, sample files, commands, scripts and references that do not fit in a two-hour session.</a:t>
+              <a:t>Timing: introduction 5 minutes, passwords 20, PKI 25, email security 30, PowerShell 20, DFIR box 15, questions and wrap-up 5.</a:t>
             </a:r>
           </a:p>
         </p:txBody>
@@ -1735,7 +1722,7 @@
             </a:pPr>
             <a:r>
               <a:rPr/>
-              <a:t>RFC 5598, Internet Mail Architecture: https://www.rfc-editor.org/rfc/rfc5598.html RFC 5321, SMTP: https://www.rfc-editor.org/rfc/rfc5321.html</a:t>
+              <a:t>RFC 5321 section 4.4: the delivering SMTP server inserts Return-Path from the MAIL FROM reverse-path. RFC 5322 section 3.6.2: From, Sender, Reply-To.</a:t>
             </a:r>
           </a:p>
         </p:txBody>
@@ -1757,7 +1744,7 @@
           <a:p>
             <a:fld id="{18BDFEC3-8487-43E8-A154-7C12CBC1FFF2}" type="slidenum">
               <a:rPr lang="en-US"/>
-              <a:t>26</a:t>
+              <a:t>27</a:t>
             </a:fld>
             <a:endParaRPr lang="en-US"/>
           </a:p>
@@ -1817,7 +1804,21 @@
             </a:pPr>
             <a:r>
               <a:rPr/>
-              <a:t>RFC 5321 section 4.4: the delivering SMTP server inserts Return-Path from the MAIL FROM reverse-path. RFC 5322 section 3.6.2: From, Sender, Reply-To.</a:t>
+              <a:t>RFC 8601, Authentication-Results: https://datatracker.ietf.org/doc/html/rfc8601</a:t>
+            </a:r>
+          </a:p>
+          <a:p>
+            <a:pPr lvl="0" indent="0" marL="0">
+              <a:buNone/>
+            </a:pPr>
+          </a:p>
+          <a:p>
+            <a:pPr lvl="0" indent="0" marL="0">
+              <a:buNone/>
+            </a:pPr>
+            <a:r>
+              <a:rPr/>
+              <a:t>Message Header Analyzer: paste headers at https://mha.azurewebsites.net/pages/mha.html, or install the Outlook add-in. Source: https://github.com/microsoft/MHA</a:t>
             </a:r>
           </a:p>
         </p:txBody>
@@ -1839,7 +1840,7 @@
           <a:p>
             <a:fld id="{18BDFEC3-8487-43E8-A154-7C12CBC1FFF2}" type="slidenum">
               <a:rPr lang="en-US"/>
-              <a:t>27</a:t>
+              <a:t>28</a:t>
             </a:fld>
             <a:endParaRPr lang="en-US"/>
           </a:p>
@@ -1899,7 +1900,7 @@
             </a:pPr>
             <a:r>
               <a:rPr/>
-              <a:t>Proposed wording for the sub-points.</a:t>
+              <a:t>RFC 7208: SPF checks the MAIL FROM domain (or the HELO domain when MAIL FROM is empty), not the From header. https://www.rfc-editor.org/rfc/rfc7208.html</a:t>
             </a:r>
           </a:p>
           <a:p>
@@ -1913,7 +1914,7 @@
             </a:pPr>
             <a:r>
               <a:rPr/>
-              <a:t>RFC 8601, Authentication-Results: https://datatracker.ietf.org/doc/html/rfc8601 Companion site: annotated sample headers.</a:t>
+              <a:t>Record from learndmarc.com example 1.</a:t>
             </a:r>
           </a:p>
         </p:txBody>
@@ -1935,7 +1936,7 @@
           <a:p>
             <a:fld id="{18BDFEC3-8487-43E8-A154-7C12CBC1FFF2}" type="slidenum">
               <a:rPr lang="en-US"/>
-              <a:t>28</a:t>
+              <a:t>29</a:t>
             </a:fld>
             <a:endParaRPr lang="en-US"/>
           </a:p>
@@ -1995,21 +1996,7 @@
             </a:pPr>
             <a:r>
               <a:rPr/>
-              <a:t>RFC 7208: SPF checks the MAIL FROM domain (or the HELO domain when MAIL FROM is empty), not the From header. https://www.rfc-editor.org/rfc/rfc7208.html</a:t>
-            </a:r>
-          </a:p>
-          <a:p>
-            <a:pPr lvl="0" indent="0" marL="0">
-              <a:buNone/>
-            </a:pPr>
-          </a:p>
-          <a:p>
-            <a:pPr lvl="0" indent="0" marL="0">
-              <a:buNone/>
-            </a:pPr>
-            <a:r>
-              <a:rPr/>
-              <a:t>Record from learndmarc.com example 1.</a:t>
+              <a:t>RFC 6376: https://www.rfc-editor.org/rfc/rfc6376.html The d= domain does not have to match the From domain; DMARC is what requires alignment.</a:t>
             </a:r>
           </a:p>
         </p:txBody>
@@ -2031,7 +2018,7 @@
           <a:p>
             <a:fld id="{18BDFEC3-8487-43E8-A154-7C12CBC1FFF2}" type="slidenum">
               <a:rPr lang="en-US"/>
-              <a:t>29</a:t>
+              <a:t>30</a:t>
             </a:fld>
             <a:endParaRPr lang="en-US"/>
           </a:p>
@@ -2091,7 +2078,7 @@
             </a:pPr>
             <a:r>
               <a:rPr/>
-              <a:t>RFC 6376: https://www.rfc-editor.org/rfc/rfc6376.html The d= domain does not have to match the From domain; DMARC is what requires alignment.</a:t>
+              <a:t>RFC 9989 (May 2026, Standards Track) obsoletes RFC 7489 and RFC 9091. Section 3.2.10 defines strict and relaxed alignment; adkim and aspf default to r (relaxed). Changes: pct, rf and ri removed; t (test mode), np and psd added; organizational domain found by a DNS tree walk instead of a public suffix list. https://www.rfc-editor.org/rfc/rfc9989.html Aggregate reports: RFC 9990. Failure reports: RFC 9991.</a:t>
             </a:r>
           </a:p>
         </p:txBody>
@@ -2113,7 +2100,7 @@
           <a:p>
             <a:fld id="{18BDFEC3-8487-43E8-A154-7C12CBC1FFF2}" type="slidenum">
               <a:rPr lang="en-US"/>
-              <a:t>30</a:t>
+              <a:t>31</a:t>
             </a:fld>
             <a:endParaRPr lang="en-US"/>
           </a:p>
@@ -2173,7 +2160,7 @@
             </a:pPr>
             <a:r>
               <a:rPr/>
-              <a:t>RFC 9989 (May 2026, Standards Track) obsoletes RFC 7489 and RFC 9091. Section 3.2.10 defines strict and relaxed alignment; adkim and aspf default to r (relaxed). Changes: pct, rf and ri removed; t (test mode), np and psd added; organizational domain found by a DNS tree walk instead of a public suffix list. https://www.rfc-editor.org/rfc/rfc9989.html Aggregate reports: RFC 9990. Failure reports: RFC 9991.</a:t>
+              <a:t>Transcript from learndmarc.com, abridged. Lines starting &gt; are the client; lines starting . are the server. Ask: what are the sender identities, what did SPF and DKIM return, and does it pass DMARC?</a:t>
             </a:r>
           </a:p>
         </p:txBody>
@@ -2195,7 +2182,7 @@
           <a:p>
             <a:fld id="{18BDFEC3-8487-43E8-A154-7C12CBC1FFF2}" type="slidenum">
               <a:rPr lang="en-US"/>
-              <a:t>31</a:t>
+              <a:t>32</a:t>
             </a:fld>
             <a:endParaRPr lang="en-US"/>
           </a:p>
@@ -2255,7 +2242,7 @@
             </a:pPr>
             <a:r>
               <a:rPr/>
-              <a:t>Transcript from learndmarc.com, abridged. Ask: what are the sender identities, what did SPF and DKIM return, and does it pass DMARC?</a:t>
+              <a:t>Transcript from learndmarc.com, abridged.</a:t>
             </a:r>
           </a:p>
         </p:txBody>
@@ -2277,7 +2264,7 @@
           <a:p>
             <a:fld id="{18BDFEC3-8487-43E8-A154-7C12CBC1FFF2}" type="slidenum">
               <a:rPr lang="en-US"/>
-              <a:t>32</a:t>
+              <a:t>34</a:t>
             </a:fld>
             <a:endParaRPr lang="en-US"/>
           </a:p>
@@ -2337,7 +2324,7 @@
             </a:pPr>
             <a:r>
               <a:rPr/>
-              <a:t>From samples/email/answers.md (learndmarc-1).</a:t>
+              <a:t>Transcript from learndmarc.com, abridged. Note the trap: the sending IP is listed in red.primary.com’s SPF record, but SPF is evaluated against the MAIL FROM domain.</a:t>
             </a:r>
           </a:p>
         </p:txBody>
@@ -2359,7 +2346,7 @@
           <a:p>
             <a:fld id="{18BDFEC3-8487-43E8-A154-7C12CBC1FFF2}" type="slidenum">
               <a:rPr lang="en-US"/>
-              <a:t>33</a:t>
+              <a:t>36</a:t>
             </a:fld>
             <a:endParaRPr lang="en-US"/>
           </a:p>
@@ -2419,7 +2406,7 @@
             </a:pPr>
             <a:r>
               <a:rPr/>
-              <a:t>Transcript from learndmarc.com, abridged.</a:t>
+              <a:t>Both domains share the organizational domain primary.com, which is why relaxed alignment would have passed.</a:t>
             </a:r>
           </a:p>
         </p:txBody>
@@ -2441,7 +2428,7 @@
           <a:p>
             <a:fld id="{18BDFEC3-8487-43E8-A154-7C12CBC1FFF2}" type="slidenum">
               <a:rPr lang="en-US"/>
-              <a:t>34</a:t>
+              <a:t>37</a:t>
             </a:fld>
             <a:endParaRPr lang="en-US"/>
           </a:p>
@@ -2501,7 +2488,7 @@
             </a:pPr>
             <a:r>
               <a:rPr/>
-              <a:t>From samples/email/answers.md (learndmarc-2).</a:t>
+              <a:t>RFC 8461 (MTA-STS): https://www.rfc-editor.org/rfc/rfc8461.html RFC 8460 (TLS-RPT): https://www.rfc-editor.org/rfc/rfc8460.html RFC 6686 (Sender ID and SPF experiment resolution): https://www.rfc-editor.org/rfc/rfc6686.html</a:t>
             </a:r>
           </a:p>
         </p:txBody>
@@ -2523,7 +2510,7 @@
           <a:p>
             <a:fld id="{18BDFEC3-8487-43E8-A154-7C12CBC1FFF2}" type="slidenum">
               <a:rPr lang="en-US"/>
-              <a:t>35</a:t>
+              <a:t>38</a:t>
             </a:fld>
             <a:endParaRPr lang="en-US"/>
           </a:p>
@@ -2583,7 +2570,21 @@
             </a:pPr>
             <a:r>
               <a:rPr/>
-              <a:t>[David’s notes to add.]</a:t>
+              <a:t>xkcd 936, “Password Strength,” by Randall Munroe: https://xkcd.com/936/ (CC BY-NC 2.5).</a:t>
+            </a:r>
+          </a:p>
+          <a:p>
+            <a:pPr lvl="0" indent="0" marL="0">
+              <a:buNone/>
+            </a:pPr>
+          </a:p>
+          <a:p>
+            <a:pPr lvl="0" indent="0" marL="0">
+              <a:buNone/>
+            </a:pPr>
+            <a:r>
+              <a:rPr/>
+              <a:t>The explanation holds when the words are randomly selected rather than chosen by a person. The comic’s guess rates are historical, not a present-day benchmark.</a:t>
             </a:r>
           </a:p>
         </p:txBody>
@@ -2605,7 +2606,7 @@
           <a:p>
             <a:fld id="{18BDFEC3-8487-43E8-A154-7C12CBC1FFF2}" type="slidenum">
               <a:rPr lang="en-US"/>
-              <a:t>5</a:t>
+              <a:t>6</a:t>
             </a:fld>
             <a:endParaRPr lang="en-US"/>
           </a:p>
@@ -2665,7 +2666,7 @@
             </a:pPr>
             <a:r>
               <a:rPr/>
-              <a:t>Transcript from learndmarc.com, abridged. Note the trap: the sending IP is listed in red.primary.com’s SPF record, but SPF is evaluated against the MAIL FROM domain.</a:t>
+              <a:t>Get-Help shows local help; run Update-Help once (as administrator in Windows PowerShell 5.1) or use Get-Help -Online.</a:t>
             </a:r>
           </a:p>
         </p:txBody>
@@ -2687,7 +2688,7 @@
           <a:p>
             <a:fld id="{18BDFEC3-8487-43E8-A154-7C12CBC1FFF2}" type="slidenum">
               <a:rPr lang="en-US"/>
-              <a:t>36</a:t>
+              <a:t>42</a:t>
             </a:fld>
             <a:endParaRPr lang="en-US"/>
           </a:p>
@@ -2747,7 +2748,7 @@
             </a:pPr>
             <a:r>
               <a:rPr/>
-              <a:t>From samples/email/answers.md (learndmarc-3). The relaxed-alignment sub-point is an added observation: both domains share the organizational domain primary.com.</a:t>
+              <a:t>about_Pipelines: https://learn.microsoft.com/en-us/powershell/module/microsoft.powershell.core/about/about_pipelines</a:t>
             </a:r>
           </a:p>
         </p:txBody>
@@ -2769,7 +2770,7 @@
           <a:p>
             <a:fld id="{18BDFEC3-8487-43E8-A154-7C12CBC1FFF2}" type="slidenum">
               <a:rPr lang="en-US"/>
-              <a:t>37</a:t>
+              <a:t>43</a:t>
             </a:fld>
             <a:endParaRPr lang="en-US"/>
           </a:p>
@@ -2829,7 +2830,7 @@
             </a:pPr>
             <a:r>
               <a:rPr/>
-              <a:t>RFC 8461 (MTA-STS): https://www.rfc-editor.org/rfc/rfc8461.html RFC 8460 (TLS-RPT): https://www.rfc-editor.org/rfc/rfc8460.html RFC 6686 (Sender ID and SPF experiment resolution): https://www.rfc-editor.org/rfc/rfc6686.html</a:t>
+              <a:t>Export-Csv: https://learn.microsoft.com/en-us/powershell/module/microsoft.powershell.utility/export-csv -NoTypeInformation is the default in PowerShell 7 and needed in Windows PowerShell 5.1.</a:t>
             </a:r>
           </a:p>
         </p:txBody>
@@ -2851,7 +2852,7 @@
           <a:p>
             <a:fld id="{18BDFEC3-8487-43E8-A154-7C12CBC1FFF2}" type="slidenum">
               <a:rPr lang="en-US"/>
-              <a:t>38</a:t>
+              <a:t>44</a:t>
             </a:fld>
             <a:endParaRPr lang="en-US"/>
           </a:p>
@@ -2911,7 +2912,7 @@
             </a:pPr>
             <a:r>
               <a:rPr/>
-              <a:t>[David’s notes to add.] The third point is proposed wording.</a:t>
+              <a:t>Working with an existing collection of files. Get-FileInventory, on the companion site, combines these into one function.</a:t>
             </a:r>
           </a:p>
         </p:txBody>
@@ -2933,7 +2934,7 @@
           <a:p>
             <a:fld id="{18BDFEC3-8487-43E8-A154-7C12CBC1FFF2}" type="slidenum">
               <a:rPr lang="en-US"/>
-              <a:t>41</a:t>
+              <a:t>45</a:t>
             </a:fld>
             <a:endParaRPr lang="en-US"/>
           </a:p>
@@ -2993,7 +2994,7 @@
             </a:pPr>
             <a:r>
               <a:rPr/>
-              <a:t>Get-Help shows local help; run Update-Help once (as administrator in Windows PowerShell 5.1) or use Get-Help -Online.</a:t>
+              <a:t>Get-WinEvent: https://learn.microsoft.com/en-us/powershell/module/microsoft.powershell.diagnostics/get-winevent 4624 is a successful logon, 4625 a failed logon. Get-EvtxSummary and Get-LogonEvent on the companion site extend this.</a:t>
             </a:r>
           </a:p>
         </p:txBody>
@@ -3015,7 +3016,7 @@
           <a:p>
             <a:fld id="{18BDFEC3-8487-43E8-A154-7C12CBC1FFF2}" type="slidenum">
               <a:rPr lang="en-US"/>
-              <a:t>42</a:t>
+              <a:t>46</a:t>
             </a:fld>
             <a:endParaRPr lang="en-US"/>
           </a:p>
@@ -3075,7 +3076,7 @@
             </a:pPr>
             <a:r>
               <a:rPr/>
-              <a:t>about_Pipelines: https://learn.microsoft.com/en-us/powershell/module/microsoft.powershell.core/about/about_pipelines</a:t>
+              <a:t>about_Functions_CmdletBindingAttribute and ShouldProcess: https://learn.microsoft.com/en-us/powershell/module/microsoft.powershell.core/about/about_functions_cmdletbindingattribute New-CaseFolder -Path E:\2026-0142 -WhatIf shows what would happen without doing it. The full version on the companion site creates Collected, Output and Notes.</a:t>
             </a:r>
           </a:p>
         </p:txBody>
@@ -3097,7 +3098,7 @@
           <a:p>
             <a:fld id="{18BDFEC3-8487-43E8-A154-7C12CBC1FFF2}" type="slidenum">
               <a:rPr lang="en-US"/>
-              <a:t>43</a:t>
+              <a:t>47</a:t>
             </a:fld>
             <a:endParaRPr lang="en-US"/>
           </a:p>
@@ -3157,7 +3158,7 @@
             </a:pPr>
             <a:r>
               <a:rPr/>
-              <a:t>Export-Csv: https://learn.microsoft.com/en-us/powershell/module/microsoft.powershell.utility/export-csv -NoTypeInformation is the default in PowerShell 7 and needed in Windows PowerShell 5.1.</a:t>
+              <a:t>about_Modules: https://learn.microsoft.com/en-us/powershell/module/microsoft.powershell.core/about/about_modules Windows PowerShell 5.1 uses Documentsinstead. Every function on the companion site is in its own copyable block, and all of them are packaged as the CrtEssentials module.</a:t>
             </a:r>
           </a:p>
         </p:txBody>
@@ -3179,7 +3180,7 @@
           <a:p>
             <a:fld id="{18BDFEC3-8487-43E8-A154-7C12CBC1FFF2}" type="slidenum">
               <a:rPr lang="en-US"/>
-              <a:t>44</a:t>
+              <a:t>48</a:t>
             </a:fld>
             <a:endParaRPr lang="en-US"/>
           </a:p>
@@ -3239,7 +3240,7 @@
             </a:pPr>
             <a:r>
               <a:rPr/>
-              <a:t>Working with an existing collection of files. The full Get-FileInventory.ps1 script is on the companion site.</a:t>
+              <a:t>Independent non-persistent disks discard changes at power-off: https://docs.vmware.com/en/VMware-Workstation-Pro/17/com.vmware.ws.using.doc/GUID-A6792F54-2734-4AF4-9473-C8B9AD8321AF.html Workstation Pro is free for commercial, educational and personal use since November 2024: https://knowledge.broadcom.com/external/article/368667/download-and-license-vmware-desktop-hypervisor.html In the guest, shared folders are at \vmware-hostFolders.</a:t>
             </a:r>
           </a:p>
         </p:txBody>
@@ -3261,7 +3262,7 @@
           <a:p>
             <a:fld id="{18BDFEC3-8487-43E8-A154-7C12CBC1FFF2}" type="slidenum">
               <a:rPr lang="en-US"/>
-              <a:t>45</a:t>
+              <a:t>52</a:t>
             </a:fld>
             <a:endParaRPr lang="en-US"/>
           </a:p>
@@ -3321,7 +3322,7 @@
             </a:pPr>
             <a:r>
               <a:rPr/>
-              <a:t>Get-WinEvent: https://learn.microsoft.com/en-us/powershell/module/microsoft.powershell.diagnostics/get-winevent 4624 is a successful logon, 4625 a failed logon. The Get-EvtxSummary.ps1 script on the companion site extends this.</a:t>
+              <a:t>Windows Server hardware requirements list a TPM as required only for certain features: https://learn.microsoft.com/en-us/windows-server/get-started/hardware-requirements Defender on Windows Server is the Windows-Defender feature: https://learn.microsoft.com/en-us/defender-endpoint/microsoft-defender-antivirus-windows-server-configure The 180-day evaluation must be activated online within its first 10 days. The unattend generator is written for Windows 10 and 11; test its output on Server 2025.</a:t>
             </a:r>
           </a:p>
         </p:txBody>
@@ -3343,7 +3344,7 @@
           <a:p>
             <a:fld id="{18BDFEC3-8487-43E8-A154-7C12CBC1FFF2}" type="slidenum">
               <a:rPr lang="en-US"/>
-              <a:t>46</a:t>
+              <a:t>53</a:t>
             </a:fld>
             <a:endParaRPr lang="en-US"/>
           </a:p>
@@ -3403,7 +3404,7 @@
             </a:pPr>
             <a:r>
               <a:rPr/>
-              <a:t>about_Functions_CmdletBindingAttribute and ShouldProcess: https://learn.microsoft.com/en-us/powershell/module/microsoft.powershell.core/about/about_functions_cmdletbindingattribute</a:t>
+              <a:t>UAC off: EnableLUA = 0. Defender: Uninstall-WindowsFeature -Name Windows-Defender. Long paths: LongPathsEnabled = 1. All of these are options in the unattend generator. Commands are on the companion site.</a:t>
             </a:r>
           </a:p>
         </p:txBody>
@@ -3425,7 +3426,7 @@
           <a:p>
             <a:fld id="{18BDFEC3-8487-43E8-A154-7C12CBC1FFF2}" type="slidenum">
               <a:rPr lang="en-US"/>
-              <a:t>47</a:t>
+              <a:t>54</a:t>
             </a:fld>
             <a:endParaRPr lang="en-US"/>
           </a:p>
@@ -3485,21 +3486,7 @@
             </a:pPr>
             <a:r>
               <a:rPr/>
-              <a:t>xkcd 936, “Password Strength,” by Randall Munroe: https://xkcd.com/936/ (CC BY-NC 2.5).</a:t>
-            </a:r>
-          </a:p>
-          <a:p>
-            <a:pPr lvl="0" indent="0" marL="0">
-              <a:buNone/>
-            </a:pPr>
-          </a:p>
-          <a:p>
-            <a:pPr lvl="0" indent="0" marL="0">
-              <a:buNone/>
-            </a:pPr>
-            <a:r>
-              <a:rPr/>
-              <a:t>Review note (outline section 5): the explanation holds when the words are randomly selected rather than chosen by a person; the comic’s guess rates are historical, not a present-day benchmark.</a:t>
+              <a:t>Claude Shannon, as recounted in M. Tribus and E. C. McIrvine, “Energy and Information,” Scientific American 225(3), 1971.</a:t>
             </a:r>
           </a:p>
         </p:txBody>
@@ -3521,7 +3508,7 @@
           <a:p>
             <a:fld id="{18BDFEC3-8487-43E8-A154-7C12CBC1FFF2}" type="slidenum">
               <a:rPr lang="en-US"/>
-              <a:t>6</a:t>
+              <a:t>7</a:t>
             </a:fld>
             <a:endParaRPr lang="en-US"/>
           </a:p>
@@ -3581,7 +3568,7 @@
             </a:pPr>
             <a:r>
               <a:rPr/>
-              <a:t>[David’s notes to add.]</a:t>
+              <a:t>The full line on the companion site also installs 7-Zip, Sysinternals and PowerShell 7. KAPE, FTK Imager, Chainsaw and Hayabusa are direct downloads; Chocolatey’s “chainsaw” package is a different program. Plaso runs on Windows through Docker. KAPE and the community KapeFiles repository: https://github.com/EricZimmerman/KapeFiles Kroll’s KAPE terms distinguish free and enterprise use: https://www.kroll.com/en/kape-license-agreement</a:t>
             </a:r>
           </a:p>
         </p:txBody>
@@ -3603,7 +3590,7 @@
           <a:p>
             <a:fld id="{18BDFEC3-8487-43E8-A154-7C12CBC1FFF2}" type="slidenum">
               <a:rPr lang="en-US"/>
-              <a:t>50</a:t>
+              <a:t>55</a:t>
             </a:fld>
             <a:endParaRPr lang="en-US"/>
           </a:p>
@@ -3663,7 +3650,7 @@
             </a:pPr>
             <a:r>
               <a:rPr/>
-              <a:t>Proposed split. The reset method (snapshot, differencing disk or other) is an open implementation decision recorded in README.md.</a:t>
+              <a:t>Read from the read-only Evidence share, write to Cases. Before power-off, confirm the output is on the Cases share; after power-on, confirm the system disk is clean.</a:t>
             </a:r>
           </a:p>
         </p:txBody>
@@ -3685,431 +3672,7 @@
           <a:p>
             <a:fld id="{18BDFEC3-8487-43E8-A154-7C12CBC1FFF2}" type="slidenum">
               <a:rPr lang="en-US"/>
-              <a:t>51</a:t>
-            </a:fld>
-            <a:endParaRPr lang="en-US"/>
-          </a:p>
-        </p:txBody>
-      </p:sp>
-    </p:spTree>
-  </p:cSld>
-</p:notes>
-</file>
-
-<file path=ppt/notesSlides/notesSlide42.xml><?xml version="1.0" encoding="utf-8"?>
-<p:notes xmlns:a="http://schemas.openxmlformats.org/drawingml/2006/main" xmlns:r="http://schemas.openxmlformats.org/officeDocument/2006/relationships" xmlns:p="http://schemas.openxmlformats.org/presentationml/2006/main">
-  <p:cSld>
-    <p:spTree>
-      <p:nvGrpSpPr>
-        <p:cNvPr id="1" name=""/>
-        <p:cNvGrpSpPr/>
-        <p:nvPr/>
-      </p:nvGrpSpPr>
-      <p:grpSpPr>
-        <a:xfrm>
-          <a:off x="0" y="0"/>
-          <a:ext cx="0" cy="0"/>
-          <a:chOff x="0" y="0"/>
-          <a:chExt cx="0" cy="0"/>
-        </a:xfrm>
-      </p:grpSpPr>
-      <p:sp>
-        <p:nvSpPr>
-          <p:cNvPr id="2" name="Slide Image Placeholder 1"/>
-          <p:cNvSpPr>
-            <a:spLocks noGrp="1" noRot="1" noChangeAspect="1"/>
-          </p:cNvSpPr>
-          <p:nvPr>
-            <p:ph type="sldImg"/>
-          </p:nvPr>
-        </p:nvSpPr>
-        <p:spPr/>
-      </p:sp>
-      <p:sp>
-        <p:nvSpPr>
-          <p:cNvPr id="3" name="Notes Placeholder 2"/>
-          <p:cNvSpPr>
-            <a:spLocks noGrp="1"/>
-          </p:cNvSpPr>
-          <p:nvPr>
-            <p:ph type="body" idx="1"/>
-          </p:nvPr>
-        </p:nvSpPr>
-        <p:spPr/>
-        <p:txBody>
-          <a:bodyPr/>
-          <a:lstStyle/>
-          <a:p>
-            <a:pPr lvl="0" indent="0" marL="0">
-              <a:buNone/>
-            </a:pPr>
-            <a:r>
-              <a:rPr/>
-              <a:t>The companion site has an example build script and tool manifest. The manifest entries are placeholders until the tool list is selected.</a:t>
-            </a:r>
-          </a:p>
-        </p:txBody>
-      </p:sp>
-      <p:sp>
-        <p:nvSpPr>
-          <p:cNvPr id="4" name="Slide Number Placeholder 3"/>
-          <p:cNvSpPr>
-            <a:spLocks noGrp="1"/>
-          </p:cNvSpPr>
-          <p:nvPr>
-            <p:ph type="sldNum" sz="quarter" idx="10"/>
-          </p:nvPr>
-        </p:nvSpPr>
-        <p:spPr/>
-        <p:txBody>
-          <a:bodyPr/>
-          <a:lstStyle/>
-          <a:p>
-            <a:fld id="{18BDFEC3-8487-43E8-A154-7C12CBC1FFF2}" type="slidenum">
-              <a:rPr lang="en-US"/>
-              <a:t>52</a:t>
-            </a:fld>
-            <a:endParaRPr lang="en-US"/>
-          </a:p>
-        </p:txBody>
-      </p:sp>
-    </p:spTree>
-  </p:cSld>
-</p:notes>
-</file>
-
-<file path=ppt/notesSlides/notesSlide43.xml><?xml version="1.0" encoding="utf-8"?>
-<p:notes xmlns:a="http://schemas.openxmlformats.org/drawingml/2006/main" xmlns:r="http://schemas.openxmlformats.org/officeDocument/2006/relationships" xmlns:p="http://schemas.openxmlformats.org/presentationml/2006/main">
-  <p:cSld>
-    <p:spTree>
-      <p:nvGrpSpPr>
-        <p:cNvPr id="1" name=""/>
-        <p:cNvGrpSpPr/>
-        <p:nvPr/>
-      </p:nvGrpSpPr>
-      <p:grpSpPr>
-        <a:xfrm>
-          <a:off x="0" y="0"/>
-          <a:ext cx="0" cy="0"/>
-          <a:chOff x="0" y="0"/>
-          <a:chExt cx="0" cy="0"/>
-        </a:xfrm>
-      </p:grpSpPr>
-      <p:sp>
-        <p:nvSpPr>
-          <p:cNvPr id="2" name="Slide Image Placeholder 1"/>
-          <p:cNvSpPr>
-            <a:spLocks noGrp="1" noRot="1" noChangeAspect="1"/>
-          </p:cNvSpPr>
-          <p:nvPr>
-            <p:ph type="sldImg"/>
-          </p:nvPr>
-        </p:nvSpPr>
-        <p:spPr/>
-      </p:sp>
-      <p:sp>
-        <p:nvSpPr>
-          <p:cNvPr id="3" name="Notes Placeholder 2"/>
-          <p:cNvSpPr>
-            <a:spLocks noGrp="1"/>
-          </p:cNvSpPr>
-          <p:nvPr>
-            <p:ph type="body" idx="1"/>
-          </p:nvPr>
-        </p:nvSpPr>
-        <p:spPr/>
-        <p:txBody>
-          <a:bodyPr/>
-          <a:lstStyle/>
-          <a:p>
-            <a:pPr lvl="0" indent="0" marL="0">
-              <a:buNone/>
-            </a:pPr>
-            <a:r>
-              <a:rPr/>
-              <a:t>Defender and networking are listed as open decisions in outline.md section 5.2.</a:t>
-            </a:r>
-          </a:p>
-        </p:txBody>
-      </p:sp>
-      <p:sp>
-        <p:nvSpPr>
-          <p:cNvPr id="4" name="Slide Number Placeholder 3"/>
-          <p:cNvSpPr>
-            <a:spLocks noGrp="1"/>
-          </p:cNvSpPr>
-          <p:nvPr>
-            <p:ph type="sldNum" sz="quarter" idx="10"/>
-          </p:nvPr>
-        </p:nvSpPr>
-        <p:spPr/>
-        <p:txBody>
-          <a:bodyPr/>
-          <a:lstStyle/>
-          <a:p>
-            <a:fld id="{18BDFEC3-8487-43E8-A154-7C12CBC1FFF2}" type="slidenum">
-              <a:rPr lang="en-US"/>
-              <a:t>53</a:t>
-            </a:fld>
-            <a:endParaRPr lang="en-US"/>
-          </a:p>
-        </p:txBody>
-      </p:sp>
-    </p:spTree>
-  </p:cSld>
-</p:notes>
-</file>
-
-<file path=ppt/notesSlides/notesSlide44.xml><?xml version="1.0" encoding="utf-8"?>
-<p:notes xmlns:a="http://schemas.openxmlformats.org/drawingml/2006/main" xmlns:r="http://schemas.openxmlformats.org/officeDocument/2006/relationships" xmlns:p="http://schemas.openxmlformats.org/presentationml/2006/main">
-  <p:cSld>
-    <p:spTree>
-      <p:nvGrpSpPr>
-        <p:cNvPr id="1" name=""/>
-        <p:cNvGrpSpPr/>
-        <p:nvPr/>
-      </p:nvGrpSpPr>
-      <p:grpSpPr>
-        <a:xfrm>
-          <a:off x="0" y="0"/>
-          <a:ext cx="0" cy="0"/>
-          <a:chOff x="0" y="0"/>
-          <a:chExt cx="0" cy="0"/>
-        </a:xfrm>
-      </p:grpSpPr>
-      <p:sp>
-        <p:nvSpPr>
-          <p:cNvPr id="2" name="Slide Image Placeholder 1"/>
-          <p:cNvSpPr>
-            <a:spLocks noGrp="1" noRot="1" noChangeAspect="1"/>
-          </p:cNvSpPr>
-          <p:nvPr>
-            <p:ph type="sldImg"/>
-          </p:nvPr>
-        </p:nvSpPr>
-        <p:spPr/>
-      </p:sp>
-      <p:sp>
-        <p:nvSpPr>
-          <p:cNvPr id="3" name="Notes Placeholder 2"/>
-          <p:cNvSpPr>
-            <a:spLocks noGrp="1"/>
-          </p:cNvSpPr>
-          <p:nvPr>
-            <p:ph type="body" idx="1"/>
-          </p:nvPr>
-        </p:nvSpPr>
-        <p:spPr/>
-        <p:txBody>
-          <a:bodyPr/>
-          <a:lstStyle/>
-          <a:p>
-            <a:pPr lvl="0" indent="0" marL="0">
-              <a:buNone/>
-            </a:pPr>
-            <a:r>
-              <a:rPr/>
-              <a:t>Outline: “confirm intended tool name”. KAPE and the community KapeFiles repository: https://github.com/EricZimmerman/KapeFiles</a:t>
-            </a:r>
-          </a:p>
-          <a:p>
-            <a:pPr lvl="0" indent="0" marL="0">
-              <a:buNone/>
-            </a:pPr>
-          </a:p>
-          <a:p>
-            <a:pPr lvl="0" indent="0" marL="0">
-              <a:buNone/>
-            </a:pPr>
-            <a:r>
-              <a:rPr/>
-              <a:t>Licensing: Kroll’s KAPE terms distinguish free and enterprise use; confirm which applies to CRT engagements before selection: https://www.kroll.com/en/kape-license-agreement</a:t>
-            </a:r>
-          </a:p>
-        </p:txBody>
-      </p:sp>
-      <p:sp>
-        <p:nvSpPr>
-          <p:cNvPr id="4" name="Slide Number Placeholder 3"/>
-          <p:cNvSpPr>
-            <a:spLocks noGrp="1"/>
-          </p:cNvSpPr>
-          <p:nvPr>
-            <p:ph type="sldNum" sz="quarter" idx="10"/>
-          </p:nvPr>
-        </p:nvSpPr>
-        <p:spPr/>
-        <p:txBody>
-          <a:bodyPr/>
-          <a:lstStyle/>
-          <a:p>
-            <a:fld id="{18BDFEC3-8487-43E8-A154-7C12CBC1FFF2}" type="slidenum">
-              <a:rPr lang="en-US"/>
-              <a:t>54</a:t>
-            </a:fld>
-            <a:endParaRPr lang="en-US"/>
-          </a:p>
-        </p:txBody>
-      </p:sp>
-    </p:spTree>
-  </p:cSld>
-</p:notes>
-</file>
-
-<file path=ppt/notesSlides/notesSlide45.xml><?xml version="1.0" encoding="utf-8"?>
-<p:notes xmlns:a="http://schemas.openxmlformats.org/drawingml/2006/main" xmlns:r="http://schemas.openxmlformats.org/officeDocument/2006/relationships" xmlns:p="http://schemas.openxmlformats.org/presentationml/2006/main">
-  <p:cSld>
-    <p:spTree>
-      <p:nvGrpSpPr>
-        <p:cNvPr id="1" name=""/>
-        <p:cNvGrpSpPr/>
-        <p:nvPr/>
-      </p:nvGrpSpPr>
-      <p:grpSpPr>
-        <a:xfrm>
-          <a:off x="0" y="0"/>
-          <a:ext cx="0" cy="0"/>
-          <a:chOff x="0" y="0"/>
-          <a:chExt cx="0" cy="0"/>
-        </a:xfrm>
-      </p:grpSpPr>
-      <p:sp>
-        <p:nvSpPr>
-          <p:cNvPr id="2" name="Slide Image Placeholder 1"/>
-          <p:cNvSpPr>
-            <a:spLocks noGrp="1" noRot="1" noChangeAspect="1"/>
-          </p:cNvSpPr>
-          <p:nvPr>
-            <p:ph type="sldImg"/>
-          </p:nvPr>
-        </p:nvSpPr>
-        <p:spPr/>
-      </p:sp>
-      <p:sp>
-        <p:nvSpPr>
-          <p:cNvPr id="3" name="Notes Placeholder 2"/>
-          <p:cNvSpPr>
-            <a:spLocks noGrp="1"/>
-          </p:cNvSpPr>
-          <p:nvPr>
-            <p:ph type="body" idx="1"/>
-          </p:nvPr>
-        </p:nvSpPr>
-        <p:spPr/>
-        <p:txBody>
-          <a:bodyPr/>
-          <a:lstStyle/>
-          <a:p>
-            <a:pPr lvl="0" indent="0" marL="0">
-              <a:buNone/>
-            </a:pPr>
-            <a:r>
-              <a:rPr/>
-              <a:t>Companion site: checks to confirm output is retained before reset.</a:t>
-            </a:r>
-          </a:p>
-        </p:txBody>
-      </p:sp>
-      <p:sp>
-        <p:nvSpPr>
-          <p:cNvPr id="4" name="Slide Number Placeholder 3"/>
-          <p:cNvSpPr>
-            <a:spLocks noGrp="1"/>
-          </p:cNvSpPr>
-          <p:nvPr>
-            <p:ph type="sldNum" sz="quarter" idx="10"/>
-          </p:nvPr>
-        </p:nvSpPr>
-        <p:spPr/>
-        <p:txBody>
-          <a:bodyPr/>
-          <a:lstStyle/>
-          <a:p>
-            <a:fld id="{18BDFEC3-8487-43E8-A154-7C12CBC1FFF2}" type="slidenum">
-              <a:rPr lang="en-US"/>
-              <a:t>55</a:t>
-            </a:fld>
-            <a:endParaRPr lang="en-US"/>
-          </a:p>
-        </p:txBody>
-      </p:sp>
-    </p:spTree>
-  </p:cSld>
-</p:notes>
-</file>
-
-<file path=ppt/notesSlides/notesSlide46.xml><?xml version="1.0" encoding="utf-8"?>
-<p:notes xmlns:a="http://schemas.openxmlformats.org/drawingml/2006/main" xmlns:r="http://schemas.openxmlformats.org/officeDocument/2006/relationships" xmlns:p="http://schemas.openxmlformats.org/presentationml/2006/main">
-  <p:cSld>
-    <p:spTree>
-      <p:nvGrpSpPr>
-        <p:cNvPr id="1" name=""/>
-        <p:cNvGrpSpPr/>
-        <p:nvPr/>
-      </p:nvGrpSpPr>
-      <p:grpSpPr>
-        <a:xfrm>
-          <a:off x="0" y="0"/>
-          <a:ext cx="0" cy="0"/>
-          <a:chOff x="0" y="0"/>
-          <a:chExt cx="0" cy="0"/>
-        </a:xfrm>
-      </p:grpSpPr>
-      <p:sp>
-        <p:nvSpPr>
-          <p:cNvPr id="2" name="Slide Image Placeholder 1"/>
-          <p:cNvSpPr>
-            <a:spLocks noGrp="1" noRot="1" noChangeAspect="1"/>
-          </p:cNvSpPr>
-          <p:nvPr>
-            <p:ph type="sldImg"/>
-          </p:nvPr>
-        </p:nvSpPr>
-        <p:spPr/>
-      </p:sp>
-      <p:sp>
-        <p:nvSpPr>
-          <p:cNvPr id="3" name="Notes Placeholder 2"/>
-          <p:cNvSpPr>
-            <a:spLocks noGrp="1"/>
-          </p:cNvSpPr>
-          <p:nvPr>
-            <p:ph type="body" idx="1"/>
-          </p:nvPr>
-        </p:nvSpPr>
-        <p:spPr/>
-        <p:txBody>
-          <a:bodyPr/>
-          <a:lstStyle/>
-          <a:p>
-            <a:pPr lvl="0" indent="0" marL="0">
-              <a:buNone/>
-            </a:pPr>
-            <a:r>
-              <a:rPr/>
-              <a:t>Proposed wording, summarizing each section’s takeaways.</a:t>
-            </a:r>
-          </a:p>
-        </p:txBody>
-      </p:sp>
-      <p:sp>
-        <p:nvSpPr>
-          <p:cNvPr id="4" name="Slide Number Placeholder 3"/>
-          <p:cNvSpPr>
-            <a:spLocks noGrp="1"/>
-          </p:cNvSpPr>
-          <p:nvPr>
-            <p:ph type="sldNum" sz="quarter" idx="10"/>
-          </p:nvPr>
-        </p:nvSpPr>
-        <p:spPr/>
-        <p:txBody>
-          <a:bodyPr/>
-          <a:lstStyle/>
-          <a:p>
-            <a:fld id="{18BDFEC3-8487-43E8-A154-7C12CBC1FFF2}" type="slidenum">
-              <a:rPr lang="en-US"/>
-              <a:t>58</a:t>
+              <a:t>56</a:t>
             </a:fld>
             <a:endParaRPr lang="en-US"/>
           </a:p>
@@ -4169,7 +3732,59 @@
             </a:pPr>
             <a:r>
               <a:rPr/>
-              <a:t>Claude Shannon, as recounted in M. Tribus and E. C. McIrvine, “Energy and Information,” Scientific American 225(3), 1971.</a:t>
+              <a:t>The alphabet/length formula assumes each character, or word, is chosen uniformly at random from the alphabet. Human-chosen passwords do not meet that assumption.</a:t>
+            </a:r>
+          </a:p>
+          <a:p>
+            <a:pPr lvl="0" indent="0" marL="0">
+              <a:buNone/>
+            </a:pPr>
+          </a:p>
+          <a:p>
+            <a:pPr lvl="0" indent="0" marL="0">
+              <a:buNone/>
+            </a:pPr>
+            <a:r>
+              <a:rPr/>
+              <a:t>Bits = log</a:t>
+            </a:r>
+            <a:r>
+              <a:rPr baseline="-25000"/>
+              <a:t>2</a:t>
+            </a:r>
+            <a:r>
+              <a:rPr/>
+              <a:t>(alphabet</a:t>
+            </a:r>
+            <a:r>
+              <a:rPr baseline="30000"/>
+              <a:t>length</a:t>
+            </a:r>
+            <a:r>
+              <a:rPr/>
+              <a:t>) = length × log</a:t>
+            </a:r>
+            <a:r>
+              <a:rPr baseline="-25000"/>
+              <a:t>2</a:t>
+            </a:r>
+            <a:r>
+              <a:rPr/>
+              <a:t>(alphabet). xkcd 936 uses 11 bits per word (2,048 words). The EFF large wordlist has 7,776 words (five dice): https://www.eff.org/dice</a:t>
+            </a:r>
+          </a:p>
+          <a:p>
+            <a:pPr lvl="0" indent="0" marL="0">
+              <a:buNone/>
+            </a:pPr>
+          </a:p>
+          <a:p>
+            <a:pPr lvl="0" indent="0" marL="0">
+              <a:buNone/>
+            </a:pPr>
+            <a:r>
+              <a:rPr/>
+              <a:t>Get-PasswordEntropy and Get-PasswordLength on the companion site calculate these.</a:t>
             </a:r>
           </a:p>
         </p:txBody>
@@ -4191,7 +3806,7 @@
           <a:p>
             <a:fld id="{18BDFEC3-8487-43E8-A154-7C12CBC1FFF2}" type="slidenum">
               <a:rPr lang="en-US"/>
-              <a:t>7</a:t>
+              <a:t>8</a:t>
             </a:fld>
             <a:endParaRPr lang="en-US"/>
           </a:p>
@@ -4251,7 +3866,7 @@
             </a:pPr>
             <a:r>
               <a:rPr/>
-              <a:t>Review note (outline section 5): the pool/length formula assumes each character, or word, is chosen uniformly at random from the alphabet. Human-chosen passwords do not meet that assumption.</a:t>
+              <a:t>Switch to the companion site for the entropy calculation: dzampino.github.io/crt-essentials-2026/passwords.html</a:t>
             </a:r>
           </a:p>
           <a:p>
@@ -4265,7 +3880,15 @@
             </a:pPr>
             <a:r>
               <a:rPr/>
-              <a:t>Table values computed as log2(alphabet^length). xkcd 936 uses 11 bits per word (2,048 words). The EFF large wordlist has 7,776 words (five dice): https://www.eff.org/dice</a:t>
+              <a:t>Adding a character multiplies the search space by the alphabet size (adds log</a:t>
+            </a:r>
+            <a:r>
+              <a:rPr baseline="-25000"/>
+              <a:t>2</a:t>
+            </a:r>
+            <a:r>
+              <a:rPr/>
+              <a:t>(alphabet) bits); doubling the alphabet adds only one bit per character. On average an attacker finds the secret after searching half the space, which is one bit less.</a:t>
             </a:r>
           </a:p>
         </p:txBody>
@@ -4287,7 +3910,7 @@
           <a:p>
             <a:fld id="{18BDFEC3-8487-43E8-A154-7C12CBC1FFF2}" type="slidenum">
               <a:rPr lang="en-US"/>
-              <a:t>8</a:t>
+              <a:t>9</a:t>
             </a:fld>
             <a:endParaRPr lang="en-US"/>
           </a:p>
@@ -4347,7 +3970,15 @@
             </a:pPr>
             <a:r>
               <a:rPr/>
-              <a:t>SWAP TO SITE for the entropy calculation: dzampino.github.io/crt-essentials-2026/passwords.html</a:t>
+              <a:t>Rates: hashcat v6.2.6 benchmark, RTX 5090 Founders Edition, Chick3nman, February 2025: https://gist.github.com/Chick3nman/09bac0775e6393468c2925c1e1363d5c Average time = (95</a:t>
+            </a:r>
+            <a:r>
+              <a:rPr baseline="30000"/>
+              <a:t>8</a:t>
+            </a:r>
+            <a:r>
+              <a:rPr/>
+              <a:t> / 2) / rate, a full brute force with no wordlist. Real attacks start with wordlists and rules, so human-chosen passwords fall much faster.</a:t>
             </a:r>
           </a:p>
           <a:p>
@@ -4361,7 +3992,35 @@
             </a:pPr>
             <a:r>
               <a:rPr/>
-              <a:t>Points to show: adding a character multiplies the search space by the alphabet size (adds log2(alphabet) bits); doubling the alphabet adds only one bit per character. On average an attacker finds the secret after searching half the space, which is one bit less.</a:t>
+              <a:t>Each RTX 5090 draws up to 575 W, all of which becomes heat: about 1,960 BTU/h, or 0.16 tons of cooling per card. The companion site works out power and cooling for each threat level.</a:t>
+            </a:r>
+          </a:p>
+          <a:p>
+            <a:pPr lvl="0" indent="0" marL="0">
+              <a:buNone/>
+            </a:pPr>
+          </a:p>
+          <a:p>
+            <a:pPr lvl="0" indent="0" marL="0">
+              <a:buNone/>
+            </a:pPr>
+            <a:r>
+              <a:rPr/>
+              <a:t>A stored Windows NT hash and an NTLM protocol exchange (NetNTLMv2, 16.0 G/s on the same card) are different things.</a:t>
+            </a:r>
+          </a:p>
+          <a:p>
+            <a:pPr lvl="0" indent="0" marL="0">
+              <a:buNone/>
+            </a:pPr>
+          </a:p>
+          <a:p>
+            <a:pPr lvl="0" indent="0" marL="0">
+              <a:buNone/>
+            </a:pPr>
+            <a:r>
+              <a:rPr/>
+              <a:t>OWASP Password Storage Cheat Sheet: https://cheatsheetseries.owasp.org/cheatsheets/Password_Storage_Cheat_Sheet.html Microsoft, Passwords technical overview: https://learn.microsoft.com/en-us/windows-server/security/kerberos/passwords-technical-overview</a:t>
             </a:r>
           </a:p>
         </p:txBody>
@@ -4383,7 +4042,7 @@
           <a:p>
             <a:fld id="{18BDFEC3-8487-43E8-A154-7C12CBC1FFF2}" type="slidenum">
               <a:rPr lang="en-US"/>
-              <a:t>9</a:t>
+              <a:t>10</a:t>
             </a:fld>
             <a:endParaRPr lang="en-US"/>
           </a:p>
@@ -4443,49 +4102,7 @@
             </a:pPr>
             <a:r>
               <a:rPr/>
-              <a:t>Companion site: hashing algorithms, threat levels, time and cost to crack.</a:t>
-            </a:r>
-          </a:p>
-          <a:p>
-            <a:pPr lvl="0" indent="0" marL="0">
-              <a:buNone/>
-            </a:pPr>
-          </a:p>
-          <a:p>
-            <a:pPr lvl="0" indent="0" marL="0">
-              <a:buNone/>
-            </a:pPr>
-            <a:r>
-              <a:rPr/>
-              <a:t>Rates: hashcat v6.2.6 benchmark, RTX 5090 Founders Edition, Chick3nman, February 2025: https://gist.github.com/Chick3nman/09bac0775e6393468c2925c1e1363d5c Average time = (95^8 / 2) / rate, a full brute force with no wordlist. Real attacks start with wordlists and rules, so human-chosen passwords fall much faster.</a:t>
-            </a:r>
-          </a:p>
-          <a:p>
-            <a:pPr lvl="0" indent="0" marL="0">
-              <a:buNone/>
-            </a:pPr>
-          </a:p>
-          <a:p>
-            <a:pPr lvl="0" indent="0" marL="0">
-              <a:buNone/>
-            </a:pPr>
-            <a:r>
-              <a:rPr/>
-              <a:t>Review note (outline section 5): a stored Windows NT hash and an NTLM protocol exchange (NetNTLMv2, 16.0 G/s on the same card) are different comparison subjects.</a:t>
-            </a:r>
-          </a:p>
-          <a:p>
-            <a:pPr lvl="0" indent="0" marL="0">
-              <a:buNone/>
-            </a:pPr>
-          </a:p>
-          <a:p>
-            <a:pPr lvl="0" indent="0" marL="0">
-              <a:buNone/>
-            </a:pPr>
-            <a:r>
-              <a:rPr/>
-              <a:t>OWASP Password Storage Cheat Sheet: https://cheatsheetseries.owasp.org/cheatsheets/Password_Storage_Cheat_Sheet.html Microsoft, Passwords technical overview: https://learn.microsoft.com/en-us/windows-server/security/kerberos/passwords-technical-overview</a:t>
+              <a:t>NIST SP 800-63B-4 section 3.2.2: rate limiting SHALL limit consecutive failed attempts on an account to no more than 100. Section 3.1.1.2: passwords SHALL be salted (at least 32 bits) and hashed with a suitable password hashing scheme; the cost factor SHOULD be as high as practical. https://pages.nist.gov/800-63-4/sp800-63b.html</a:t>
             </a:r>
           </a:p>
         </p:txBody>
@@ -4507,7 +4124,7 @@
           <a:p>
             <a:fld id="{18BDFEC3-8487-43E8-A154-7C12CBC1FFF2}" type="slidenum">
               <a:rPr lang="en-US"/>
-              <a:t>10</a:t>
+              <a:t>11</a:t>
             </a:fld>
             <a:endParaRPr lang="en-US"/>
           </a:p>
@@ -4567,21 +4184,7 @@
             </a:pPr>
             <a:r>
               <a:rPr/>
-              <a:t>[David’s notes to add.]</a:t>
-            </a:r>
-          </a:p>
-          <a:p>
-            <a:pPr lvl="0" indent="0" marL="0">
-              <a:buNone/>
-            </a:pPr>
-          </a:p>
-          <a:p>
-            <a:pPr lvl="0" indent="0" marL="0">
-              <a:buNone/>
-            </a:pPr>
-            <a:r>
-              <a:rPr/>
-              <a:t>NIST SP 800-63B-4 section 3.2.2: rate limiting SHALL limit consecutive failed attempts on an account to no more than 100. Section 3.1.1.2: passwords SHALL be salted (at least 32 bits) and hashed with a suitable password hashing scheme; the cost factor SHOULD be as high as practical. https://pages.nist.gov/800-63-4/sp800-63b.html</a:t>
+              <a:t>NIST SP 800-63B-4 section 3.1.1.2: minimum 15 characters when a password is used as a single-factor authenticator, 8 when used only as part of MFA; support at least 64 characters; compare against a blocklist; SHALL NOT impose other composition rules; SHALL NOT require periodic changes, but force a change on evidence of compromise. https://pages.nist.gov/800-63-4/sp800-63b.html Have I Been Pwned, Pwned Passwords: https://haveibeenpwned.com/Passwords</a:t>
             </a:r>
           </a:p>
         </p:txBody>
@@ -4603,7 +4206,7 @@
           <a:p>
             <a:fld id="{18BDFEC3-8487-43E8-A154-7C12CBC1FFF2}" type="slidenum">
               <a:rPr lang="en-US"/>
-              <a:t>11</a:t>
+              <a:t>12</a:t>
             </a:fld>
             <a:endParaRPr lang="en-US"/>
           </a:p>
@@ -9076,13 +8679,13 @@
               <a:rPr>
                 <a:latin typeface="Consolas"/>
               </a:rPr>
-              <a:t>Serial Number: 05:6d:6d:da:99:ef:6a:99:e4:fe:...:0a:94
-Issuer:  CN=CRT Fictional Training Root
+              <a:t>Serial Number: 3e:23:6d:a6:5a:1d:83:f6:...:8e:0c
+Issuer:  O=Fictional Cheese Curd Authority, CN=Squeaky Curd Root CA
 Not Before: Oct  1 00:00:00 2026 GMT
 Not After : Oct  1 00:00:00 2027 GMT
-Subject: CN=training.example
+Subject: L=Curdsville, O=Squeaky Curds Co-op, CN=squeakycurds.example
 Basic Constraints: critical, CA:FALSE
-Subject Alternative Name: DNS:training.example
+Subject Alternative Name: DNS:squeakycurds.example
 Extended Key Usage: TLS Web Server Authentication</a:t>
             </a:r>
           </a:p>
@@ -9849,300 +9452,78 @@
             </a:pPr>
             <a:r>
               <a:rPr/>
-              <a:t>Agenda</a:t>
-            </a:r>
-          </a:p>
-        </p:txBody>
-      </p:sp>
-      <p:graphicFrame>
-        <p:nvGraphicFramePr>
-          <p:cNvPr id="6" name="Content Placeholder 5"/>
-          <p:cNvGraphicFramePr>
-            <a:graphicFrameLocks noGrp="1"/>
-          </p:cNvGraphicFramePr>
-          <p:nvPr>
-            <p:ph idx="1"/>
-          </p:nvPr>
-        </p:nvGraphicFramePr>
-        <p:xfrm>
-          <a:off x="546100" y="1435100"/>
-          <a:ext cx="11087100" cy="4597400"/>
-        </p:xfrm>
-        <a:graphic>
-          <a:graphicData uri="http://schemas.openxmlformats.org/drawingml/2006/table">
-            <a:tbl>
-              <a:tblPr firstRow="1" bandRow="1">
-                <a:tableStyleId>{5C22544A-7EE6-4342-B048-85BDC9FD1C3A}</a:tableStyleId>
-              </a:tblPr>
-              <a:tblGrid>
-                <a:gridCol w="5537200"/>
-                <a:gridCol w="5537200"/>
-              </a:tblGrid>
-              <a:tr h="0">
-                <a:tc>
-                  <a:txBody>
-                    <a:bodyPr/>
-                    <a:lstStyle/>
-                    <a:p>
-                      <a:pPr lvl="0" indent="0" marL="0">
-                        <a:buNone/>
-                      </a:pPr>
-                      <a:r>
-                        <a:rPr/>
-                        <a:t>Segment</a:t>
-                      </a:r>
-                    </a:p>
-                  </a:txBody>
-                  <a:tcPr/>
-                </a:tc>
-                <a:tc>
-                  <a:txBody>
-                    <a:bodyPr/>
-                    <a:lstStyle/>
-                    <a:p>
-                      <a:pPr lvl="0" indent="0" marL="0" algn="r">
-                        <a:buNone/>
-                      </a:pPr>
-                      <a:r>
-                        <a:rPr/>
-                        <a:t>Minutes</a:t>
-                      </a:r>
-                    </a:p>
-                  </a:txBody>
-                  <a:tcPr/>
-                </a:tc>
-              </a:tr>
-              <a:tr h="0">
-                <a:tc>
-                  <a:txBody>
-                    <a:bodyPr/>
-                    <a:lstStyle/>
-                    <a:p>
-                      <a:pPr lvl="0" indent="0" marL="0">
-                        <a:buNone/>
-                      </a:pPr>
-                      <a:r>
-                        <a:rPr/>
-                        <a:t>Introduction and purpose</a:t>
-                      </a:r>
-                    </a:p>
-                  </a:txBody>
-                </a:tc>
-                <a:tc>
-                  <a:txBody>
-                    <a:bodyPr/>
-                    <a:lstStyle/>
-                    <a:p>
-                      <a:pPr lvl="0" indent="0" marL="0" algn="r">
-                        <a:buNone/>
-                      </a:pPr>
-                      <a:r>
-                        <a:rPr/>
-                        <a:t>5</a:t>
-                      </a:r>
-                    </a:p>
-                  </a:txBody>
-                </a:tc>
-              </a:tr>
-              <a:tr h="0">
-                <a:tc>
-                  <a:txBody>
-                    <a:bodyPr/>
-                    <a:lstStyle/>
-                    <a:p>
-                      <a:pPr lvl="0" indent="0" marL="0">
-                        <a:buNone/>
-                      </a:pPr>
-                      <a:r>
-                        <a:rPr/>
-                        <a:t>Passwords</a:t>
-                      </a:r>
-                    </a:p>
-                  </a:txBody>
-                </a:tc>
-                <a:tc>
-                  <a:txBody>
-                    <a:bodyPr/>
-                    <a:lstStyle/>
-                    <a:p>
-                      <a:pPr lvl="0" indent="0" marL="0" algn="r">
-                        <a:buNone/>
-                      </a:pPr>
-                      <a:r>
-                        <a:rPr/>
-                        <a:t>20</a:t>
-                      </a:r>
-                    </a:p>
-                  </a:txBody>
-                </a:tc>
-              </a:tr>
-              <a:tr h="0">
-                <a:tc>
-                  <a:txBody>
-                    <a:bodyPr/>
-                    <a:lstStyle/>
-                    <a:p>
-                      <a:pPr lvl="0" indent="0" marL="0">
-                        <a:buNone/>
-                      </a:pPr>
-                      <a:r>
-                        <a:rPr/>
-                        <a:t>PKI</a:t>
-                      </a:r>
-                    </a:p>
-                  </a:txBody>
-                </a:tc>
-                <a:tc>
-                  <a:txBody>
-                    <a:bodyPr/>
-                    <a:lstStyle/>
-                    <a:p>
-                      <a:pPr lvl="0" indent="0" marL="0" algn="r">
-                        <a:buNone/>
-                      </a:pPr>
-                      <a:r>
-                        <a:rPr/>
-                        <a:t>25</a:t>
-                      </a:r>
-                    </a:p>
-                  </a:txBody>
-                </a:tc>
-              </a:tr>
-              <a:tr h="0">
-                <a:tc>
-                  <a:txBody>
-                    <a:bodyPr/>
-                    <a:lstStyle/>
-                    <a:p>
-                      <a:pPr lvl="0" indent="0" marL="0">
-                        <a:buNone/>
-                      </a:pPr>
-                      <a:r>
-                        <a:rPr/>
-                        <a:t>Email security</a:t>
-                      </a:r>
-                    </a:p>
-                  </a:txBody>
-                </a:tc>
-                <a:tc>
-                  <a:txBody>
-                    <a:bodyPr/>
-                    <a:lstStyle/>
-                    <a:p>
-                      <a:pPr lvl="0" indent="0" marL="0" algn="r">
-                        <a:buNone/>
-                      </a:pPr>
-                      <a:r>
-                        <a:rPr/>
-                        <a:t>30</a:t>
-                      </a:r>
-                    </a:p>
-                  </a:txBody>
-                </a:tc>
-              </a:tr>
-              <a:tr h="0">
-                <a:tc>
-                  <a:txBody>
-                    <a:bodyPr/>
-                    <a:lstStyle/>
-                    <a:p>
-                      <a:pPr lvl="0" indent="0" marL="0">
-                        <a:buNone/>
-                      </a:pPr>
-                      <a:r>
-                        <a:rPr/>
-                        <a:t>PowerShell</a:t>
-                      </a:r>
-                    </a:p>
-                  </a:txBody>
-                </a:tc>
-                <a:tc>
-                  <a:txBody>
-                    <a:bodyPr/>
-                    <a:lstStyle/>
-                    <a:p>
-                      <a:pPr lvl="0" indent="0" marL="0" algn="r">
-                        <a:buNone/>
-                      </a:pPr>
-                      <a:r>
-                        <a:rPr/>
-                        <a:t>20</a:t>
-                      </a:r>
-                    </a:p>
-                  </a:txBody>
-                </a:tc>
-              </a:tr>
-              <a:tr h="0">
-                <a:tc>
-                  <a:txBody>
-                    <a:bodyPr/>
-                    <a:lstStyle/>
-                    <a:p>
-                      <a:pPr lvl="0" indent="0" marL="0">
-                        <a:buNone/>
-                      </a:pPr>
-                      <a:r>
-                        <a:rPr/>
-                        <a:t>Building a Windows DFIR box</a:t>
-                      </a:r>
-                    </a:p>
-                  </a:txBody>
-                </a:tc>
-                <a:tc>
-                  <a:txBody>
-                    <a:bodyPr/>
-                    <a:lstStyle/>
-                    <a:p>
-                      <a:pPr lvl="0" indent="0" marL="0" algn="r">
-                        <a:buNone/>
-                      </a:pPr>
-                      <a:r>
-                        <a:rPr/>
-                        <a:t>15</a:t>
-                      </a:r>
-                    </a:p>
-                  </a:txBody>
-                </a:tc>
-              </a:tr>
-              <a:tr h="0">
-                <a:tc>
-                  <a:txBody>
-                    <a:bodyPr/>
-                    <a:lstStyle/>
-                    <a:p>
-                      <a:pPr lvl="0" indent="0" marL="0">
-                        <a:buNone/>
-                      </a:pPr>
-                      <a:r>
-                        <a:rPr/>
-                        <a:t>Questions and wrap-up</a:t>
-                      </a:r>
-                    </a:p>
-                  </a:txBody>
-                </a:tc>
-                <a:tc>
-                  <a:txBody>
-                    <a:bodyPr/>
-                    <a:lstStyle/>
-                    <a:p>
-                      <a:pPr lvl="0" indent="0" marL="0" algn="r">
-                        <a:buNone/>
-                      </a:pPr>
-                      <a:r>
-                        <a:rPr/>
-                        <a:t>5</a:t>
-                      </a:r>
-                    </a:p>
-                  </a:txBody>
-                </a:tc>
-              </a:tr>
-            </a:tbl>
-          </a:graphicData>
-        </a:graphic>
-      </p:graphicFrame>
-      <p:sp>
-        <p:nvSpPr>
-          <p:cNvPr id="4" name="Footer Placeholder"/>
+              <a:t>Companion site</a:t>
+            </a:r>
+          </a:p>
+        </p:txBody>
+      </p:sp>
+      <p:sp>
+        <p:nvSpPr>
+          <p:cNvPr id="4" name="Text Placeholder 4"/>
+          <p:cNvSpPr>
+            <a:spLocks noGrp="1"/>
+          </p:cNvSpPr>
+          <p:nvPr>
+            <p:ph idx="2" sz="half" type="body"/>
+          </p:nvPr>
+        </p:nvSpPr>
+        <p:spPr/>
+        <p:txBody>
+          <a:bodyPr/>
+          <a:lstStyle/>
+          <a:p>
+            <a:pPr lvl="0" indent="0" marL="0">
+              <a:buNone/>
+            </a:pPr>
+            <a:r>
+              <a:rPr b="1"/>
+              <a:t>dzampino.github.io/crt-essentials-2026</a:t>
+            </a:r>
+          </a:p>
+          <a:p>
+            <a:pPr lvl="0" indent="0" marL="0">
+              <a:buNone/>
+            </a:pPr>
+            <a:r>
+              <a:rPr/>
+              <a:t>Calculators, sample files, commands, a PowerShell module and references for everything in this session</a:t>
+            </a:r>
+          </a:p>
+        </p:txBody>
+      </p:sp>
+      <p:pic>
+        <p:nvPicPr>
+          <p:cNvPr descr="../assets/site-qr.png" id="0" name="Picture 1"/>
+          <p:cNvPicPr>
+            <a:picLocks noGrp="1" noChangeAspect="1"/>
+          </p:cNvPicPr>
+          <p:nvPr/>
+        </p:nvPicPr>
+        <p:blipFill>
+          <a:blip r:embed="rId3"/>
+          <a:stretch>
+            <a:fillRect/>
+          </a:stretch>
+        </p:blipFill>
+        <p:spPr bwMode="auto">
+          <a:xfrm>
+            <a:off x="5753100" y="1435100"/>
+            <a:ext cx="4597400" cy="4597400"/>
+          </a:xfrm>
+          <a:prstGeom prst="rect">
+            <a:avLst/>
+          </a:prstGeom>
+          <a:noFill/>
+          <a:ln w="9525">
+            <a:noFill/>
+            <a:headEnd/>
+            <a:tailEnd/>
+          </a:ln>
+        </p:spPr>
+      </p:pic>
+      <p:sp>
+        <p:nvSpPr>
+          <p:cNvPr id="5" name="Footer Placeholder"/>
           <p:cNvSpPr>
             <a:spLocks noGrp="1"/>
           </p:cNvSpPr>
@@ -10184,7 +9565,7 @@
       </p:sp>
       <p:sp>
         <p:nvSpPr>
-          <p:cNvPr id="5" name="Slide Number Placeholder"/>
+          <p:cNvPr id="6" name="Slide Number Placeholder"/>
           <p:cNvSpPr>
             <a:spLocks noGrp="1"/>
           </p:cNvSpPr>
@@ -11715,6 +11096,13 @@
               <a:t>SMTP, submission, relay, delivery, and DNS/MX records</a:t>
             </a:r>
           </a:p>
+          <a:p>
+            <a:pPr lvl="0"/>
+            <a:r>
+              <a:rPr/>
+              <a:t>Submission is usually authenticated on 587 or 465, but can be unauthenticated on 25</a:t>
+            </a:r>
+          </a:p>
         </p:txBody>
       </p:sp>
       <p:pic>
@@ -12011,6 +11399,29 @@
             </a:r>
           </a:p>
           <a:p>
+            <a:pPr lvl="1"/>
+            <a:r>
+              <a:rPr/>
+              <a:t>Outlook: “</a:t>
+            </a:r>
+            <a:r>
+              <a:rPr i="1"/>
+              <a:t>Sender</a:t>
+            </a:r>
+            <a:r>
+              <a:rPr/>
+              <a:t> on behalf of </a:t>
+            </a:r>
+            <a:r>
+              <a:rPr i="1"/>
+              <a:t>From</a:t>
+            </a:r>
+            <a:r>
+              <a:rPr/>
+              <a:t>”</a:t>
+            </a:r>
+          </a:p>
+          <a:p>
             <a:pPr lvl="0"/>
             <a:r>
               <a:rPr/>
@@ -12227,6 +11638,13 @@
               <a:t>Only those added by systems you control; everything below can be forged</a:t>
             </a:r>
           </a:p>
+          <a:p>
+            <a:pPr lvl="0"/>
+            <a:r>
+              <a:rPr/>
+              <a:t>Microsoft’s Message Header Analyzer lays it all out</a:t>
+            </a:r>
+          </a:p>
         </p:txBody>
       </p:sp>
       <p:sp>
@@ -12552,7 +11970,7 @@
             </a:pPr>
             <a:r>
               <a:rPr/>
-              <a:t>Why these five topics</a:t>
+              <a:t>Agenda</a:t>
             </a:r>
           </a:p>
         </p:txBody>
@@ -12572,44 +11990,48 @@
           <a:bodyPr/>
           <a:lstStyle/>
           <a:p>
-            <a:pPr lvl="0"/>
-            <a:r>
-              <a:rPr/>
-              <a:t>Practical security knowledge CRT responders should understand and be able to explain</a:t>
-            </a:r>
-          </a:p>
-          <a:p>
-            <a:pPr lvl="0"/>
-            <a:r>
-              <a:rPr/>
-              <a:t>Including the preventative advice that helps organizations avoid the incidents we respond to</a:t>
-            </a:r>
-          </a:p>
-          <a:p>
-            <a:pPr lvl="0"/>
-            <a:r>
-              <a:rPr/>
-              <a:t>No single fictional incident; each topic stands on its own</a:t>
-            </a:r>
-          </a:p>
-          <a:p>
-            <a:pPr lvl="0"/>
-            <a:r>
-              <a:rPr/>
-              <a:t>Slides for today, a field guide for afterward</a:t>
-            </a:r>
-          </a:p>
-          <a:p>
-            <a:pPr lvl="0" indent="0" marL="0">
-              <a:buNone/>
+            <a:pPr lvl="0">
+              <a:buAutoNum type="arabicPeriod"/>
             </a:pPr>
             <a:r>
-              <a:rPr b="1"/>
-              <a:t>Companion site:</a:t>
-            </a:r>
-            <a:r>
-              <a:rPr/>
-              <a:t> dzampino.github.io/crt-essentials-2026</a:t>
+              <a:rPr/>
+              <a:t>Passwords</a:t>
+            </a:r>
+          </a:p>
+          <a:p>
+            <a:pPr lvl="0">
+              <a:buAutoNum type="arabicPeriod"/>
+            </a:pPr>
+            <a:r>
+              <a:rPr/>
+              <a:t>PKI</a:t>
+            </a:r>
+          </a:p>
+          <a:p>
+            <a:pPr lvl="0">
+              <a:buAutoNum type="arabicPeriod"/>
+            </a:pPr>
+            <a:r>
+              <a:rPr/>
+              <a:t>Email security</a:t>
+            </a:r>
+          </a:p>
+          <a:p>
+            <a:pPr lvl="0">
+              <a:buAutoNum type="arabicPeriod"/>
+            </a:pPr>
+            <a:r>
+              <a:rPr/>
+              <a:t>PowerShell</a:t>
+            </a:r>
+          </a:p>
+          <a:p>
+            <a:pPr lvl="0">
+              <a:buAutoNum type="arabicPeriod"/>
+            </a:pPr>
+            <a:r>
+              <a:rPr/>
+              <a:t>Building a Windows DFIR box</a:t>
             </a:r>
           </a:p>
         </p:txBody>
@@ -13215,18 +12637,103 @@
               <a:buNone/>
             </a:pPr>
             <a:r>
-              <a:rPr>
-                <a:latin typeface="Consolas"/>
-              </a:rPr>
-              <a:t>&gt; HELO red.secondary.com
-. 250 smtp.learndmarc.com Hello red.secondary.com &lt;153.112.107.49&gt;
-&gt; MAIL FROM: &lt;gina@red.secondary.com&gt;
-&gt; From: "Gina" &lt;gina@blue.secondary.com&gt;
-&gt; DKIM-Signature: v=1; a=rsa-sha256; d=primary.com; s=selector;
-  (DKIM Auth Result: PASS)
-_dmarc.blue.secondary.com: "v=DMARC1; p=quarantine; t=y;"
-red.secondary.com:  "v=spf1 ip4:182.107.92.190 -all"
-blue.secondary.com: "v=spf1 ip4:24.121.50.128 ~all"</a:t>
+              <a:rPr b="1">
+                <a:solidFill>
+                  <a:srgbClr val="0C2454"/>
+                </a:solidFill>
+                <a:latin typeface="Consolas"/>
+              </a:rPr>
+              <a:t>&gt; HELO red.secondary.com</a:t>
+            </a:r>
+            <a:br/>
+            <a:r>
+              <a:rPr>
+                <a:solidFill>
+                  <a:srgbClr val="B3352F"/>
+                </a:solidFill>
+                <a:latin typeface="Consolas"/>
+              </a:rPr>
+              <a:t>. 250 smtp.learndmarc.com Hello red.secondary.com &lt;153.112.107.49&gt;</a:t>
+            </a:r>
+            <a:br/>
+            <a:r>
+              <a:rPr b="1">
+                <a:solidFill>
+                  <a:srgbClr val="0C2454"/>
+                </a:solidFill>
+                <a:latin typeface="Consolas"/>
+              </a:rPr>
+              <a:t>&gt; MAIL FROM: &lt;gina@red.secondary.com&gt;</a:t>
+            </a:r>
+            <a:br/>
+            <a:r>
+              <a:rPr b="1">
+                <a:solidFill>
+                  <a:srgbClr val="0C2454"/>
+                </a:solidFill>
+                <a:latin typeface="Consolas"/>
+              </a:rPr>
+              <a:t>&gt; From: "Gina" &lt;gina@blue.secondary.com&gt;</a:t>
+            </a:r>
+            <a:br/>
+            <a:r>
+              <a:rPr b="1">
+                <a:solidFill>
+                  <a:srgbClr val="0C2454"/>
+                </a:solidFill>
+                <a:latin typeface="Consolas"/>
+              </a:rPr>
+              <a:t>&gt; DKIM-Signature: v=1; a=rsa-sha256; d=primary.com; s=selector;</a:t>
+            </a:r>
+            <a:br/>
+            <a:r>
+              <a:rPr>
+                <a:solidFill>
+                  <a:srgbClr val="1A1D23"/>
+                </a:solidFill>
+                <a:latin typeface="Consolas"/>
+              </a:rPr>
+              <a:t>  </a:t>
+            </a:r>
+            <a:r>
+              <a:rPr i="1">
+                <a:solidFill>
+                  <a:srgbClr val="6B7480"/>
+                </a:solidFill>
+                <a:latin typeface="Consolas"/>
+              </a:rPr>
+              <a:t>(DKIM Auth Result: PASS)</a:t>
+            </a:r>
+            <a:br/>
+            <a:br/>
+            <a:r>
+              <a:rPr>
+                <a:solidFill>
+                  <a:srgbClr val="034BAB"/>
+                </a:solidFill>
+                <a:latin typeface="Consolas"/>
+              </a:rPr>
+              <a:t>_dmarc.blue.secondary.com: "v=DMARC1; p=quarantine; t=y;"</a:t>
+            </a:r>
+            <a:br/>
+            <a:r>
+              <a:rPr>
+                <a:solidFill>
+                  <a:srgbClr val="034BAB"/>
+                </a:solidFill>
+                <a:latin typeface="Consolas"/>
+              </a:rPr>
+              <a:t>red.secondary.com:  "v=spf1 ip4:182.107.92.190 -all"</a:t>
+            </a:r>
+            <a:br/>
+            <a:r>
+              <a:rPr>
+                <a:solidFill>
+                  <a:srgbClr val="034BAB"/>
+                </a:solidFill>
+                <a:latin typeface="Consolas"/>
+              </a:rPr>
+              <a:t>blue.secondary.com: "v=spf1 ip4:24.121.50.128 ~all"</a:t>
             </a:r>
           </a:p>
         </p:txBody>
@@ -13656,18 +13163,103 @@
               <a:buNone/>
             </a:pPr>
             <a:r>
-              <a:rPr>
-                <a:latin typeface="Consolas"/>
-              </a:rPr>
-              <a:t>&gt; HELO red.primary.com
-. 250 smtp.learndmarc.com Hello red.primary.com &lt;97.196.174.88&gt;
-&gt; MAIL FROM: &lt;terry@red.primary.com&gt;
-&gt; From: "Terry" &lt;terry@blue.primary.com&gt;
-&gt; DKIM-Signature: v=1; a=rsa-sha256; d=secondary.com; s=selector;
-  (DKIM Auth Result: FAIL)
-_dmarc.blue.primary.com: "v=DMARC1; p=quarantine; adkim=s; aspf=s;"
-red.primary.com:  "v=spf1 ip4:95.129.128.101 ~all"
-blue.primary.com: "v=spf1 ip4:44.62.173.139 ~all"</a:t>
+              <a:rPr b="1">
+                <a:solidFill>
+                  <a:srgbClr val="0C2454"/>
+                </a:solidFill>
+                <a:latin typeface="Consolas"/>
+              </a:rPr>
+              <a:t>&gt; HELO red.primary.com</a:t>
+            </a:r>
+            <a:br/>
+            <a:r>
+              <a:rPr>
+                <a:solidFill>
+                  <a:srgbClr val="B3352F"/>
+                </a:solidFill>
+                <a:latin typeface="Consolas"/>
+              </a:rPr>
+              <a:t>. 250 smtp.learndmarc.com Hello red.primary.com &lt;97.196.174.88&gt;</a:t>
+            </a:r>
+            <a:br/>
+            <a:r>
+              <a:rPr b="1">
+                <a:solidFill>
+                  <a:srgbClr val="0C2454"/>
+                </a:solidFill>
+                <a:latin typeface="Consolas"/>
+              </a:rPr>
+              <a:t>&gt; MAIL FROM: &lt;terry@red.primary.com&gt;</a:t>
+            </a:r>
+            <a:br/>
+            <a:r>
+              <a:rPr b="1">
+                <a:solidFill>
+                  <a:srgbClr val="0C2454"/>
+                </a:solidFill>
+                <a:latin typeface="Consolas"/>
+              </a:rPr>
+              <a:t>&gt; From: "Terry" &lt;terry@blue.primary.com&gt;</a:t>
+            </a:r>
+            <a:br/>
+            <a:r>
+              <a:rPr b="1">
+                <a:solidFill>
+                  <a:srgbClr val="0C2454"/>
+                </a:solidFill>
+                <a:latin typeface="Consolas"/>
+              </a:rPr>
+              <a:t>&gt; DKIM-Signature: v=1; a=rsa-sha256; d=secondary.com; s=selector;</a:t>
+            </a:r>
+            <a:br/>
+            <a:r>
+              <a:rPr>
+                <a:solidFill>
+                  <a:srgbClr val="1A1D23"/>
+                </a:solidFill>
+                <a:latin typeface="Consolas"/>
+              </a:rPr>
+              <a:t>  </a:t>
+            </a:r>
+            <a:r>
+              <a:rPr i="1">
+                <a:solidFill>
+                  <a:srgbClr val="6B7480"/>
+                </a:solidFill>
+                <a:latin typeface="Consolas"/>
+              </a:rPr>
+              <a:t>(DKIM Auth Result: FAIL)</a:t>
+            </a:r>
+            <a:br/>
+            <a:br/>
+            <a:r>
+              <a:rPr>
+                <a:solidFill>
+                  <a:srgbClr val="034BAB"/>
+                </a:solidFill>
+                <a:latin typeface="Consolas"/>
+              </a:rPr>
+              <a:t>_dmarc.blue.primary.com: "v=DMARC1; p=quarantine; adkim=s; aspf=s;"</a:t>
+            </a:r>
+            <a:br/>
+            <a:r>
+              <a:rPr>
+                <a:solidFill>
+                  <a:srgbClr val="034BAB"/>
+                </a:solidFill>
+                <a:latin typeface="Consolas"/>
+              </a:rPr>
+              <a:t>red.primary.com:  "v=spf1 ip4:95.129.128.101 ~all"</a:t>
+            </a:r>
+            <a:br/>
+            <a:r>
+              <a:rPr>
+                <a:solidFill>
+                  <a:srgbClr val="034BAB"/>
+                </a:solidFill>
+                <a:latin typeface="Consolas"/>
+              </a:rPr>
+              <a:t>blue.primary.com: "v=spf1 ip4:44.62.173.139 ~all"</a:t>
             </a:r>
           </a:p>
         </p:txBody>
@@ -14057,18 +13649,103 @@
               <a:buNone/>
             </a:pPr>
             <a:r>
-              <a:rPr>
-                <a:latin typeface="Consolas"/>
-              </a:rPr>
-              <a:t>&gt; HELO blue.secondary.com
-. 250 smtp.learndmarc.com Hello blue.secondary.com &lt;156.157.23.197&gt;
-&gt; MAIL FROM: &lt;ray@blue.secondary.com&gt;
-&gt; From: "Ray" &lt;ray@red.primary.com&gt;
-&gt; DKIM-Signature: v=1; a=rsa-sha256; d=blue.primary.com; s=selector;
-  (DKIM Auth Result: PASS)
-_dmarc.red.primary.com: "v=DMARC1; p=none; adkim=s; aspf=s;"
-blue.secondary.com: "v=spf1 ip4:62.165.120.61 ~all"
-red.primary.com:    "v=spf1 ip4:156.157.23.197 -all"</a:t>
+              <a:rPr b="1">
+                <a:solidFill>
+                  <a:srgbClr val="0C2454"/>
+                </a:solidFill>
+                <a:latin typeface="Consolas"/>
+              </a:rPr>
+              <a:t>&gt; HELO blue.secondary.com</a:t>
+            </a:r>
+            <a:br/>
+            <a:r>
+              <a:rPr>
+                <a:solidFill>
+                  <a:srgbClr val="B3352F"/>
+                </a:solidFill>
+                <a:latin typeface="Consolas"/>
+              </a:rPr>
+              <a:t>. 250 smtp.learndmarc.com Hello blue.secondary.com &lt;156.157.23.197&gt;</a:t>
+            </a:r>
+            <a:br/>
+            <a:r>
+              <a:rPr b="1">
+                <a:solidFill>
+                  <a:srgbClr val="0C2454"/>
+                </a:solidFill>
+                <a:latin typeface="Consolas"/>
+              </a:rPr>
+              <a:t>&gt; MAIL FROM: &lt;ray@blue.secondary.com&gt;</a:t>
+            </a:r>
+            <a:br/>
+            <a:r>
+              <a:rPr b="1">
+                <a:solidFill>
+                  <a:srgbClr val="0C2454"/>
+                </a:solidFill>
+                <a:latin typeface="Consolas"/>
+              </a:rPr>
+              <a:t>&gt; From: "Ray" &lt;ray@red.primary.com&gt;</a:t>
+            </a:r>
+            <a:br/>
+            <a:r>
+              <a:rPr b="1">
+                <a:solidFill>
+                  <a:srgbClr val="0C2454"/>
+                </a:solidFill>
+                <a:latin typeface="Consolas"/>
+              </a:rPr>
+              <a:t>&gt; DKIM-Signature: v=1; a=rsa-sha256; d=blue.primary.com; s=selector;</a:t>
+            </a:r>
+            <a:br/>
+            <a:r>
+              <a:rPr>
+                <a:solidFill>
+                  <a:srgbClr val="1A1D23"/>
+                </a:solidFill>
+                <a:latin typeface="Consolas"/>
+              </a:rPr>
+              <a:t>  </a:t>
+            </a:r>
+            <a:r>
+              <a:rPr i="1">
+                <a:solidFill>
+                  <a:srgbClr val="6B7480"/>
+                </a:solidFill>
+                <a:latin typeface="Consolas"/>
+              </a:rPr>
+              <a:t>(DKIM Auth Result: PASS)</a:t>
+            </a:r>
+            <a:br/>
+            <a:br/>
+            <a:r>
+              <a:rPr>
+                <a:solidFill>
+                  <a:srgbClr val="034BAB"/>
+                </a:solidFill>
+                <a:latin typeface="Consolas"/>
+              </a:rPr>
+              <a:t>_dmarc.red.primary.com: "v=DMARC1; p=none; adkim=s; aspf=s;"</a:t>
+            </a:r>
+            <a:br/>
+            <a:r>
+              <a:rPr>
+                <a:solidFill>
+                  <a:srgbClr val="034BAB"/>
+                </a:solidFill>
+                <a:latin typeface="Consolas"/>
+              </a:rPr>
+              <a:t>blue.secondary.com: "v=spf1 ip4:62.165.120.61 ~all"</a:t>
+            </a:r>
+            <a:br/>
+            <a:r>
+              <a:rPr>
+                <a:solidFill>
+                  <a:srgbClr val="034BAB"/>
+                </a:solidFill>
+                <a:latin typeface="Consolas"/>
+              </a:rPr>
+              <a:t>red.primary.com:    "v=spf1 ip4:156.157.23.197 -all"</a:t>
             </a:r>
           </a:p>
         </p:txBody>
@@ -17830,12 +17507,49 @@
               <a:buNone/>
             </a:pPr>
             <a:r>
+              <a:rPr b="1">
+                <a:solidFill>
+                  <a:srgbClr val="0C2454"/>
+                </a:solidFill>
+                <a:latin typeface="Consolas"/>
+              </a:rPr>
+              <a:t>function</a:t>
+            </a:r>
+            <a:r>
+              <a:rPr>
+                <a:solidFill>
+                  <a:srgbClr val="1A1D23"/>
+                </a:solidFill>
+                <a:latin typeface="Consolas"/>
+              </a:rPr>
+              <a:t> New-CaseFolder </a:t>
+            </a:r>
+            <a:r>
               <a:rPr>
                 <a:solidFill>
                   <a:srgbClr val="5A6472"/>
                 </a:solidFill>
                 <a:latin typeface="Consolas"/>
               </a:rPr>
+              <a:t>{</a:t>
+            </a:r>
+            <a:br/>
+            <a:r>
+              <a:rPr>
+                <a:solidFill>
+                  <a:srgbClr val="1A1D23"/>
+                </a:solidFill>
+                <a:latin typeface="Consolas"/>
+              </a:rPr>
+              <a:t>    </a:t>
+            </a:r>
+            <a:r>
+              <a:rPr>
+                <a:solidFill>
+                  <a:srgbClr val="5A6472"/>
+                </a:solidFill>
+                <a:latin typeface="Consolas"/>
+              </a:rPr>
               <a:t>[</a:t>
             </a:r>
             <a:r>
@@ -17876,6 +17590,15 @@
             </a:r>
             <a:br/>
             <a:r>
+              <a:rPr>
+                <a:solidFill>
+                  <a:srgbClr val="1A1D23"/>
+                </a:solidFill>
+                <a:latin typeface="Consolas"/>
+              </a:rPr>
+              <a:t>    </a:t>
+            </a:r>
+            <a:r>
               <a:rPr b="1">
                 <a:solidFill>
                   <a:srgbClr val="0C2454"/>
@@ -17901,6 +17624,107 @@
                 </a:solidFill>
                 <a:latin typeface="Consolas"/>
               </a:rPr>
+              <a:t>        </a:t>
+            </a:r>
+            <a:r>
+              <a:rPr>
+                <a:solidFill>
+                  <a:srgbClr val="5A6472"/>
+                </a:solidFill>
+                <a:latin typeface="Consolas"/>
+              </a:rPr>
+              <a:t>[</a:t>
+            </a:r>
+            <a:r>
+              <a:rPr>
+                <a:solidFill>
+                  <a:srgbClr val="1A1D23"/>
+                </a:solidFill>
+                <a:latin typeface="Consolas"/>
+              </a:rPr>
+              <a:t>Parameter</a:t>
+            </a:r>
+            <a:r>
+              <a:rPr>
+                <a:solidFill>
+                  <a:srgbClr val="5A6472"/>
+                </a:solidFill>
+                <a:latin typeface="Consolas"/>
+              </a:rPr>
+              <a:t>(</a:t>
+            </a:r>
+            <a:r>
+              <a:rPr>
+                <a:solidFill>
+                  <a:srgbClr val="1A1D23"/>
+                </a:solidFill>
+                <a:latin typeface="Consolas"/>
+              </a:rPr>
+              <a:t>Mandatory</a:t>
+            </a:r>
+            <a:r>
+              <a:rPr>
+                <a:solidFill>
+                  <a:srgbClr val="5A6472"/>
+                </a:solidFill>
+                <a:latin typeface="Consolas"/>
+              </a:rPr>
+              <a:t>)]</a:t>
+            </a:r>
+            <a:br/>
+            <a:r>
+              <a:rPr>
+                <a:solidFill>
+                  <a:srgbClr val="1A1D23"/>
+                </a:solidFill>
+                <a:latin typeface="Consolas"/>
+              </a:rPr>
+              <a:t>        </a:t>
+            </a:r>
+            <a:r>
+              <a:rPr>
+                <a:solidFill>
+                  <a:srgbClr val="5A6472"/>
+                </a:solidFill>
+                <a:latin typeface="Consolas"/>
+              </a:rPr>
+              <a:t>[</a:t>
+            </a:r>
+            <a:r>
+              <a:rPr>
+                <a:solidFill>
+                  <a:srgbClr val="034BAB"/>
+                </a:solidFill>
+                <a:latin typeface="Consolas"/>
+              </a:rPr>
+              <a:t>string</a:t>
+            </a:r>
+            <a:r>
+              <a:rPr>
+                <a:solidFill>
+                  <a:srgbClr val="5A6472"/>
+                </a:solidFill>
+                <a:latin typeface="Consolas"/>
+              </a:rPr>
+              <a:t>]</a:t>
+            </a:r>
+            <a:r>
+              <a:rPr>
+                <a:solidFill>
+                  <a:srgbClr val="0C2454"/>
+                </a:solidFill>
+                <a:latin typeface="Consolas"/>
+              </a:rPr>
+              <a:t>$Path</a:t>
+            </a:r>
+            <a:br/>
+            <a:r>
+              <a:rPr>
+                <a:solidFill>
+                  <a:srgbClr val="1A1D23"/>
+                </a:solidFill>
+                <a:latin typeface="Consolas"/>
+              </a:rPr>
               <a:t>    </a:t>
             </a:r>
             <a:r>
@@ -17910,8 +17734,9 @@
                 </a:solidFill>
                 <a:latin typeface="Consolas"/>
               </a:rPr>
-              <a:t>[</a:t>
-            </a:r>
+              <a:t>)</a:t>
+            </a:r>
+            <a:br/>
             <a:r>
               <a:rPr>
                 <a:solidFill>
@@ -17919,7 +17744,25 @@
                 </a:solidFill>
                 <a:latin typeface="Consolas"/>
               </a:rPr>
-              <a:t>Parameter</a:t>
+              <a:t>    </a:t>
+            </a:r>
+            <a:r>
+              <a:rPr b="1">
+                <a:solidFill>
+                  <a:srgbClr val="0C2454"/>
+                </a:solidFill>
+                <a:latin typeface="Consolas"/>
+              </a:rPr>
+              <a:t>if</a:t>
+            </a:r>
+            <a:r>
+              <a:rPr>
+                <a:solidFill>
+                  <a:srgbClr val="1A1D23"/>
+                </a:solidFill>
+                <a:latin typeface="Consolas"/>
+              </a:rPr>
+              <a:t> </a:t>
             </a:r>
             <a:r>
               <a:rPr>
@@ -17933,11 +17776,74 @@
             <a:r>
               <a:rPr>
                 <a:solidFill>
+                  <a:srgbClr val="0C2454"/>
+                </a:solidFill>
+                <a:latin typeface="Consolas"/>
+              </a:rPr>
+              <a:t>$PSCmdlet</a:t>
+            </a:r>
+            <a:r>
+              <a:rPr>
+                <a:solidFill>
+                  <a:srgbClr val="5A6472"/>
+                </a:solidFill>
+                <a:latin typeface="Consolas"/>
+              </a:rPr>
+              <a:t>.</a:t>
+            </a:r>
+            <a:r>
+              <a:rPr>
+                <a:solidFill>
+                  <a:srgbClr val="034BAB"/>
+                </a:solidFill>
+                <a:latin typeface="Consolas"/>
+              </a:rPr>
+              <a:t>ShouldProcess</a:t>
+            </a:r>
+            <a:r>
+              <a:rPr>
+                <a:solidFill>
+                  <a:srgbClr val="5A6472"/>
+                </a:solidFill>
+                <a:latin typeface="Consolas"/>
+              </a:rPr>
+              <a:t>(</a:t>
+            </a:r>
+            <a:r>
+              <a:rPr>
+                <a:solidFill>
+                  <a:srgbClr val="0C2454"/>
+                </a:solidFill>
+                <a:latin typeface="Consolas"/>
+              </a:rPr>
+              <a:t>$Path</a:t>
+            </a:r>
+            <a:r>
+              <a:rPr>
+                <a:solidFill>
+                  <a:srgbClr val="5A6472"/>
+                </a:solidFill>
+                <a:latin typeface="Consolas"/>
+              </a:rPr>
+              <a:t>,</a:t>
+            </a:r>
+            <a:r>
+              <a:rPr>
+                <a:solidFill>
                   <a:srgbClr val="1A1D23"/>
                 </a:solidFill>
                 <a:latin typeface="Consolas"/>
               </a:rPr>
-              <a:t>Mandatory</a:t>
+              <a:t> </a:t>
+            </a:r>
+            <a:r>
+              <a:rPr>
+                <a:solidFill>
+                  <a:srgbClr val="B3352F"/>
+                </a:solidFill>
+                <a:latin typeface="Consolas"/>
+              </a:rPr>
+              <a:t>'Create case folder'</a:t>
             </a:r>
             <a:r>
               <a:rPr>
@@ -17946,7 +17852,25 @@
                 </a:solidFill>
                 <a:latin typeface="Consolas"/>
               </a:rPr>
-              <a:t>)]</a:t>
+              <a:t>))</a:t>
+            </a:r>
+            <a:r>
+              <a:rPr>
+                <a:solidFill>
+                  <a:srgbClr val="1A1D23"/>
+                </a:solidFill>
+                <a:latin typeface="Consolas"/>
+              </a:rPr>
+              <a:t> </a:t>
+            </a:r>
+            <a:r>
+              <a:rPr>
+                <a:solidFill>
+                  <a:srgbClr val="5A6472"/>
+                </a:solidFill>
+                <a:latin typeface="Consolas"/>
+              </a:rPr>
+              <a:t>{</a:t>
             </a:r>
             <a:br/>
             <a:r>
@@ -17956,6 +17880,115 @@
                 </a:solidFill>
                 <a:latin typeface="Consolas"/>
               </a:rPr>
+              <a:t>        </a:t>
+            </a:r>
+            <a:r>
+              <a:rPr>
+                <a:solidFill>
+                  <a:srgbClr val="034BAB"/>
+                </a:solidFill>
+                <a:latin typeface="Consolas"/>
+              </a:rPr>
+              <a:t>New-Item</a:t>
+            </a:r>
+            <a:r>
+              <a:rPr>
+                <a:solidFill>
+                  <a:srgbClr val="1A1D23"/>
+                </a:solidFill>
+                <a:latin typeface="Consolas"/>
+              </a:rPr>
+              <a:t> </a:t>
+            </a:r>
+            <a:r>
+              <a:rPr>
+                <a:solidFill>
+                  <a:srgbClr val="5A6472"/>
+                </a:solidFill>
+                <a:latin typeface="Consolas"/>
+              </a:rPr>
+              <a:t>-</a:t>
+            </a:r>
+            <a:r>
+              <a:rPr>
+                <a:solidFill>
+                  <a:srgbClr val="1A1D23"/>
+                </a:solidFill>
+                <a:latin typeface="Consolas"/>
+              </a:rPr>
+              <a:t>Path </a:t>
+            </a:r>
+            <a:r>
+              <a:rPr>
+                <a:solidFill>
+                  <a:srgbClr val="0C2454"/>
+                </a:solidFill>
+                <a:latin typeface="Consolas"/>
+              </a:rPr>
+              <a:t>$Path</a:t>
+            </a:r>
+            <a:r>
+              <a:rPr>
+                <a:solidFill>
+                  <a:srgbClr val="1A1D23"/>
+                </a:solidFill>
+                <a:latin typeface="Consolas"/>
+              </a:rPr>
+              <a:t> </a:t>
+            </a:r>
+            <a:r>
+              <a:rPr>
+                <a:solidFill>
+                  <a:srgbClr val="5A6472"/>
+                </a:solidFill>
+                <a:latin typeface="Consolas"/>
+              </a:rPr>
+              <a:t>-</a:t>
+            </a:r>
+            <a:r>
+              <a:rPr>
+                <a:solidFill>
+                  <a:srgbClr val="1A1D23"/>
+                </a:solidFill>
+                <a:latin typeface="Consolas"/>
+              </a:rPr>
+              <a:t>ItemType Directory </a:t>
+            </a:r>
+            <a:r>
+              <a:rPr>
+                <a:solidFill>
+                  <a:srgbClr val="5A6472"/>
+                </a:solidFill>
+                <a:latin typeface="Consolas"/>
+              </a:rPr>
+              <a:t>|</a:t>
+            </a:r>
+            <a:r>
+              <a:rPr>
+                <a:solidFill>
+                  <a:srgbClr val="1A1D23"/>
+                </a:solidFill>
+                <a:latin typeface="Consolas"/>
+              </a:rPr>
+              <a:t> </a:t>
+            </a:r>
+            <a:r>
+              <a:rPr>
+                <a:solidFill>
+                  <a:srgbClr val="034BAB"/>
+                </a:solidFill>
+                <a:latin typeface="Consolas"/>
+              </a:rPr>
+              <a:t>Out-Null</a:t>
+            </a:r>
+            <a:br/>
+            <a:r>
+              <a:rPr>
+                <a:solidFill>
+                  <a:srgbClr val="1A1D23"/>
+                </a:solidFill>
+                <a:latin typeface="Consolas"/>
+              </a:rPr>
               <a:t>    </a:t>
             </a:r>
             <a:r>
@@ -17965,280 +17998,7 @@
                 </a:solidFill>
                 <a:latin typeface="Consolas"/>
               </a:rPr>
-              <a:t>[</a:t>
-            </a:r>
-            <a:r>
-              <a:rPr>
-                <a:solidFill>
-                  <a:srgbClr val="034BAB"/>
-                </a:solidFill>
-                <a:latin typeface="Consolas"/>
-              </a:rPr>
-              <a:t>string</a:t>
-            </a:r>
-            <a:r>
-              <a:rPr>
-                <a:solidFill>
-                  <a:srgbClr val="5A6472"/>
-                </a:solidFill>
-                <a:latin typeface="Consolas"/>
-              </a:rPr>
-              <a:t>]</a:t>
-            </a:r>
-            <a:r>
-              <a:rPr>
-                <a:solidFill>
-                  <a:srgbClr val="0C2454"/>
-                </a:solidFill>
-                <a:latin typeface="Consolas"/>
-              </a:rPr>
-              <a:t>$Path</a:t>
-            </a:r>
-            <a:br/>
-            <a:r>
-              <a:rPr>
-                <a:solidFill>
-                  <a:srgbClr val="5A6472"/>
-                </a:solidFill>
-                <a:latin typeface="Consolas"/>
-              </a:rPr>
-              <a:t>)</a:t>
-            </a:r>
-            <a:br/>
-            <a:r>
-              <a:rPr b="1">
-                <a:solidFill>
-                  <a:srgbClr val="0C2454"/>
-                </a:solidFill>
-                <a:latin typeface="Consolas"/>
-              </a:rPr>
-              <a:t>if</a:t>
-            </a:r>
-            <a:r>
-              <a:rPr>
-                <a:solidFill>
-                  <a:srgbClr val="1A1D23"/>
-                </a:solidFill>
-                <a:latin typeface="Consolas"/>
-              </a:rPr>
-              <a:t> </a:t>
-            </a:r>
-            <a:r>
-              <a:rPr>
-                <a:solidFill>
-                  <a:srgbClr val="5A6472"/>
-                </a:solidFill>
-                <a:latin typeface="Consolas"/>
-              </a:rPr>
-              <a:t>(</a:t>
-            </a:r>
-            <a:r>
-              <a:rPr>
-                <a:solidFill>
-                  <a:srgbClr val="0C2454"/>
-                </a:solidFill>
-                <a:latin typeface="Consolas"/>
-              </a:rPr>
-              <a:t>$PSCmdlet</a:t>
-            </a:r>
-            <a:r>
-              <a:rPr>
-                <a:solidFill>
-                  <a:srgbClr val="5A6472"/>
-                </a:solidFill>
-                <a:latin typeface="Consolas"/>
-              </a:rPr>
-              <a:t>.</a:t>
-            </a:r>
-            <a:r>
-              <a:rPr>
-                <a:solidFill>
-                  <a:srgbClr val="034BAB"/>
-                </a:solidFill>
-                <a:latin typeface="Consolas"/>
-              </a:rPr>
-              <a:t>ShouldProcess</a:t>
-            </a:r>
-            <a:r>
-              <a:rPr>
-                <a:solidFill>
-                  <a:srgbClr val="5A6472"/>
-                </a:solidFill>
-                <a:latin typeface="Consolas"/>
-              </a:rPr>
-              <a:t>(</a:t>
-            </a:r>
-            <a:r>
-              <a:rPr>
-                <a:solidFill>
-                  <a:srgbClr val="0C2454"/>
-                </a:solidFill>
-                <a:latin typeface="Consolas"/>
-              </a:rPr>
-              <a:t>$Path</a:t>
-            </a:r>
-            <a:r>
-              <a:rPr>
-                <a:solidFill>
-                  <a:srgbClr val="5A6472"/>
-                </a:solidFill>
-                <a:latin typeface="Consolas"/>
-              </a:rPr>
-              <a:t>,</a:t>
-            </a:r>
-            <a:r>
-              <a:rPr>
-                <a:solidFill>
-                  <a:srgbClr val="1A1D23"/>
-                </a:solidFill>
-                <a:latin typeface="Consolas"/>
-              </a:rPr>
-              <a:t> </a:t>
-            </a:r>
-            <a:r>
-              <a:rPr>
-                <a:solidFill>
-                  <a:srgbClr val="B3352F"/>
-                </a:solidFill>
-                <a:latin typeface="Consolas"/>
-              </a:rPr>
-              <a:t>'Create case folder'</a:t>
-            </a:r>
-            <a:r>
-              <a:rPr>
-                <a:solidFill>
-                  <a:srgbClr val="5A6472"/>
-                </a:solidFill>
-                <a:latin typeface="Consolas"/>
-              </a:rPr>
-              <a:t>))</a:t>
-            </a:r>
-            <a:r>
-              <a:rPr>
-                <a:solidFill>
-                  <a:srgbClr val="1A1D23"/>
-                </a:solidFill>
-                <a:latin typeface="Consolas"/>
-              </a:rPr>
-              <a:t> </a:t>
-            </a:r>
-            <a:r>
-              <a:rPr>
-                <a:solidFill>
-                  <a:srgbClr val="5A6472"/>
-                </a:solidFill>
-                <a:latin typeface="Consolas"/>
-              </a:rPr>
-              <a:t>{</a:t>
-            </a:r>
-            <a:br/>
-            <a:r>
-              <a:rPr>
-                <a:solidFill>
-                  <a:srgbClr val="1A1D23"/>
-                </a:solidFill>
-                <a:latin typeface="Consolas"/>
-              </a:rPr>
-              <a:t>    </a:t>
-            </a:r>
-            <a:r>
-              <a:rPr>
-                <a:solidFill>
-                  <a:srgbClr val="034BAB"/>
-                </a:solidFill>
-                <a:latin typeface="Consolas"/>
-              </a:rPr>
-              <a:t>New-Item</a:t>
-            </a:r>
-            <a:r>
-              <a:rPr>
-                <a:solidFill>
-                  <a:srgbClr val="1A1D23"/>
-                </a:solidFill>
-                <a:latin typeface="Consolas"/>
-              </a:rPr>
-              <a:t> </a:t>
-            </a:r>
-            <a:r>
-              <a:rPr>
-                <a:solidFill>
-                  <a:srgbClr val="5A6472"/>
-                </a:solidFill>
-                <a:latin typeface="Consolas"/>
-              </a:rPr>
-              <a:t>-</a:t>
-            </a:r>
-            <a:r>
-              <a:rPr>
-                <a:solidFill>
-                  <a:srgbClr val="1A1D23"/>
-                </a:solidFill>
-                <a:latin typeface="Consolas"/>
-              </a:rPr>
-              <a:t>Path </a:t>
-            </a:r>
-            <a:r>
-              <a:rPr>
-                <a:solidFill>
-                  <a:srgbClr val="0C2454"/>
-                </a:solidFill>
-                <a:latin typeface="Consolas"/>
-              </a:rPr>
-              <a:t>$Path</a:t>
-            </a:r>
-            <a:r>
-              <a:rPr>
-                <a:solidFill>
-                  <a:srgbClr val="1A1D23"/>
-                </a:solidFill>
-                <a:latin typeface="Consolas"/>
-              </a:rPr>
-              <a:t> </a:t>
-            </a:r>
-            <a:r>
-              <a:rPr>
-                <a:solidFill>
-                  <a:srgbClr val="5A6472"/>
-                </a:solidFill>
-                <a:latin typeface="Consolas"/>
-              </a:rPr>
-              <a:t>-</a:t>
-            </a:r>
-            <a:r>
-              <a:rPr>
-                <a:solidFill>
-                  <a:srgbClr val="1A1D23"/>
-                </a:solidFill>
-                <a:latin typeface="Consolas"/>
-              </a:rPr>
-              <a:t>ItemType Directory </a:t>
-            </a:r>
-            <a:r>
-              <a:rPr>
-                <a:solidFill>
-                  <a:srgbClr val="5A6472"/>
-                </a:solidFill>
-                <a:latin typeface="Consolas"/>
-              </a:rPr>
-              <a:t>|</a:t>
-            </a:r>
-            <a:r>
-              <a:rPr>
-                <a:solidFill>
-                  <a:srgbClr val="1A1D23"/>
-                </a:solidFill>
-                <a:latin typeface="Consolas"/>
-              </a:rPr>
-              <a:t> </a:t>
-            </a:r>
-            <a:r>
-              <a:rPr>
-                <a:solidFill>
-                  <a:srgbClr val="034BAB"/>
-                </a:solidFill>
-                <a:latin typeface="Consolas"/>
-              </a:rPr>
-              <a:t>Out-Null</a:t>
+              <a:t>}</a:t>
             </a:r>
             <a:br/>
             <a:r>
@@ -18372,8 +18132,8 @@
         </p:nvSpPr>
         <p:spPr>
           <a:xfrm>
-            <a:off x="548640" y="1828800"/>
-            <a:ext cx="6766560" cy="2377440"/>
+            <a:off x="548640" y="347472"/>
+            <a:ext cx="11094720" cy="841248"/>
           </a:xfrm>
           <a:prstGeom prst="rect">
             <a:avLst/>
@@ -18388,14 +18148,415 @@
             </a:pPr>
             <a:r>
               <a:rPr/>
-              <a:t>Questions?</a:t>
-            </a:r>
-          </a:p>
-        </p:txBody>
-      </p:sp>
-      <p:sp>
-        <p:nvSpPr>
-          <p:cNvPr id="5" name="Footer Placeholder"/>
+              <a:t>Your own module</a:t>
+            </a:r>
+          </a:p>
+        </p:txBody>
+      </p:sp>
+      <p:sp>
+        <p:nvSpPr>
+          <p:cNvPr id="3" name="Content Placeholder 3"/>
+          <p:cNvSpPr>
+            <a:spLocks noGrp="1"/>
+          </p:cNvSpPr>
+          <p:nvPr>
+            <p:ph idx="1"/>
+          </p:nvPr>
+        </p:nvSpPr>
+        <p:spPr/>
+        <p:txBody>
+          <a:bodyPr/>
+          <a:lstStyle/>
+          <a:p>
+            <a:pPr lvl="0"/>
+            <a:r>
+              <a:rPr/>
+              <a:t>A </a:t>
+            </a:r>
+            <a:r>
+              <a:rPr>
+                <a:latin typeface="Consolas"/>
+              </a:rPr>
+              <a:t>.psm1</a:t>
+            </a:r>
+            <a:r>
+              <a:rPr/>
+              <a:t> file of functions, in a folder of the same name</a:t>
+            </a:r>
+          </a:p>
+          <a:p>
+            <a:pPr lvl="0"/>
+            <a:r>
+              <a:rPr/>
+              <a:t>In your </a:t>
+            </a:r>
+            <a:r>
+              <a:rPr>
+                <a:latin typeface="Consolas"/>
+              </a:rPr>
+              <a:t>Documents\PowerShell\Modules</a:t>
+            </a:r>
+            <a:r>
+              <a:rPr/>
+              <a:t> folder, PowerShell loads it for you</a:t>
+            </a:r>
+          </a:p>
+          <a:p>
+            <a:pPr lvl="0" indent="0">
+              <a:buNone/>
+            </a:pPr>
+            <a:r>
+              <a:rPr>
+                <a:solidFill>
+                  <a:srgbClr val="0C2454"/>
+                </a:solidFill>
+                <a:latin typeface="Consolas"/>
+              </a:rPr>
+              <a:t>$Docs</a:t>
+            </a:r>
+            <a:r>
+              <a:rPr>
+                <a:solidFill>
+                  <a:srgbClr val="1A1D23"/>
+                </a:solidFill>
+                <a:latin typeface="Consolas"/>
+              </a:rPr>
+              <a:t> </a:t>
+            </a:r>
+            <a:r>
+              <a:rPr>
+                <a:solidFill>
+                  <a:srgbClr val="5A6472"/>
+                </a:solidFill>
+                <a:latin typeface="Consolas"/>
+              </a:rPr>
+              <a:t>=</a:t>
+            </a:r>
+            <a:r>
+              <a:rPr>
+                <a:solidFill>
+                  <a:srgbClr val="1A1D23"/>
+                </a:solidFill>
+                <a:latin typeface="Consolas"/>
+              </a:rPr>
+              <a:t> </a:t>
+            </a:r>
+            <a:r>
+              <a:rPr>
+                <a:solidFill>
+                  <a:srgbClr val="5A6472"/>
+                </a:solidFill>
+                <a:latin typeface="Consolas"/>
+              </a:rPr>
+              <a:t>[</a:t>
+            </a:r>
+            <a:r>
+              <a:rPr>
+                <a:solidFill>
+                  <a:srgbClr val="1A1D23"/>
+                </a:solidFill>
+                <a:latin typeface="Consolas"/>
+              </a:rPr>
+              <a:t>Environment</a:t>
+            </a:r>
+            <a:r>
+              <a:rPr>
+                <a:solidFill>
+                  <a:srgbClr val="5A6472"/>
+                </a:solidFill>
+                <a:latin typeface="Consolas"/>
+              </a:rPr>
+              <a:t>]::</a:t>
+            </a:r>
+            <a:r>
+              <a:rPr>
+                <a:solidFill>
+                  <a:srgbClr val="1A1D23"/>
+                </a:solidFill>
+                <a:latin typeface="Consolas"/>
+              </a:rPr>
+              <a:t>GetFolderPath</a:t>
+            </a:r>
+            <a:r>
+              <a:rPr>
+                <a:solidFill>
+                  <a:srgbClr val="5A6472"/>
+                </a:solidFill>
+                <a:latin typeface="Consolas"/>
+              </a:rPr>
+              <a:t>(</a:t>
+            </a:r>
+            <a:r>
+              <a:rPr>
+                <a:solidFill>
+                  <a:srgbClr val="B3352F"/>
+                </a:solidFill>
+                <a:latin typeface="Consolas"/>
+              </a:rPr>
+              <a:t>'MyDocuments'</a:t>
+            </a:r>
+            <a:r>
+              <a:rPr>
+                <a:solidFill>
+                  <a:srgbClr val="5A6472"/>
+                </a:solidFill>
+                <a:latin typeface="Consolas"/>
+              </a:rPr>
+              <a:t>)</a:t>
+            </a:r>
+            <a:br/>
+            <a:r>
+              <a:rPr>
+                <a:solidFill>
+                  <a:srgbClr val="0C2454"/>
+                </a:solidFill>
+                <a:latin typeface="Consolas"/>
+              </a:rPr>
+              <a:t>$Folder</a:t>
+            </a:r>
+            <a:r>
+              <a:rPr>
+                <a:solidFill>
+                  <a:srgbClr val="1A1D23"/>
+                </a:solidFill>
+                <a:latin typeface="Consolas"/>
+              </a:rPr>
+              <a:t> </a:t>
+            </a:r>
+            <a:r>
+              <a:rPr>
+                <a:solidFill>
+                  <a:srgbClr val="5A6472"/>
+                </a:solidFill>
+                <a:latin typeface="Consolas"/>
+              </a:rPr>
+              <a:t>=</a:t>
+            </a:r>
+            <a:r>
+              <a:rPr>
+                <a:solidFill>
+                  <a:srgbClr val="1A1D23"/>
+                </a:solidFill>
+                <a:latin typeface="Consolas"/>
+              </a:rPr>
+              <a:t> </a:t>
+            </a:r>
+            <a:r>
+              <a:rPr>
+                <a:solidFill>
+                  <a:srgbClr val="B3352F"/>
+                </a:solidFill>
+                <a:latin typeface="Consolas"/>
+              </a:rPr>
+              <a:t>"</a:t>
+            </a:r>
+            <a:r>
+              <a:rPr>
+                <a:solidFill>
+                  <a:srgbClr val="0C2454"/>
+                </a:solidFill>
+                <a:latin typeface="Consolas"/>
+              </a:rPr>
+              <a:t>$Docs</a:t>
+            </a:r>
+            <a:r>
+              <a:rPr>
+                <a:solidFill>
+                  <a:srgbClr val="B3352F"/>
+                </a:solidFill>
+                <a:latin typeface="Consolas"/>
+              </a:rPr>
+              <a:t>\PowerShell\Modules\MyTools"</a:t>
+            </a:r>
+            <a:br/>
+            <a:r>
+              <a:rPr>
+                <a:solidFill>
+                  <a:srgbClr val="034BAB"/>
+                </a:solidFill>
+                <a:latin typeface="Consolas"/>
+              </a:rPr>
+              <a:t>New-Item</a:t>
+            </a:r>
+            <a:r>
+              <a:rPr>
+                <a:solidFill>
+                  <a:srgbClr val="1A1D23"/>
+                </a:solidFill>
+                <a:latin typeface="Consolas"/>
+              </a:rPr>
+              <a:t> </a:t>
+            </a:r>
+            <a:r>
+              <a:rPr>
+                <a:solidFill>
+                  <a:srgbClr val="5A6472"/>
+                </a:solidFill>
+                <a:latin typeface="Consolas"/>
+              </a:rPr>
+              <a:t>-</a:t>
+            </a:r>
+            <a:r>
+              <a:rPr>
+                <a:solidFill>
+                  <a:srgbClr val="1A1D23"/>
+                </a:solidFill>
+                <a:latin typeface="Consolas"/>
+              </a:rPr>
+              <a:t>Path </a:t>
+            </a:r>
+            <a:r>
+              <a:rPr>
+                <a:solidFill>
+                  <a:srgbClr val="0C2454"/>
+                </a:solidFill>
+                <a:latin typeface="Consolas"/>
+              </a:rPr>
+              <a:t>$Folder</a:t>
+            </a:r>
+            <a:r>
+              <a:rPr>
+                <a:solidFill>
+                  <a:srgbClr val="1A1D23"/>
+                </a:solidFill>
+                <a:latin typeface="Consolas"/>
+              </a:rPr>
+              <a:t> </a:t>
+            </a:r>
+            <a:r>
+              <a:rPr>
+                <a:solidFill>
+                  <a:srgbClr val="5A6472"/>
+                </a:solidFill>
+                <a:latin typeface="Consolas"/>
+              </a:rPr>
+              <a:t>-</a:t>
+            </a:r>
+            <a:r>
+              <a:rPr>
+                <a:solidFill>
+                  <a:srgbClr val="1A1D23"/>
+                </a:solidFill>
+                <a:latin typeface="Consolas"/>
+              </a:rPr>
+              <a:t>ItemType Directory </a:t>
+            </a:r>
+            <a:r>
+              <a:rPr>
+                <a:solidFill>
+                  <a:srgbClr val="5A6472"/>
+                </a:solidFill>
+                <a:latin typeface="Consolas"/>
+              </a:rPr>
+              <a:t>-</a:t>
+            </a:r>
+            <a:r>
+              <a:rPr>
+                <a:solidFill>
+                  <a:srgbClr val="1A1D23"/>
+                </a:solidFill>
+                <a:latin typeface="Consolas"/>
+              </a:rPr>
+              <a:t>Force</a:t>
+            </a:r>
+            <a:br/>
+            <a:r>
+              <a:rPr>
+                <a:solidFill>
+                  <a:srgbClr val="1A1D23"/>
+                </a:solidFill>
+                <a:latin typeface="Consolas"/>
+              </a:rPr>
+              <a:t>notepad </a:t>
+            </a:r>
+            <a:r>
+              <a:rPr>
+                <a:solidFill>
+                  <a:srgbClr val="B3352F"/>
+                </a:solidFill>
+                <a:latin typeface="Consolas"/>
+              </a:rPr>
+              <a:t>"</a:t>
+            </a:r>
+            <a:r>
+              <a:rPr>
+                <a:solidFill>
+                  <a:srgbClr val="0C2454"/>
+                </a:solidFill>
+                <a:latin typeface="Consolas"/>
+              </a:rPr>
+              <a:t>$Folder</a:t>
+            </a:r>
+            <a:r>
+              <a:rPr>
+                <a:solidFill>
+                  <a:srgbClr val="B3352F"/>
+                </a:solidFill>
+                <a:latin typeface="Consolas"/>
+              </a:rPr>
+              <a:t>\MyTools.psm1"</a:t>
+            </a:r>
+            <a:r>
+              <a:rPr>
+                <a:solidFill>
+                  <a:srgbClr val="1A1D23"/>
+                </a:solidFill>
+                <a:latin typeface="Consolas"/>
+              </a:rPr>
+              <a:t>     </a:t>
+            </a:r>
+            <a:r>
+              <a:rPr i="1">
+                <a:solidFill>
+                  <a:srgbClr val="6B7480"/>
+                </a:solidFill>
+                <a:latin typeface="Consolas"/>
+              </a:rPr>
+              <a:t># paste functions, save</a:t>
+            </a:r>
+            <a:br/>
+            <a:r>
+              <a:rPr>
+                <a:solidFill>
+                  <a:srgbClr val="034BAB"/>
+                </a:solidFill>
+                <a:latin typeface="Consolas"/>
+              </a:rPr>
+              <a:t>Get-Command</a:t>
+            </a:r>
+            <a:r>
+              <a:rPr>
+                <a:solidFill>
+                  <a:srgbClr val="1A1D23"/>
+                </a:solidFill>
+                <a:latin typeface="Consolas"/>
+              </a:rPr>
+              <a:t> </a:t>
+            </a:r>
+            <a:r>
+              <a:rPr>
+                <a:solidFill>
+                  <a:srgbClr val="5A6472"/>
+                </a:solidFill>
+                <a:latin typeface="Consolas"/>
+              </a:rPr>
+              <a:t>-</a:t>
+            </a:r>
+            <a:r>
+              <a:rPr>
+                <a:solidFill>
+                  <a:srgbClr val="1A1D23"/>
+                </a:solidFill>
+                <a:latin typeface="Consolas"/>
+              </a:rPr>
+              <a:t>Module MyTools</a:t>
+            </a:r>
+          </a:p>
+        </p:txBody>
+      </p:sp>
+      <p:sp>
+        <p:nvSpPr>
+          <p:cNvPr id="4" name="Footer Placeholder"/>
           <p:cNvSpPr>
             <a:spLocks noGrp="1"/>
           </p:cNvSpPr>
@@ -18421,7 +18582,7 @@
               <a:buNone/>
               <a:defRPr spc="10" sz="1000">
                 <a:solidFill>
-                  <a:srgbClr val="8DA2BE"/>
+                  <a:srgbClr val="5A6472"/>
                 </a:solidFill>
                 <a:latin typeface="+mn-lt"/>
               </a:defRPr>
@@ -18437,7 +18598,7 @@
       </p:sp>
       <p:sp>
         <p:nvSpPr>
-          <p:cNvPr id="6" name="Slide Number Placeholder"/>
+          <p:cNvPr id="5" name="Slide Number Placeholder"/>
           <p:cNvSpPr>
             <a:spLocks noGrp="1"/>
           </p:cNvSpPr>
@@ -18463,7 +18624,7 @@
               <a:buNone/>
               <a:defRPr spc="10" sz="1000">
                 <a:solidFill>
-                  <a:srgbClr val="8DA2BE"/>
+                  <a:srgbClr val="5A6472"/>
                 </a:solidFill>
                 <a:latin typeface="+mn-lt"/>
               </a:defRPr>
@@ -18528,7 +18689,7 @@
             </a:pPr>
             <a:r>
               <a:rPr/>
-              <a:t>Building a Windows DFIR box</a:t>
+              <a:t>Questions?</a:t>
             </a:r>
           </a:p>
         </p:txBody>
@@ -18851,8 +19012,8 @@
         </p:nvSpPr>
         <p:spPr>
           <a:xfrm>
-            <a:off x="548640" y="347472"/>
-            <a:ext cx="11094720" cy="841248"/>
+            <a:off x="548640" y="1828800"/>
+            <a:ext cx="6766560" cy="2377440"/>
           </a:xfrm>
           <a:prstGeom prst="rect">
             <a:avLst/>
@@ -18867,51 +19028,14 @@
             </a:pPr>
             <a:r>
               <a:rPr/>
-              <a:t>What we’re building</a:t>
-            </a:r>
-          </a:p>
-        </p:txBody>
-      </p:sp>
-      <p:sp>
-        <p:nvSpPr>
-          <p:cNvPr id="3" name="Content Placeholder 3"/>
-          <p:cNvSpPr>
-            <a:spLocks noGrp="1"/>
-          </p:cNvSpPr>
-          <p:nvPr>
-            <p:ph idx="1"/>
-          </p:nvPr>
-        </p:nvSpPr>
-        <p:spPr/>
-        <p:txBody>
-          <a:bodyPr/>
-          <a:lstStyle/>
-          <a:p>
-            <a:pPr lvl="0"/>
-            <a:r>
-              <a:rPr/>
-              <a:t>A Windows analysis machine, not an evidence acquisition machine</a:t>
-            </a:r>
-          </a:p>
-          <a:p>
-            <a:pPr lvl="0"/>
-            <a:r>
-              <a:rPr/>
-              <a:t>Evidence is already collected</a:t>
-            </a:r>
-          </a:p>
-          <a:p>
-            <a:pPr lvl="0"/>
-            <a:r>
-              <a:rPr/>
-              <a:t>Memory acquisition is handled separately (Magnet in our workflow)</a:t>
-            </a:r>
-          </a:p>
-        </p:txBody>
-      </p:sp>
-      <p:sp>
-        <p:nvSpPr>
-          <p:cNvPr id="4" name="Footer Placeholder"/>
+              <a:t>Building a Windows DFIR box</a:t>
+            </a:r>
+          </a:p>
+        </p:txBody>
+      </p:sp>
+      <p:sp>
+        <p:nvSpPr>
+          <p:cNvPr id="5" name="Footer Placeholder"/>
           <p:cNvSpPr>
             <a:spLocks noGrp="1"/>
           </p:cNvSpPr>
@@ -18937,7 +19061,7 @@
               <a:buNone/>
               <a:defRPr spc="10" sz="1000">
                 <a:solidFill>
-                  <a:srgbClr val="5A6472"/>
+                  <a:srgbClr val="8DA2BE"/>
                 </a:solidFill>
                 <a:latin typeface="+mn-lt"/>
               </a:defRPr>
@@ -18953,7 +19077,7 @@
       </p:sp>
       <p:sp>
         <p:nvSpPr>
-          <p:cNvPr id="5" name="Slide Number Placeholder"/>
+          <p:cNvPr id="6" name="Slide Number Placeholder"/>
           <p:cNvSpPr>
             <a:spLocks noGrp="1"/>
           </p:cNvSpPr>
@@ -18979,7 +19103,7 @@
               <a:buNone/>
               <a:defRPr spc="10" sz="1000">
                 <a:solidFill>
-                  <a:srgbClr val="5A6472"/>
+                  <a:srgbClr val="8DA2BE"/>
                 </a:solidFill>
                 <a:latin typeface="+mn-lt"/>
               </a:defRPr>
@@ -19044,7 +19168,7 @@
             </a:pPr>
             <a:r>
               <a:rPr/>
-              <a:t>Disposable/nonpersistent virtual machine</a:t>
+              <a:t>What we’re building</a:t>
             </a:r>
           </a:p>
         </p:txBody>
@@ -19056,7 +19180,7 @@
             <a:spLocks noGrp="1"/>
           </p:cNvSpPr>
           <p:nvPr>
-            <p:ph idx="1" sz="half"/>
+            <p:ph idx="1"/>
           </p:nvPr>
         </p:nvSpPr>
         <p:spPr/>
@@ -19064,86 +19188,31 @@
           <a:bodyPr/>
           <a:lstStyle/>
           <a:p>
-            <a:pPr lvl="0" indent="0" marL="0">
-              <a:buNone/>
-            </a:pPr>
-            <a:r>
-              <a:rPr b="1"/>
-              <a:t>Return the machine to a known state</a:t>
-            </a:r>
-          </a:p>
-          <a:p>
             <a:pPr lvl="0"/>
             <a:r>
               <a:rPr/>
-              <a:t>Windows and settings</a:t>
+              <a:t>A Windows analysis machine, not an evidence acquisition machine</a:t>
             </a:r>
           </a:p>
           <a:p>
             <a:pPr lvl="0"/>
             <a:r>
               <a:rPr/>
-              <a:t>Installed tools</a:t>
+              <a:t>Evidence is already collected</a:t>
             </a:r>
           </a:p>
           <a:p>
             <a:pPr lvl="0"/>
             <a:r>
               <a:rPr/>
-              <a:t>Temporary files and caches</a:t>
-            </a:r>
-          </a:p>
-        </p:txBody>
-      </p:sp>
-      <p:sp>
-        <p:nvSpPr>
-          <p:cNvPr id="4" name="Content Placeholder 4"/>
-          <p:cNvSpPr>
-            <a:spLocks noGrp="1"/>
-          </p:cNvSpPr>
-          <p:nvPr>
-            <p:ph idx="2" sz="half"/>
-          </p:nvPr>
-        </p:nvSpPr>
-        <p:spPr/>
-        <p:txBody>
-          <a:bodyPr/>
-          <a:lstStyle/>
-          <a:p>
-            <a:pPr lvl="0" indent="0" marL="0">
-              <a:buNone/>
-            </a:pPr>
-            <a:r>
-              <a:rPr b="1"/>
-              <a:t>Keep case data and analysis output separate from what gets reset</a:t>
-            </a:r>
-          </a:p>
-          <a:p>
-            <a:pPr lvl="0"/>
-            <a:r>
-              <a:rPr/>
-              <a:t>Evidence (read-only)</a:t>
-            </a:r>
-          </a:p>
-          <a:p>
-            <a:pPr lvl="0"/>
-            <a:r>
-              <a:rPr/>
-              <a:t>Analysis output</a:t>
-            </a:r>
-          </a:p>
-          <a:p>
-            <a:pPr lvl="0"/>
-            <a:r>
-              <a:rPr/>
-              <a:t>Tool logs and notes</a:t>
-            </a:r>
-          </a:p>
-        </p:txBody>
-      </p:sp>
-      <p:sp>
-        <p:nvSpPr>
-          <p:cNvPr id="5" name="Footer Placeholder"/>
+              <a:t>Memory acquisition is handled separately (Magnet in our workflow)</a:t>
+            </a:r>
+          </a:p>
+        </p:txBody>
+      </p:sp>
+      <p:sp>
+        <p:nvSpPr>
+          <p:cNvPr id="4" name="Footer Placeholder"/>
           <p:cNvSpPr>
             <a:spLocks noGrp="1"/>
           </p:cNvSpPr>
@@ -19185,7 +19254,7 @@
       </p:sp>
       <p:sp>
         <p:nvSpPr>
-          <p:cNvPr id="6" name="Slide Number Placeholder"/>
+          <p:cNvPr id="5" name="Slide Number Placeholder"/>
           <p:cNvSpPr>
             <a:spLocks noGrp="1"/>
           </p:cNvSpPr>
@@ -19276,7 +19345,7 @@
             </a:pPr>
             <a:r>
               <a:rPr/>
-              <a:t>Automating the build</a:t>
+              <a:t>Disposable/nonpersistent virtual machine</a:t>
             </a:r>
           </a:p>
         </p:txBody>
@@ -19288,7 +19357,7 @@
             <a:spLocks noGrp="1"/>
           </p:cNvSpPr>
           <p:nvPr>
-            <p:ph idx="1"/>
+            <p:ph idx="1" sz="half"/>
           </p:nvPr>
         </p:nvSpPr>
         <p:spPr/>
@@ -19296,51 +19365,86 @@
           <a:bodyPr/>
           <a:lstStyle/>
           <a:p>
+            <a:pPr lvl="0" indent="0" marL="0">
+              <a:buNone/>
+            </a:pPr>
+            <a:r>
+              <a:rPr b="1"/>
+              <a:t>Return the machine to a known state</a:t>
+            </a:r>
+          </a:p>
+          <a:p>
             <a:pPr lvl="0"/>
             <a:r>
               <a:rPr/>
-              <a:t>Decide on the Windows image and tool list</a:t>
+              <a:t>VMware Workstation Pro</a:t>
             </a:r>
           </a:p>
           <a:p>
             <a:pPr lvl="0"/>
             <a:r>
               <a:rPr/>
-              <a:t>Make setup repeatable rather than configuring it by hand each time</a:t>
+              <a:t>System disk: independent, non-persistent</a:t>
             </a:r>
           </a:p>
           <a:p>
             <a:pPr lvl="0"/>
             <a:r>
               <a:rPr/>
-              <a:t>Script it with </a:t>
-            </a:r>
-            <a:r>
-              <a:rPr>
-                <a:latin typeface="Consolas"/>
-              </a:rPr>
-              <a:t>-WhatIf</a:t>
-            </a:r>
-            <a:r>
-              <a:rPr/>
-              <a:t> and </a:t>
-            </a:r>
-            <a:r>
-              <a:rPr>
-                <a:latin typeface="Consolas"/>
-              </a:rPr>
-              <a:t>-Verbose</a:t>
-            </a:r>
-            <a:r>
-              <a:rPr/>
-              <a:t>, keep the tool list in a data file</a:t>
-            </a:r>
-          </a:p>
-        </p:txBody>
-      </p:sp>
-      <p:sp>
-        <p:nvSpPr>
-          <p:cNvPr id="4" name="Footer Placeholder"/>
+              <a:t>Power off, and every change is gone</a:t>
+            </a:r>
+          </a:p>
+        </p:txBody>
+      </p:sp>
+      <p:sp>
+        <p:nvSpPr>
+          <p:cNvPr id="4" name="Content Placeholder 4"/>
+          <p:cNvSpPr>
+            <a:spLocks noGrp="1"/>
+          </p:cNvSpPr>
+          <p:nvPr>
+            <p:ph idx="2" sz="half"/>
+          </p:nvPr>
+        </p:nvSpPr>
+        <p:spPr/>
+        <p:txBody>
+          <a:bodyPr/>
+          <a:lstStyle/>
+          <a:p>
+            <a:pPr lvl="0" indent="0" marL="0">
+              <a:buNone/>
+            </a:pPr>
+            <a:r>
+              <a:rPr b="1"/>
+              <a:t>Keep case data and analysis output separate from what gets reset</a:t>
+            </a:r>
+          </a:p>
+          <a:p>
+            <a:pPr lvl="0"/>
+            <a:r>
+              <a:rPr/>
+              <a:t>Shared Folders on the host</a:t>
+            </a:r>
+          </a:p>
+          <a:p>
+            <a:pPr lvl="0"/>
+            <a:r>
+              <a:rPr/>
+              <a:t>Evidence: read-only</a:t>
+            </a:r>
+          </a:p>
+          <a:p>
+            <a:pPr lvl="0"/>
+            <a:r>
+              <a:rPr/>
+              <a:t>Cases (output, logs, notes): read-write</a:t>
+            </a:r>
+          </a:p>
+        </p:txBody>
+      </p:sp>
+      <p:sp>
+        <p:nvSpPr>
+          <p:cNvPr id="5" name="Footer Placeholder"/>
           <p:cNvSpPr>
             <a:spLocks noGrp="1"/>
           </p:cNvSpPr>
@@ -19382,7 +19486,7 @@
       </p:sp>
       <p:sp>
         <p:nvSpPr>
-          <p:cNvPr id="5" name="Slide Number Placeholder"/>
+          <p:cNvPr id="6" name="Slide Number Placeholder"/>
           <p:cNvSpPr>
             <a:spLocks noGrp="1"/>
           </p:cNvSpPr>
@@ -19473,7 +19577,7 @@
             </a:pPr>
             <a:r>
               <a:rPr/>
-              <a:t>Configuring Windows for analysis</a:t>
+              <a:t>Automating the build</a:t>
             </a:r>
           </a:p>
         </p:txBody>
@@ -19496,35 +19600,28 @@
             <a:pPr lvl="0"/>
             <a:r>
               <a:rPr/>
-              <a:t>Tools that need to run as administrator</a:t>
+              <a:t>Decide on the Windows image and tool list</a:t>
+            </a:r>
+          </a:p>
+          <a:p>
+            <a:pPr lvl="1"/>
+            <a:r>
+              <a:rPr/>
+              <a:t>Windows Server 2025: stable, Defender is a removable feature, no TPM needed</a:t>
             </a:r>
           </a:p>
           <a:p>
             <a:pPr lvl="0"/>
             <a:r>
               <a:rPr/>
-              <a:t>UAC: normally I don’t disable security features, but this is a disposable VM and reducing friction matters</a:t>
-            </a:r>
-          </a:p>
-          <a:p>
-            <a:pPr lvl="0"/>
-            <a:r>
-              <a:rPr/>
-              <a:t>Other Windows security settings as decisions specific to this machine, not general recommendations</a:t>
+              <a:t>Make setup repeatable rather than configuring it by hand each time</a:t>
             </a:r>
           </a:p>
           <a:p>
             <a:pPr lvl="1"/>
             <a:r>
               <a:rPr/>
-              <a:t>Defender scanning evidence and tools</a:t>
-            </a:r>
-          </a:p>
-          <a:p>
-            <a:pPr lvl="1"/>
-            <a:r>
-              <a:rPr/>
-              <a:t>Network access</a:t>
+              <a:t>An unattend file: schneegans.de/windows/unattend-generator</a:t>
             </a:r>
           </a:p>
         </p:txBody>
@@ -19664,7 +19761,7 @@
             </a:pPr>
             <a:r>
               <a:rPr/>
-              <a:t>Tools for analysis</a:t>
+              <a:t>Configuring Windows for analysis</a:t>
             </a:r>
           </a:p>
         </p:txBody>
@@ -19687,28 +19784,35 @@
             <a:pPr lvl="0"/>
             <a:r>
               <a:rPr/>
-              <a:t>Select the tools and versions</a:t>
+              <a:t>Tools that need to run as administrator</a:t>
             </a:r>
           </a:p>
           <a:p>
             <a:pPr lvl="0"/>
             <a:r>
               <a:rPr/>
-              <a:t>KAPE modules for processing already-collected artifacts</a:t>
+              <a:t>UAC: normally I don’t disable security features, but this is a disposable VM and reducing friction matters</a:t>
+            </a:r>
+          </a:p>
+          <a:p>
+            <a:pPr lvl="0"/>
+            <a:r>
+              <a:rPr/>
+              <a:t>Other Windows security settings as decisions specific to this machine, not general recommendations</a:t>
             </a:r>
           </a:p>
           <a:p>
             <a:pPr lvl="1"/>
             <a:r>
               <a:rPr/>
-              <a:t>Targets collect; modules process what was collected</a:t>
-            </a:r>
-          </a:p>
-          <a:p>
-            <a:pPr lvl="0"/>
-            <a:r>
-              <a:rPr/>
-              <a:t>Record the version of every tool used in the case notes</a:t>
+              <a:t>Defender removed, long paths on</a:t>
+            </a:r>
+          </a:p>
+          <a:p>
+            <a:pPr lvl="1"/>
+            <a:r>
+              <a:rPr/>
+              <a:t>File extensions and hidden files shown</a:t>
             </a:r>
           </a:p>
         </p:txBody>
@@ -19848,7 +19952,7 @@
             </a:pPr>
             <a:r>
               <a:rPr/>
-              <a:t>Using and resetting the box</a:t>
+              <a:t>Tools for analysis</a:t>
             </a:r>
           </a:p>
         </p:txBody>
@@ -19871,21 +19975,74 @@
             <a:pPr lvl="0"/>
             <a:r>
               <a:rPr/>
-              <a:t>Run tools against existing artifacts</a:t>
+              <a:t>Select the tools and versions</a:t>
+            </a:r>
+          </a:p>
+          <a:p>
+            <a:pPr lvl="1"/>
+            <a:r>
+              <a:rPr/>
+              <a:t>Eric Zimmerman’s tools, KAPE, FTK Imager, Volatility 3, plaso</a:t>
+            </a:r>
+          </a:p>
+          <a:p>
+            <a:pPr lvl="1"/>
+            <a:r>
+              <a:rPr/>
+              <a:t>Chainsaw, Hayabusa, Autopsy, Office if licensed</a:t>
             </a:r>
           </a:p>
           <a:p>
             <a:pPr lvl="0"/>
             <a:r>
               <a:rPr/>
-              <a:t>Retain the results and relevant logs</a:t>
+              <a:t>Chocolatey installs most of them in one line</a:t>
             </a:r>
           </a:p>
           <a:p>
             <a:pPr lvl="0"/>
             <a:r>
               <a:rPr/>
-              <a:t>Verify the environment and reset it for the next case</a:t>
+              <a:t>KAPE modules for processing already-collected artifacts</a:t>
+            </a:r>
+          </a:p>
+          <a:p>
+            <a:pPr lvl="1"/>
+            <a:r>
+              <a:rPr/>
+              <a:t>Targets collect; modules process what was collected</a:t>
+            </a:r>
+          </a:p>
+          <a:p>
+            <a:pPr lvl="0" indent="0">
+              <a:buNone/>
+            </a:pPr>
+            <a:r>
+              <a:rPr>
+                <a:solidFill>
+                  <a:srgbClr val="1A1D23"/>
+                </a:solidFill>
+                <a:latin typeface="Consolas"/>
+              </a:rPr>
+              <a:t>choco install </a:t>
+            </a:r>
+            <a:r>
+              <a:rPr>
+                <a:solidFill>
+                  <a:srgbClr val="5A6472"/>
+                </a:solidFill>
+                <a:latin typeface="Consolas"/>
+              </a:rPr>
+              <a:t>-</a:t>
+            </a:r>
+            <a:r>
+              <a:rPr>
+                <a:solidFill>
+                  <a:srgbClr val="1A1D23"/>
+                </a:solidFill>
+                <a:latin typeface="Consolas"/>
+              </a:rPr>
+              <a:t>y ericzimmermantools volatility3 autopsy</a:t>
             </a:r>
           </a:p>
         </p:txBody>
@@ -20009,8 +20166,8 @@
         </p:nvSpPr>
         <p:spPr>
           <a:xfrm>
-            <a:off x="548640" y="1828800"/>
-            <a:ext cx="6766560" cy="2377440"/>
+            <a:off x="548640" y="347472"/>
+            <a:ext cx="11094720" cy="841248"/>
           </a:xfrm>
           <a:prstGeom prst="rect">
             <a:avLst/>
@@ -20025,14 +20182,51 @@
             </a:pPr>
             <a:r>
               <a:rPr/>
-              <a:t>Questions?</a:t>
-            </a:r>
-          </a:p>
-        </p:txBody>
-      </p:sp>
-      <p:sp>
-        <p:nvSpPr>
-          <p:cNvPr id="5" name="Footer Placeholder"/>
+              <a:t>Using and resetting the box</a:t>
+            </a:r>
+          </a:p>
+        </p:txBody>
+      </p:sp>
+      <p:sp>
+        <p:nvSpPr>
+          <p:cNvPr id="3" name="Content Placeholder 3"/>
+          <p:cNvSpPr>
+            <a:spLocks noGrp="1"/>
+          </p:cNvSpPr>
+          <p:nvPr>
+            <p:ph idx="1"/>
+          </p:nvPr>
+        </p:nvSpPr>
+        <p:spPr/>
+        <p:txBody>
+          <a:bodyPr/>
+          <a:lstStyle/>
+          <a:p>
+            <a:pPr lvl="0"/>
+            <a:r>
+              <a:rPr/>
+              <a:t>Run tools against existing artifacts</a:t>
+            </a:r>
+          </a:p>
+          <a:p>
+            <a:pPr lvl="0"/>
+            <a:r>
+              <a:rPr/>
+              <a:t>Retain the results and relevant logs</a:t>
+            </a:r>
+          </a:p>
+          <a:p>
+            <a:pPr lvl="0"/>
+            <a:r>
+              <a:rPr/>
+              <a:t>Verify the environment and reset it for the next case</a:t>
+            </a:r>
+          </a:p>
+        </p:txBody>
+      </p:sp>
+      <p:sp>
+        <p:nvSpPr>
+          <p:cNvPr id="4" name="Footer Placeholder"/>
           <p:cNvSpPr>
             <a:spLocks noGrp="1"/>
           </p:cNvSpPr>
@@ -20058,7 +20252,7 @@
               <a:buNone/>
               <a:defRPr spc="10" sz="1000">
                 <a:solidFill>
-                  <a:srgbClr val="8DA2BE"/>
+                  <a:srgbClr val="5A6472"/>
                 </a:solidFill>
                 <a:latin typeface="+mn-lt"/>
               </a:defRPr>
@@ -20074,7 +20268,7 @@
       </p:sp>
       <p:sp>
         <p:nvSpPr>
-          <p:cNvPr id="6" name="Slide Number Placeholder"/>
+          <p:cNvPr id="5" name="Slide Number Placeholder"/>
           <p:cNvSpPr>
             <a:spLocks noGrp="1"/>
           </p:cNvSpPr>
@@ -20100,7 +20294,7 @@
               <a:buNone/>
               <a:defRPr spc="10" sz="1000">
                 <a:solidFill>
-                  <a:srgbClr val="8DA2BE"/>
+                  <a:srgbClr val="5A6472"/>
                 </a:solidFill>
                 <a:latin typeface="+mn-lt"/>
               </a:defRPr>
@@ -20165,7 +20359,7 @@
             </a:pPr>
             <a:r>
               <a:rPr/>
-              <a:t>Wrap-Up</a:t>
+              <a:t>Questions?</a:t>
             </a:r>
           </a:p>
         </p:txBody>
@@ -20289,8 +20483,8 @@
         </p:nvSpPr>
         <p:spPr>
           <a:xfrm>
-            <a:off x="548640" y="347472"/>
-            <a:ext cx="11094720" cy="841248"/>
+            <a:off x="548640" y="1828800"/>
+            <a:ext cx="6766560" cy="2377440"/>
           </a:xfrm>
           <a:prstGeom prst="rect">
             <a:avLst/>
@@ -20305,95 +20499,14 @@
             </a:pPr>
             <a:r>
               <a:rPr/>
-              <a:t>Key takeaways</a:t>
-            </a:r>
-          </a:p>
-        </p:txBody>
-      </p:sp>
-      <p:sp>
-        <p:nvSpPr>
-          <p:cNvPr id="3" name="Content Placeholder 3"/>
-          <p:cNvSpPr>
-            <a:spLocks noGrp="1"/>
-          </p:cNvSpPr>
-          <p:nvPr>
-            <p:ph idx="1"/>
-          </p:nvPr>
-        </p:nvSpPr>
-        <p:spPr/>
-        <p:txBody>
-          <a:bodyPr/>
-          <a:lstStyle/>
-          <a:p>
-            <a:pPr lvl="0"/>
-            <a:r>
-              <a:rPr b="1"/>
-              <a:t>Passwords:</a:t>
-            </a:r>
-            <a:r>
-              <a:rPr/>
-              <a:t> unique, long, checked against breaches, with MFA</a:t>
-            </a:r>
-          </a:p>
-          <a:p>
-            <a:pPr lvl="0"/>
-            <a:r>
-              <a:rPr b="1"/>
-              <a:t>PKI:</a:t>
-            </a:r>
-            <a:r>
-              <a:rPr/>
-              <a:t> a certificate binds a key to a name; validation checks name, dates, chain, trust and usage</a:t>
-            </a:r>
-          </a:p>
-          <a:p>
-            <a:pPr lvl="0"/>
-            <a:r>
-              <a:rPr b="1"/>
-              <a:t>Email:</a:t>
-            </a:r>
-            <a:r>
-              <a:rPr/>
-              <a:t> DMARC starts with the </a:t>
-            </a:r>
-            <a:r>
-              <a:rPr>
-                <a:latin typeface="Consolas"/>
-              </a:rPr>
-              <a:t>From</a:t>
-            </a:r>
-            <a:r>
-              <a:rPr/>
-              <a:t> domain and needs an aligned pass</a:t>
-            </a:r>
-          </a:p>
-          <a:p>
-            <a:pPr lvl="0"/>
-            <a:r>
-              <a:rPr b="1"/>
-              <a:t>PowerShell:</a:t>
-            </a:r>
-            <a:r>
-              <a:rPr/>
-              <a:t> objects in a pipeline turn a task into something repeatable</a:t>
-            </a:r>
-          </a:p>
-          <a:p>
-            <a:pPr lvl="0"/>
-            <a:r>
-              <a:rPr b="1"/>
-              <a:t>DFIR box:</a:t>
-            </a:r>
-            <a:r>
-              <a:rPr/>
-              <a:t> a disposable analysis VM with case data kept elsewhere</a:t>
-            </a:r>
-          </a:p>
-        </p:txBody>
-      </p:sp>
-      <p:sp>
-        <p:nvSpPr>
-          <p:cNvPr id="4" name="Footer Placeholder"/>
+              <a:t>Wrap-Up</a:t>
+            </a:r>
+          </a:p>
+        </p:txBody>
+      </p:sp>
+      <p:sp>
+        <p:nvSpPr>
+          <p:cNvPr id="5" name="Footer Placeholder"/>
           <p:cNvSpPr>
             <a:spLocks noGrp="1"/>
           </p:cNvSpPr>
@@ -20419,7 +20532,7 @@
               <a:buNone/>
               <a:defRPr spc="10" sz="1000">
                 <a:solidFill>
-                  <a:srgbClr val="5A6472"/>
+                  <a:srgbClr val="8DA2BE"/>
                 </a:solidFill>
                 <a:latin typeface="+mn-lt"/>
               </a:defRPr>
@@ -20435,7 +20548,7 @@
       </p:sp>
       <p:sp>
         <p:nvSpPr>
-          <p:cNvPr id="5" name="Slide Number Placeholder"/>
+          <p:cNvPr id="6" name="Slide Number Placeholder"/>
           <p:cNvSpPr>
             <a:spLocks noGrp="1"/>
           </p:cNvSpPr>
@@ -20461,7 +20574,7 @@
               <a:buNone/>
               <a:defRPr spc="10" sz="1000">
                 <a:solidFill>
-                  <a:srgbClr val="5A6472"/>
+                  <a:srgbClr val="8DA2BE"/>
                 </a:solidFill>
                 <a:latin typeface="+mn-lt"/>
               </a:defRPr>
@@ -20526,7 +20639,7 @@
             </a:pPr>
             <a:r>
               <a:rPr/>
-              <a:t>References</a:t>
+              <a:t>Key takeaways</a:t>
             </a:r>
           </a:p>
         </p:txBody>
@@ -20548,45 +20661,66 @@
           <a:p>
             <a:pPr lvl="0"/>
             <a:r>
-              <a:rPr/>
-              <a:t>NIST SP 800-63B-4: pages.nist.gov/800-63-4/sp800-63b.html</a:t>
+              <a:rPr b="1"/>
+              <a:t>Passwords:</a:t>
+            </a:r>
+            <a:r>
+              <a:rPr/>
+              <a:t> unique, long, checked against breaches, with MFA</a:t>
             </a:r>
           </a:p>
           <a:p>
             <a:pPr lvl="0"/>
             <a:r>
-              <a:rPr/>
-              <a:t>RFC 5280, RFC 9525, RFC 2986, RFC 8555 (PKI)</a:t>
+              <a:rPr b="1"/>
+              <a:t>PKI:</a:t>
+            </a:r>
+            <a:r>
+              <a:rPr/>
+              <a:t> a certificate binds a key to a name; validation checks name, dates, chain, trust and usage</a:t>
             </a:r>
           </a:p>
           <a:p>
             <a:pPr lvl="0"/>
             <a:r>
-              <a:rPr/>
-              <a:t>RFC 5321, RFC 5322, RFC 7208, RFC 6376, RFC 9989, RFC 9990, RFC 9991 (email)</a:t>
+              <a:rPr b="1"/>
+              <a:t>Email:</a:t>
+            </a:r>
+            <a:r>
+              <a:rPr/>
+              <a:t> DMARC starts with the </a:t>
+            </a:r>
+            <a:r>
+              <a:rPr>
+                <a:latin typeface="Consolas"/>
+              </a:rPr>
+              <a:t>From</a:t>
+            </a:r>
+            <a:r>
+              <a:rPr/>
+              <a:t> domain and needs an aligned pass</a:t>
             </a:r>
           </a:p>
           <a:p>
             <a:pPr lvl="0"/>
             <a:r>
-              <a:rPr/>
-              <a:t>Microsoft Learn: about_Pipelines, Get-WinEvent, Export-Csv</a:t>
+              <a:rPr b="1"/>
+              <a:t>PowerShell:</a:t>
+            </a:r>
+            <a:r>
+              <a:rPr/>
+              <a:t> objects in a pipeline turn a task into something repeatable</a:t>
             </a:r>
           </a:p>
           <a:p>
             <a:pPr lvl="0"/>
             <a:r>
-              <a:rPr/>
-              <a:t>Full list with links on the companion site</a:t>
-            </a:r>
-          </a:p>
-          <a:p>
-            <a:pPr lvl="0" indent="0" marL="0">
-              <a:buNone/>
-            </a:pPr>
-            <a:r>
               <a:rPr b="1"/>
-              <a:t>dzampino.github.io/crt-essentials-2026</a:t>
+              <a:t>DFIR box:</a:t>
+            </a:r>
+            <a:r>
+              <a:rPr/>
+              <a:t> a disposable analysis VM with case data kept elsewhere</a:t>
             </a:r>
           </a:p>
         </p:txBody>
@@ -20916,6 +21050,206 @@
         </p:nvSpPr>
         <p:spPr>
           <a:xfrm>
+            <a:off x="548640" y="347472"/>
+            <a:ext cx="11094720" cy="841248"/>
+          </a:xfrm>
+          <a:prstGeom prst="rect">
+            <a:avLst/>
+          </a:prstGeom>
+        </p:spPr>
+        <p:txBody>
+          <a:bodyPr/>
+          <a:lstStyle/>
+          <a:p>
+            <a:pPr lvl="0" indent="0" marL="0">
+              <a:buNone/>
+            </a:pPr>
+            <a:r>
+              <a:rPr/>
+              <a:t>References</a:t>
+            </a:r>
+          </a:p>
+        </p:txBody>
+      </p:sp>
+      <p:sp>
+        <p:nvSpPr>
+          <p:cNvPr id="3" name="Content Placeholder 3"/>
+          <p:cNvSpPr>
+            <a:spLocks noGrp="1"/>
+          </p:cNvSpPr>
+          <p:nvPr>
+            <p:ph idx="1"/>
+          </p:nvPr>
+        </p:nvSpPr>
+        <p:spPr/>
+        <p:txBody>
+          <a:bodyPr/>
+          <a:lstStyle/>
+          <a:p>
+            <a:pPr lvl="0"/>
+            <a:r>
+              <a:rPr/>
+              <a:t>NIST SP 800-63B-4: pages.nist.gov/800-63-4/sp800-63b.html</a:t>
+            </a:r>
+          </a:p>
+          <a:p>
+            <a:pPr lvl="0"/>
+            <a:r>
+              <a:rPr/>
+              <a:t>RFC 5280, RFC 9525, RFC 2986, RFC 8555 (PKI)</a:t>
+            </a:r>
+          </a:p>
+          <a:p>
+            <a:pPr lvl="0"/>
+            <a:r>
+              <a:rPr/>
+              <a:t>RFC 5321, RFC 6409, RFC 5322, RFC 7208, RFC 6376, RFC 9989, RFC 9990, RFC 9991 (email)</a:t>
+            </a:r>
+          </a:p>
+          <a:p>
+            <a:pPr lvl="0"/>
+            <a:r>
+              <a:rPr/>
+              <a:t>Microsoft Learn: about_Pipelines, about_Modules, Get-WinEvent, Export-Csv</a:t>
+            </a:r>
+          </a:p>
+          <a:p>
+            <a:pPr lvl="0"/>
+            <a:r>
+              <a:rPr/>
+              <a:t>Full list with links on the companion site</a:t>
+            </a:r>
+          </a:p>
+          <a:p>
+            <a:pPr lvl="0" indent="0" marL="0">
+              <a:buNone/>
+            </a:pPr>
+            <a:r>
+              <a:rPr b="1"/>
+              <a:t>dzampino.github.io/crt-essentials-2026</a:t>
+            </a:r>
+          </a:p>
+        </p:txBody>
+      </p:sp>
+      <p:sp>
+        <p:nvSpPr>
+          <p:cNvPr id="4" name="Footer Placeholder"/>
+          <p:cNvSpPr>
+            <a:spLocks noGrp="1"/>
+          </p:cNvSpPr>
+          <p:nvPr>
+            <p:ph idx="11" sz="quarter" type="ftr"/>
+          </p:nvPr>
+        </p:nvSpPr>
+        <p:spPr>
+          <a:xfrm>
+            <a:off x="1005840" y="6345936"/>
+            <a:ext cx="6949440" cy="274320"/>
+          </a:xfrm>
+          <a:prstGeom prst="rect">
+            <a:avLst/>
+          </a:prstGeom>
+        </p:spPr>
+        <p:txBody>
+          <a:bodyPr anchor="ctr" bIns="0" lIns="0" rIns="0" rtlCol="0" tIns="0" vert="horz" wrap="square">
+            <a:noAutofit/>
+          </a:bodyPr>
+          <a:lstStyle>
+            <a:lvl1pPr algn="l" indent="0" marL="0">
+              <a:buNone/>
+              <a:defRPr spc="10" sz="1000">
+                <a:solidFill>
+                  <a:srgbClr val="5A6472"/>
+                </a:solidFill>
+                <a:latin typeface="+mn-lt"/>
+              </a:defRPr>
+            </a:lvl1pPr>
+          </a:lstStyle>
+          <a:p>
+            <a:r>
+              <a:rPr lang="en-US"/>
+              <a:t>CRT Annual Training Conference 2026</a:t>
+            </a:r>
+          </a:p>
+        </p:txBody>
+      </p:sp>
+      <p:sp>
+        <p:nvSpPr>
+          <p:cNvPr id="5" name="Slide Number Placeholder"/>
+          <p:cNvSpPr>
+            <a:spLocks noGrp="1"/>
+          </p:cNvSpPr>
+          <p:nvPr>
+            <p:ph idx="12" sz="quarter" type="sldNum"/>
+          </p:nvPr>
+        </p:nvSpPr>
+        <p:spPr>
+          <a:xfrm>
+            <a:off x="11186160" y="6345936"/>
+            <a:ext cx="457200" cy="274320"/>
+          </a:xfrm>
+          <a:prstGeom prst="rect">
+            <a:avLst/>
+          </a:prstGeom>
+        </p:spPr>
+        <p:txBody>
+          <a:bodyPr anchor="ctr" bIns="0" lIns="0" rIns="0" rtlCol="0" tIns="0" vert="horz" wrap="square">
+            <a:noAutofit/>
+          </a:bodyPr>
+          <a:lstStyle>
+            <a:lvl1pPr algn="r" indent="0" marL="0">
+              <a:buNone/>
+              <a:defRPr spc="10" sz="1000">
+                <a:solidFill>
+                  <a:srgbClr val="5A6472"/>
+                </a:solidFill>
+                <a:latin typeface="+mn-lt"/>
+              </a:defRPr>
+            </a:lvl1pPr>
+          </a:lstStyle>
+          <a:p>
+            <a:fld id="{8A1C2F2E-3D4B-4C6E-9F10-2B7A5C9E1D01}" type="slidenum">
+              <a:rPr lang="en-US"/>
+              <a:t>‹#›</a:t>
+            </a:fld>
+            <a:endParaRPr lang="en-US"/>
+          </a:p>
+        </p:txBody>
+      </p:sp>
+    </p:spTree>
+  </p:cSld>
+</p:sld>
+</file>
+
+<file path=ppt/slides/slide61.xml><?xml version="1.0" encoding="utf-8"?>
+<p:sld xmlns:a="http://schemas.openxmlformats.org/drawingml/2006/main" xmlns:r="http://schemas.openxmlformats.org/officeDocument/2006/relationships" xmlns:p="http://schemas.openxmlformats.org/presentationml/2006/main">
+  <p:cSld>
+    <p:spTree>
+      <p:nvGrpSpPr>
+        <p:cNvPr id="1" name=""/>
+        <p:cNvGrpSpPr/>
+        <p:nvPr/>
+      </p:nvGrpSpPr>
+      <p:grpSpPr>
+        <a:xfrm>
+          <a:off x="0" y="0"/>
+          <a:ext cx="0" cy="0"/>
+          <a:chOff x="0" y="0"/>
+          <a:chExt cx="0" cy="0"/>
+        </a:xfrm>
+      </p:grpSpPr>
+      <p:sp>
+        <p:nvSpPr>
+          <p:cNvPr id="2" name="Title 1"/>
+          <p:cNvSpPr>
+            <a:spLocks noGrp="1"/>
+          </p:cNvSpPr>
+          <p:nvPr>
+            <p:ph type="title"/>
+          </p:nvPr>
+        </p:nvSpPr>
+        <p:spPr>
+          <a:xfrm>
             <a:off x="548640" y="1828800"/>
             <a:ext cx="6766560" cy="2377440"/>
           </a:xfrm>
@@ -21284,7 +21618,11 @@
             <a:pPr lvl="0"/>
             <a:r>
               <a:rPr/>
-              <a:t>Search space = alphabet ^ length</a:t>
+              <a:t>Search space = alphabet</a:t>
+            </a:r>
+            <a:r>
+              <a:rPr baseline="30000"/>
+              <a:t>length</a:t>
             </a:r>
           </a:p>
         </p:txBody>

</xml_diff>

<commit_message>
Open decisions answered; entropy chart rescales; no module download; deck-only subtitle
- Speaker note placeholders removed, short notes added; slide image alt text
  set from image titles (build.ps1 strips the path Pandoc appends)
- Timing confirmed; KAPE free for CRT members; unattend for Server 2025 needs
  a product key and image selection; no version pinning, VM offline in cases
- Certificate-chain diagram uses squeakycurds.example
- Entropy chart: x covers the length slider, y scales to fit, no 128-bit clamp
- CrtEssentials zip and .psm1 removed; functions are scripts/*.ps1 starting points
- Slide 2: URL as title with QR code, description dropped
- Deck subtitle removed from site, README, outline and AGENTS.md

Co-Authored-By: Claude Opus 5.5 <noreply@anthropic.com>
</commit_message>
<xml_diff>
--- a/docs/files/crt-essentials.pptx
+++ b/docs/files/crt-essentials.pptx
@@ -666,7 +666,7 @@
             </a:pPr>
             <a:r>
               <a:rPr/>
-              <a:t>RFC 5280, Internet X.509 PKI Certificate and CRL Profile: https://www.rfc-editor.org/rfc/rfc5280.html</a:t>
+              <a:t>NIST SP 800-63B-4 section 3.1.1.2: minimum 15 characters when a password is used as a single-factor authenticator, 8 when used only as part of MFA; support at least 64 characters; compare against a blocklist; SHALL NOT impose other composition rules; SHALL NOT require periodic changes, but force a change on evidence of compromise. https://pages.nist.gov/800-63-4/sp800-63b.html Have I Been Pwned, Pwned Passwords: https://haveibeenpwned.com/Passwords</a:t>
             </a:r>
           </a:p>
         </p:txBody>
@@ -688,7 +688,7 @@
           <a:p>
             <a:fld id="{18BDFEC3-8487-43E8-A154-7C12CBC1FFF2}" type="slidenum">
               <a:rPr lang="en-US"/>
-              <a:t>15</a:t>
+              <a:t>12</a:t>
             </a:fld>
             <a:endParaRPr lang="en-US"/>
           </a:p>
@@ -748,21 +748,7 @@
             </a:pPr>
             <a:r>
               <a:rPr/>
-              <a:t>RFC 5280 section 4.1 (fields) and 4.2 (extensions).</a:t>
-            </a:r>
-          </a:p>
-          <a:p>
-            <a:pPr lvl="0" indent="0" marL="0">
-              <a:buNone/>
-            </a:pPr>
-          </a:p>
-          <a:p>
-            <a:pPr lvl="0" indent="0" marL="0">
-              <a:buNone/>
-            </a:pPr>
-            <a:r>
-              <a:rPr/>
-              <a:t>RFC 9525 section 2: “The Common Name RDN MUST NOT be used to identify a service.” Names are matched against the SAN. https://www.rfc-editor.org/rfc/rfc9525.html</a:t>
+              <a:t>RFC 5280, Internet X.509 PKI Certificate and CRL Profile: https://www.rfc-editor.org/rfc/rfc5280.html</a:t>
             </a:r>
           </a:p>
         </p:txBody>
@@ -784,7 +770,7 @@
           <a:p>
             <a:fld id="{18BDFEC3-8487-43E8-A154-7C12CBC1FFF2}" type="slidenum">
               <a:rPr lang="en-US"/>
-              <a:t>16</a:t>
+              <a:t>15</a:t>
             </a:fld>
             <a:endParaRPr lang="en-US"/>
           </a:p>
@@ -844,7 +830,7 @@
             </a:pPr>
             <a:r>
               <a:rPr/>
-              <a:t>Inspect it with openssl x509, certutil -dump or XCA.</a:t>
+              <a:t>RFC 5280 section 4.1 (fields) and 4.2 (extensions).</a:t>
             </a:r>
           </a:p>
           <a:p>
@@ -858,35 +844,7 @@
             </a:pPr>
             <a:r>
               <a:rPr/>
-              <a:t>Output trimmed and condensed from: openssl x509 -in training-leaf.pem -noout -text (OpenSSL 3.5). The full subject also has ST=Wisconsin, C=US.</a:t>
-            </a:r>
-          </a:p>
-          <a:p>
-            <a:pPr lvl="0" indent="0" marL="0">
-              <a:buNone/>
-            </a:pPr>
-          </a:p>
-          <a:p>
-            <a:pPr lvl="0" indent="0" marL="0">
-              <a:buNone/>
-            </a:pPr>
-            <a:r>
-              <a:rPr/>
-              <a:t>Fictional training certificates for the fictional Squeaky Curds Co-op; .example is reserved (RFC 2606), so the names do not exist. No private keys are included. Do not install the training root.</a:t>
-            </a:r>
-          </a:p>
-          <a:p>
-            <a:pPr lvl="0" indent="0" marL="0">
-              <a:buNone/>
-            </a:pPr>
-          </a:p>
-          <a:p>
-            <a:pPr lvl="0" indent="0" marL="0">
-              <a:buNone/>
-            </a:pPr>
-            <a:r>
-              <a:rPr/>
-              <a:t>XCA, a graphical certificate and key manager: https://hohnstaedt.de/xca/</a:t>
+              <a:t>RFC 9525 section 2: “The Common Name RDN MUST NOT be used to identify a service.” Names are matched against the SAN. https://www.rfc-editor.org/rfc/rfc9525.html</a:t>
             </a:r>
           </a:p>
         </p:txBody>
@@ -908,7 +866,7 @@
           <a:p>
             <a:fld id="{18BDFEC3-8487-43E8-A154-7C12CBC1FFF2}" type="slidenum">
               <a:rPr lang="en-US"/>
-              <a:t>17</a:t>
+              <a:t>16</a:t>
             </a:fld>
             <a:endParaRPr lang="en-US"/>
           </a:p>
@@ -968,7 +926,7 @@
             </a:pPr>
             <a:r>
               <a:rPr/>
-              <a:t>The training sample is a two-level chain: the root signs the leaf directly. Public CAs issue from intermediates.</a:t>
+              <a:t>Inspect it with openssl x509, certutil -dump or XCA.</a:t>
             </a:r>
           </a:p>
           <a:p>
@@ -982,7 +940,35 @@
             </a:pPr>
             <a:r>
               <a:rPr/>
-              <a:t>RFC 5280 section 6 (certification path validation).</a:t>
+              <a:t>Output trimmed and condensed from: openssl x509 -in training-leaf.pem -noout -text (OpenSSL 3.5). The full subject also has ST=Wisconsin, C=US.</a:t>
+            </a:r>
+          </a:p>
+          <a:p>
+            <a:pPr lvl="0" indent="0" marL="0">
+              <a:buNone/>
+            </a:pPr>
+          </a:p>
+          <a:p>
+            <a:pPr lvl="0" indent="0" marL="0">
+              <a:buNone/>
+            </a:pPr>
+            <a:r>
+              <a:rPr/>
+              <a:t>Fictional training certificates for the fictional Squeaky Curds Co-op; .example is reserved (RFC 2606), so the names do not exist. No private keys are included. Do not install the training root.</a:t>
+            </a:r>
+          </a:p>
+          <a:p>
+            <a:pPr lvl="0" indent="0" marL="0">
+              <a:buNone/>
+            </a:pPr>
+          </a:p>
+          <a:p>
+            <a:pPr lvl="0" indent="0" marL="0">
+              <a:buNone/>
+            </a:pPr>
+            <a:r>
+              <a:rPr/>
+              <a:t>XCA, a graphical certificate and key manager: https://hohnstaedt.de/xca/</a:t>
             </a:r>
           </a:p>
         </p:txBody>
@@ -1004,7 +990,7 @@
           <a:p>
             <a:fld id="{18BDFEC3-8487-43E8-A154-7C12CBC1FFF2}" type="slidenum">
               <a:rPr lang="en-US"/>
-              <a:t>18</a:t>
+              <a:t>17</a:t>
             </a:fld>
             <a:endParaRPr lang="en-US"/>
           </a:p>
@@ -1064,7 +1050,7 @@
             </a:pPr>
             <a:r>
               <a:rPr/>
-              <a:t>RFC 7468 (PEM textual encodings), RFC 7292 (PKCS #12), RFC 5652 (CMS, the basis of .p7b), RFC 2986 (PKCS #10).</a:t>
+              <a:t>The training sample is a two-level chain: the root signs the leaf directly. Public CAs issue from intermediates.</a:t>
             </a:r>
           </a:p>
           <a:p>
@@ -1078,21 +1064,7 @@
             </a:pPr>
             <a:r>
               <a:rPr/>
-              <a:t>training-leaf.pem and training-leaf.der are the same certificate: both have SHA-256 fingerprint D1:B7:D4:59:…:C0:E5. certutil -dump reads both.</a:t>
-            </a:r>
-          </a:p>
-          <a:p>
-            <a:pPr lvl="0" indent="0" marL="0">
-              <a:buNone/>
-            </a:pPr>
-          </a:p>
-          <a:p>
-            <a:pPr lvl="0" indent="0" marL="0">
-              <a:buNone/>
-            </a:pPr>
-            <a:r>
-              <a:rPr/>
-              <a:t>OpenSSL on Windows: it comes with Git for Windows, or winget install ShiningLight.OpenSSL.Light (other builds: https://github.com/openssl/openssl/wiki/Binaries).</a:t>
+              <a:t>RFC 5280 section 6 (certification path validation).</a:t>
             </a:r>
           </a:p>
         </p:txBody>
@@ -1114,7 +1086,7 @@
           <a:p>
             <a:fld id="{18BDFEC3-8487-43E8-A154-7C12CBC1FFF2}" type="slidenum">
               <a:rPr lang="en-US"/>
-              <a:t>19</a:t>
+              <a:t>18</a:t>
             </a:fld>
             <a:endParaRPr lang="en-US"/>
           </a:p>
@@ -1174,7 +1146,7 @@
             </a:pPr>
             <a:r>
               <a:rPr/>
-              <a:t>RFC 2986 (PKCS #10): https://www.rfc-editor.org/rfc/rfc2986.html certreq: https://learn.microsoft.com/en-us/windows-server/administration/windows-commands/certreq_1 RFC 8555 (ACME): https://www.rfc-editor.org/rfc/rfc8555.html</a:t>
+              <a:t>RFC 7468 (PEM textual encodings), RFC 7292 (PKCS #12), RFC 5652 (CMS, the basis of .p7b), RFC 2986 (PKCS #10).</a:t>
             </a:r>
           </a:p>
           <a:p>
@@ -1188,7 +1160,21 @@
             </a:pPr>
             <a:r>
               <a:rPr/>
-              <a:t>The training CSR’s public key matches the training leaf: openssl req -in training-request.csr -noout -verify reports “Certificate request self-signature verify OK”.</a:t>
+              <a:t>training-leaf.pem and training-leaf.der are the same certificate: both have SHA-256 fingerprint D1:B7:D4:59:…:C0:E5. certutil -dump reads both.</a:t>
+            </a:r>
+          </a:p>
+          <a:p>
+            <a:pPr lvl="0" indent="0" marL="0">
+              <a:buNone/>
+            </a:pPr>
+          </a:p>
+          <a:p>
+            <a:pPr lvl="0" indent="0" marL="0">
+              <a:buNone/>
+            </a:pPr>
+            <a:r>
+              <a:rPr/>
+              <a:t>OpenSSL on Windows: it comes with Git for Windows, or winget install ShiningLight.OpenSSL.Light (other builds: https://github.com/openssl/openssl/wiki/Binaries).</a:t>
             </a:r>
           </a:p>
         </p:txBody>
@@ -1210,7 +1196,7 @@
           <a:p>
             <a:fld id="{18BDFEC3-8487-43E8-A154-7C12CBC1FFF2}" type="slidenum">
               <a:rPr lang="en-US"/>
-              <a:t>20</a:t>
+              <a:t>19</a:t>
             </a:fld>
             <a:endParaRPr lang="en-US"/>
           </a:p>
@@ -1270,7 +1256,21 @@
             </a:pPr>
             <a:r>
               <a:rPr/>
-              <a:t>A common incident-response finding: a missing intermediate works in one browser (which cached or fetched it) and fails in another client.</a:t>
+              <a:t>RFC 2986 (PKCS #10): https://www.rfc-editor.org/rfc/rfc2986.html certreq: https://learn.microsoft.com/en-us/windows-server/administration/windows-commands/certreq_1 RFC 8555 (ACME): https://www.rfc-editor.org/rfc/rfc8555.html</a:t>
+            </a:r>
+          </a:p>
+          <a:p>
+            <a:pPr lvl="0" indent="0" marL="0">
+              <a:buNone/>
+            </a:pPr>
+          </a:p>
+          <a:p>
+            <a:pPr lvl="0" indent="0" marL="0">
+              <a:buNone/>
+            </a:pPr>
+            <a:r>
+              <a:rPr/>
+              <a:t>The training CSR’s public key matches the training leaf: openssl req -in training-request.csr -noout -verify reports “Certificate request self-signature verify OK”.</a:t>
             </a:r>
           </a:p>
         </p:txBody>
@@ -1292,7 +1292,7 @@
           <a:p>
             <a:fld id="{18BDFEC3-8487-43E8-A154-7C12CBC1FFF2}" type="slidenum">
               <a:rPr lang="en-US"/>
-              <a:t>21</a:t>
+              <a:t>20</a:t>
             </a:fld>
             <a:endParaRPr lang="en-US"/>
           </a:p>
@@ -1352,21 +1352,7 @@
             </a:pPr>
             <a:r>
               <a:rPr/>
-              <a:t>Each row was produced against the training files with openssl verify (OpenSSL 3.5); the commands are on the companion site.</a:t>
-            </a:r>
-          </a:p>
-          <a:p>
-            <a:pPr lvl="0" indent="0" marL="0">
-              <a:buNone/>
-            </a:pPr>
-          </a:p>
-          <a:p>
-            <a:pPr lvl="0" indent="0" marL="0">
-              <a:buNone/>
-            </a:pPr>
-            <a:r>
-              <a:rPr/>
-              <a:t>Revocation: Let’s Encrypt ended its OCSP service on August 6, 2025 and publishes revocation through CRLs only: https://letsencrypt.org/2025/08/06/ocsp-service-has-reached-end-of-life Chrome uses CRLSets rather than online checks for most certificates: https://www.chromium.org/Home/chromium-security/crlsets/</a:t>
+              <a:t>A common incident-response finding: a missing intermediate works in one browser (which cached or fetched it) and fails in another client.</a:t>
             </a:r>
           </a:p>
         </p:txBody>
@@ -1388,7 +1374,7 @@
           <a:p>
             <a:fld id="{18BDFEC3-8487-43E8-A154-7C12CBC1FFF2}" type="slidenum">
               <a:rPr lang="en-US"/>
-              <a:t>22</a:t>
+              <a:t>21</a:t>
             </a:fld>
             <a:endParaRPr lang="en-US"/>
           </a:p>
@@ -1448,7 +1434,7 @@
             </a:pPr>
             <a:r>
               <a:rPr/>
-              <a:t>CA/Browser Forum Baseline Requirements section 1.2.2, from ballot SC-081v3 (passed April 2025): https://cabforum.org/working-groups/server/baseline-requirements/requirements/</a:t>
+              <a:t>Each row was produced against the training files with openssl verify (OpenSSL 3.5); the commands are on the companion site.</a:t>
             </a:r>
           </a:p>
           <a:p>
@@ -1462,7 +1448,7 @@
             </a:pPr>
             <a:r>
               <a:rPr/>
-              <a:t>These limits apply to publicly trusted TLS certificates. Internal CAs set their own policy; the training root is not a statement of public Web PKI issuance policy.</a:t>
+              <a:t>Revocation: Let’s Encrypt ended its OCSP service on August 6, 2025 and publishes revocation through CRLs only: https://letsencrypt.org/2025/08/06/ocsp-service-has-reached-end-of-life Chrome uses CRLSets rather than online checks for most certificates: https://www.chromium.org/Home/chromium-security/crlsets/</a:t>
             </a:r>
           </a:p>
         </p:txBody>
@@ -1484,7 +1470,7 @@
           <a:p>
             <a:fld id="{18BDFEC3-8487-43E8-A154-7C12CBC1FFF2}" type="slidenum">
               <a:rPr lang="en-US"/>
-              <a:t>23</a:t>
+              <a:t>22</a:t>
             </a:fld>
             <a:endParaRPr lang="en-US"/>
           </a:p>
@@ -1544,7 +1530,7 @@
             </a:pPr>
             <a:r>
               <a:rPr/>
-              <a:t>RFC 5598, Internet Mail Architecture: https://www.rfc-editor.org/rfc/rfc5598.html RFC 5321, SMTP: https://www.rfc-editor.org/rfc/rfc5321.html</a:t>
+              <a:t>CA/Browser Forum Baseline Requirements section 1.2.2, from ballot SC-081v3 (passed April 2025): https://cabforum.org/working-groups/server/baseline-requirements/requirements/</a:t>
             </a:r>
           </a:p>
           <a:p>
@@ -1558,7 +1544,7 @@
             </a:pPr>
             <a:r>
               <a:rPr/>
-              <a:t>RFC 6409 section 4.3: the MSA must reject unauthenticated mail by default “unless it has already independently established authentication or authorization (such as being within a protected subnetwork)”. Section 3.1: “A site MAY choose to use port 25 for message submission.” Printers, scanners and applications relaying through an IP-restricted connector are the everyday example. https://www.rfc-editor.org/rfc/rfc6409.html</a:t>
+              <a:t>These limits apply to publicly trusted TLS certificates. Internal CAs set their own policy; the training root is not a statement of public Web PKI issuance policy.</a:t>
             </a:r>
           </a:p>
         </p:txBody>
@@ -1580,7 +1566,7 @@
           <a:p>
             <a:fld id="{18BDFEC3-8487-43E8-A154-7C12CBC1FFF2}" type="slidenum">
               <a:rPr lang="en-US"/>
-              <a:t>26</a:t>
+              <a:t>23</a:t>
             </a:fld>
             <a:endParaRPr lang="en-US"/>
           </a:p>
@@ -1722,7 +1708,21 @@
             </a:pPr>
             <a:r>
               <a:rPr/>
-              <a:t>RFC 5321 section 4.4: the delivering SMTP server inserts Return-Path from the MAIL FROM reverse-path. RFC 5322 section 3.6.2: From, Sender, Reply-To.</a:t>
+              <a:t>RFC 5598, Internet Mail Architecture: https://www.rfc-editor.org/rfc/rfc5598.html RFC 5321, SMTP: https://www.rfc-editor.org/rfc/rfc5321.html</a:t>
+            </a:r>
+          </a:p>
+          <a:p>
+            <a:pPr lvl="0" indent="0" marL="0">
+              <a:buNone/>
+            </a:pPr>
+          </a:p>
+          <a:p>
+            <a:pPr lvl="0" indent="0" marL="0">
+              <a:buNone/>
+            </a:pPr>
+            <a:r>
+              <a:rPr/>
+              <a:t>RFC 6409 section 4.3: the MSA must reject unauthenticated mail by default “unless it has already independently established authentication or authorization (such as being within a protected subnetwork)”. Section 3.1: “A site MAY choose to use port 25 for message submission.” Printers, scanners and applications relaying through an IP-restricted connector are the everyday example. https://www.rfc-editor.org/rfc/rfc6409.html</a:t>
             </a:r>
           </a:p>
         </p:txBody>
@@ -1744,7 +1744,7 @@
           <a:p>
             <a:fld id="{18BDFEC3-8487-43E8-A154-7C12CBC1FFF2}" type="slidenum">
               <a:rPr lang="en-US"/>
-              <a:t>27</a:t>
+              <a:t>26</a:t>
             </a:fld>
             <a:endParaRPr lang="en-US"/>
           </a:p>
@@ -1804,21 +1804,7 @@
             </a:pPr>
             <a:r>
               <a:rPr/>
-              <a:t>RFC 8601, Authentication-Results: https://datatracker.ietf.org/doc/html/rfc8601</a:t>
-            </a:r>
-          </a:p>
-          <a:p>
-            <a:pPr lvl="0" indent="0" marL="0">
-              <a:buNone/>
-            </a:pPr>
-          </a:p>
-          <a:p>
-            <a:pPr lvl="0" indent="0" marL="0">
-              <a:buNone/>
-            </a:pPr>
-            <a:r>
-              <a:rPr/>
-              <a:t>Message Header Analyzer: paste headers at https://mha.azurewebsites.net/pages/mha.html, or install the Outlook add-in. Source: https://github.com/microsoft/MHA</a:t>
+              <a:t>RFC 5321 section 4.4: the delivering SMTP server inserts Return-Path from the MAIL FROM reverse-path. RFC 5322 section 3.6.2: From, Sender, Reply-To.</a:t>
             </a:r>
           </a:p>
         </p:txBody>
@@ -1840,7 +1826,7 @@
           <a:p>
             <a:fld id="{18BDFEC3-8487-43E8-A154-7C12CBC1FFF2}" type="slidenum">
               <a:rPr lang="en-US"/>
-              <a:t>28</a:t>
+              <a:t>27</a:t>
             </a:fld>
             <a:endParaRPr lang="en-US"/>
           </a:p>
@@ -1900,7 +1886,7 @@
             </a:pPr>
             <a:r>
               <a:rPr/>
-              <a:t>RFC 7208: SPF checks the MAIL FROM domain (or the HELO domain when MAIL FROM is empty), not the From header. https://www.rfc-editor.org/rfc/rfc7208.html</a:t>
+              <a:t>RFC 8601, Authentication-Results: https://datatracker.ietf.org/doc/html/rfc8601</a:t>
             </a:r>
           </a:p>
           <a:p>
@@ -1914,7 +1900,7 @@
             </a:pPr>
             <a:r>
               <a:rPr/>
-              <a:t>Record from learndmarc.com example 1.</a:t>
+              <a:t>Message Header Analyzer: paste headers at https://mha.azurewebsites.net/pages/mha.html, or install the Outlook add-in. Source: https://github.com/microsoft/MHA</a:t>
             </a:r>
           </a:p>
         </p:txBody>
@@ -1936,7 +1922,7 @@
           <a:p>
             <a:fld id="{18BDFEC3-8487-43E8-A154-7C12CBC1FFF2}" type="slidenum">
               <a:rPr lang="en-US"/>
-              <a:t>29</a:t>
+              <a:t>28</a:t>
             </a:fld>
             <a:endParaRPr lang="en-US"/>
           </a:p>
@@ -1996,7 +1982,21 @@
             </a:pPr>
             <a:r>
               <a:rPr/>
-              <a:t>RFC 6376: https://www.rfc-editor.org/rfc/rfc6376.html The d= domain does not have to match the From domain; DMARC is what requires alignment.</a:t>
+              <a:t>RFC 7208: SPF checks the MAIL FROM domain (or the HELO domain when MAIL FROM is empty), not the From header. https://www.rfc-editor.org/rfc/rfc7208.html</a:t>
+            </a:r>
+          </a:p>
+          <a:p>
+            <a:pPr lvl="0" indent="0" marL="0">
+              <a:buNone/>
+            </a:pPr>
+          </a:p>
+          <a:p>
+            <a:pPr lvl="0" indent="0" marL="0">
+              <a:buNone/>
+            </a:pPr>
+            <a:r>
+              <a:rPr/>
+              <a:t>Record from learndmarc.com example 1.</a:t>
             </a:r>
           </a:p>
         </p:txBody>
@@ -2018,7 +2018,7 @@
           <a:p>
             <a:fld id="{18BDFEC3-8487-43E8-A154-7C12CBC1FFF2}" type="slidenum">
               <a:rPr lang="en-US"/>
-              <a:t>30</a:t>
+              <a:t>29</a:t>
             </a:fld>
             <a:endParaRPr lang="en-US"/>
           </a:p>
@@ -2078,7 +2078,7 @@
             </a:pPr>
             <a:r>
               <a:rPr/>
-              <a:t>RFC 9989 (May 2026, Standards Track) obsoletes RFC 7489 and RFC 9091. Section 3.2.10 defines strict and relaxed alignment; adkim and aspf default to r (relaxed). Changes: pct, rf and ri removed; t (test mode), np and psd added; organizational domain found by a DNS tree walk instead of a public suffix list. https://www.rfc-editor.org/rfc/rfc9989.html Aggregate reports: RFC 9990. Failure reports: RFC 9991.</a:t>
+              <a:t>RFC 6376: https://www.rfc-editor.org/rfc/rfc6376.html The d= domain does not have to match the From domain; DMARC is what requires alignment.</a:t>
             </a:r>
           </a:p>
         </p:txBody>
@@ -2100,7 +2100,7 @@
           <a:p>
             <a:fld id="{18BDFEC3-8487-43E8-A154-7C12CBC1FFF2}" type="slidenum">
               <a:rPr lang="en-US"/>
-              <a:t>31</a:t>
+              <a:t>30</a:t>
             </a:fld>
             <a:endParaRPr lang="en-US"/>
           </a:p>
@@ -2160,7 +2160,7 @@
             </a:pPr>
             <a:r>
               <a:rPr/>
-              <a:t>Transcript from learndmarc.com, abridged. Lines starting &gt; are the client; lines starting . are the server. Ask: what are the sender identities, what did SPF and DKIM return, and does it pass DMARC?</a:t>
+              <a:t>RFC 9989 (May 2026, Standards Track) obsoletes RFC 7489 and RFC 9091. Section 3.2.10 defines strict and relaxed alignment; adkim and aspf default to r (relaxed). Changes: pct, rf and ri removed; t (test mode), np and psd added; organizational domain found by a DNS tree walk instead of a public suffix list. https://www.rfc-editor.org/rfc/rfc9989.html Aggregate reports: RFC 9990. Failure reports: RFC 9991.</a:t>
             </a:r>
           </a:p>
         </p:txBody>
@@ -2182,7 +2182,7 @@
           <a:p>
             <a:fld id="{18BDFEC3-8487-43E8-A154-7C12CBC1FFF2}" type="slidenum">
               <a:rPr lang="en-US"/>
-              <a:t>32</a:t>
+              <a:t>31</a:t>
             </a:fld>
             <a:endParaRPr lang="en-US"/>
           </a:p>
@@ -2242,7 +2242,7 @@
             </a:pPr>
             <a:r>
               <a:rPr/>
-              <a:t>Transcript from learndmarc.com, abridged.</a:t>
+              <a:t>Transcript from learndmarc.com, abridged. Lines starting &gt; are the client; lines starting . are the server. Ask: what are the sender identities, what did SPF and DKIM return, and does it pass DMARC?</a:t>
             </a:r>
           </a:p>
         </p:txBody>
@@ -2264,7 +2264,7 @@
           <a:p>
             <a:fld id="{18BDFEC3-8487-43E8-A154-7C12CBC1FFF2}" type="slidenum">
               <a:rPr lang="en-US"/>
-              <a:t>34</a:t>
+              <a:t>32</a:t>
             </a:fld>
             <a:endParaRPr lang="en-US"/>
           </a:p>
@@ -2324,7 +2324,7 @@
             </a:pPr>
             <a:r>
               <a:rPr/>
-              <a:t>Transcript from learndmarc.com, abridged. Note the trap: the sending IP is listed in red.primary.com’s SPF record, but SPF is evaluated against the MAIL FROM domain.</a:t>
+              <a:t>Transcript from learndmarc.com, abridged.</a:t>
             </a:r>
           </a:p>
         </p:txBody>
@@ -2346,7 +2346,7 @@
           <a:p>
             <a:fld id="{18BDFEC3-8487-43E8-A154-7C12CBC1FFF2}" type="slidenum">
               <a:rPr lang="en-US"/>
-              <a:t>36</a:t>
+              <a:t>34</a:t>
             </a:fld>
             <a:endParaRPr lang="en-US"/>
           </a:p>
@@ -2406,7 +2406,7 @@
             </a:pPr>
             <a:r>
               <a:rPr/>
-              <a:t>Both domains share the organizational domain primary.com, which is why relaxed alignment would have passed.</a:t>
+              <a:t>Transcript from learndmarc.com, abridged. Note the trap: the sending IP is listed in red.primary.com’s SPF record, but SPF is evaluated against the MAIL FROM domain.</a:t>
             </a:r>
           </a:p>
         </p:txBody>
@@ -2428,7 +2428,7 @@
           <a:p>
             <a:fld id="{18BDFEC3-8487-43E8-A154-7C12CBC1FFF2}" type="slidenum">
               <a:rPr lang="en-US"/>
-              <a:t>37</a:t>
+              <a:t>36</a:t>
             </a:fld>
             <a:endParaRPr lang="en-US"/>
           </a:p>
@@ -2488,7 +2488,7 @@
             </a:pPr>
             <a:r>
               <a:rPr/>
-              <a:t>RFC 8461 (MTA-STS): https://www.rfc-editor.org/rfc/rfc8461.html RFC 8460 (TLS-RPT): https://www.rfc-editor.org/rfc/rfc8460.html RFC 6686 (Sender ID and SPF experiment resolution): https://www.rfc-editor.org/rfc/rfc6686.html</a:t>
+              <a:t>Both domains share the organizational domain primary.com, which is why relaxed alignment would have passed.</a:t>
             </a:r>
           </a:p>
         </p:txBody>
@@ -2510,7 +2510,7 @@
           <a:p>
             <a:fld id="{18BDFEC3-8487-43E8-A154-7C12CBC1FFF2}" type="slidenum">
               <a:rPr lang="en-US"/>
-              <a:t>38</a:t>
+              <a:t>37</a:t>
             </a:fld>
             <a:endParaRPr lang="en-US"/>
           </a:p>
@@ -2570,21 +2570,7 @@
             </a:pPr>
             <a:r>
               <a:rPr/>
-              <a:t>xkcd 936, “Password Strength,” by Randall Munroe: https://xkcd.com/936/ (CC BY-NC 2.5).</a:t>
-            </a:r>
-          </a:p>
-          <a:p>
-            <a:pPr lvl="0" indent="0" marL="0">
-              <a:buNone/>
-            </a:pPr>
-          </a:p>
-          <a:p>
-            <a:pPr lvl="0" indent="0" marL="0">
-              <a:buNone/>
-            </a:pPr>
-            <a:r>
-              <a:rPr/>
-              <a:t>The explanation holds when the words are randomly selected rather than chosen by a person. The comic’s guess rates are historical, not a present-day benchmark.</a:t>
+              <a:t>NIST SP 800-63B-4 covers passwords alongside the other authenticator types: https://pages.nist.gov/800-63-4/sp800-63b.html</a:t>
             </a:r>
           </a:p>
         </p:txBody>
@@ -2606,7 +2592,7 @@
           <a:p>
             <a:fld id="{18BDFEC3-8487-43E8-A154-7C12CBC1FFF2}" type="slidenum">
               <a:rPr lang="en-US"/>
-              <a:t>6</a:t>
+              <a:t>5</a:t>
             </a:fld>
             <a:endParaRPr lang="en-US"/>
           </a:p>
@@ -2666,7 +2652,7 @@
             </a:pPr>
             <a:r>
               <a:rPr/>
-              <a:t>Get-Help shows local help; run Update-Help once (as administrator in Windows PowerShell 5.1) or use Get-Help -Online.</a:t>
+              <a:t>RFC 8461 (MTA-STS): https://www.rfc-editor.org/rfc/rfc8461.html RFC 8460 (TLS-RPT): https://www.rfc-editor.org/rfc/rfc8460.html RFC 6686 (Sender ID and SPF experiment resolution): https://www.rfc-editor.org/rfc/rfc6686.html</a:t>
             </a:r>
           </a:p>
         </p:txBody>
@@ -2688,7 +2674,7 @@
           <a:p>
             <a:fld id="{18BDFEC3-8487-43E8-A154-7C12CBC1FFF2}" type="slidenum">
               <a:rPr lang="en-US"/>
-              <a:t>42</a:t>
+              <a:t>38</a:t>
             </a:fld>
             <a:endParaRPr lang="en-US"/>
           </a:p>
@@ -2748,7 +2734,7 @@
             </a:pPr>
             <a:r>
               <a:rPr/>
-              <a:t>about_Pipelines: https://learn.microsoft.com/en-us/powershell/module/microsoft.powershell.core/about/about_pipelines</a:t>
+              <a:t>Get-Member shows the properties and methods of whatever a command returns.</a:t>
             </a:r>
           </a:p>
         </p:txBody>
@@ -2770,7 +2756,7 @@
           <a:p>
             <a:fld id="{18BDFEC3-8487-43E8-A154-7C12CBC1FFF2}" type="slidenum">
               <a:rPr lang="en-US"/>
-              <a:t>43</a:t>
+              <a:t>41</a:t>
             </a:fld>
             <a:endParaRPr lang="en-US"/>
           </a:p>
@@ -2830,7 +2816,7 @@
             </a:pPr>
             <a:r>
               <a:rPr/>
-              <a:t>Export-Csv: https://learn.microsoft.com/en-us/powershell/module/microsoft.powershell.utility/export-csv -NoTypeInformation is the default in PowerShell 7 and needed in Windows PowerShell 5.1.</a:t>
+              <a:t>Get-Help shows local help; run Update-Help once (as administrator in Windows PowerShell 5.1) or use Get-Help -Online.</a:t>
             </a:r>
           </a:p>
         </p:txBody>
@@ -2852,7 +2838,7 @@
           <a:p>
             <a:fld id="{18BDFEC3-8487-43E8-A154-7C12CBC1FFF2}" type="slidenum">
               <a:rPr lang="en-US"/>
-              <a:t>44</a:t>
+              <a:t>42</a:t>
             </a:fld>
             <a:endParaRPr lang="en-US"/>
           </a:p>
@@ -2912,7 +2898,7 @@
             </a:pPr>
             <a:r>
               <a:rPr/>
-              <a:t>Working with an existing collection of files. Get-FileInventory, on the companion site, combines these into one function.</a:t>
+              <a:t>about_Pipelines: https://learn.microsoft.com/en-us/powershell/module/microsoft.powershell.core/about/about_pipelines</a:t>
             </a:r>
           </a:p>
         </p:txBody>
@@ -2934,7 +2920,7 @@
           <a:p>
             <a:fld id="{18BDFEC3-8487-43E8-A154-7C12CBC1FFF2}" type="slidenum">
               <a:rPr lang="en-US"/>
-              <a:t>45</a:t>
+              <a:t>43</a:t>
             </a:fld>
             <a:endParaRPr lang="en-US"/>
           </a:p>
@@ -2994,7 +2980,7 @@
             </a:pPr>
             <a:r>
               <a:rPr/>
-              <a:t>Get-WinEvent: https://learn.microsoft.com/en-us/powershell/module/microsoft.powershell.diagnostics/get-winevent 4624 is a successful logon, 4625 a failed logon. Get-EvtxSummary and Get-LogonEvent on the companion site extend this.</a:t>
+              <a:t>Export-Csv: https://learn.microsoft.com/en-us/powershell/module/microsoft.powershell.utility/export-csv -NoTypeInformation is the default in PowerShell 7 and needed in Windows PowerShell 5.1.</a:t>
             </a:r>
           </a:p>
         </p:txBody>
@@ -3016,7 +3002,7 @@
           <a:p>
             <a:fld id="{18BDFEC3-8487-43E8-A154-7C12CBC1FFF2}" type="slidenum">
               <a:rPr lang="en-US"/>
-              <a:t>46</a:t>
+              <a:t>44</a:t>
             </a:fld>
             <a:endParaRPr lang="en-US"/>
           </a:p>
@@ -3076,7 +3062,7 @@
             </a:pPr>
             <a:r>
               <a:rPr/>
-              <a:t>about_Functions_CmdletBindingAttribute and ShouldProcess: https://learn.microsoft.com/en-us/powershell/module/microsoft.powershell.core/about/about_functions_cmdletbindingattribute New-CaseFolder -Path E:\2026-0142 -WhatIf shows what would happen without doing it. The full version on the companion site creates Collected, Output and Notes.</a:t>
+              <a:t>Working with an existing collection of files. Get-FileInventory, on the companion site, combines these into one function.</a:t>
             </a:r>
           </a:p>
         </p:txBody>
@@ -3098,7 +3084,7 @@
           <a:p>
             <a:fld id="{18BDFEC3-8487-43E8-A154-7C12CBC1FFF2}" type="slidenum">
               <a:rPr lang="en-US"/>
-              <a:t>47</a:t>
+              <a:t>45</a:t>
             </a:fld>
             <a:endParaRPr lang="en-US"/>
           </a:p>
@@ -3158,7 +3144,7 @@
             </a:pPr>
             <a:r>
               <a:rPr/>
-              <a:t>about_Modules: https://learn.microsoft.com/en-us/powershell/module/microsoft.powershell.core/about/about_modules Windows PowerShell 5.1 uses Documentsinstead. Every function on the companion site is in its own copyable block, and all of them are packaged as the CrtEssentials module.</a:t>
+              <a:t>Get-WinEvent: https://learn.microsoft.com/en-us/powershell/module/microsoft.powershell.diagnostics/get-winevent 4624 is a successful logon, 4625 a failed logon. Get-EvtxSummary and Get-LogonEvent on the companion site extend this.</a:t>
             </a:r>
           </a:p>
         </p:txBody>
@@ -3180,7 +3166,7 @@
           <a:p>
             <a:fld id="{18BDFEC3-8487-43E8-A154-7C12CBC1FFF2}" type="slidenum">
               <a:rPr lang="en-US"/>
-              <a:t>48</a:t>
+              <a:t>46</a:t>
             </a:fld>
             <a:endParaRPr lang="en-US"/>
           </a:p>
@@ -3240,7 +3226,7 @@
             </a:pPr>
             <a:r>
               <a:rPr/>
-              <a:t>Independent non-persistent disks discard changes at power-off: https://docs.vmware.com/en/VMware-Workstation-Pro/17/com.vmware.ws.using.doc/GUID-A6792F54-2734-4AF4-9473-C8B9AD8321AF.html Workstation Pro is free for commercial, educational and personal use since November 2024: https://knowledge.broadcom.com/external/article/368667/download-and-license-vmware-desktop-hypervisor.html In the guest, shared folders are at \vmware-hostFolders.</a:t>
+              <a:t>about_Functions_CmdletBindingAttribute and ShouldProcess: https://learn.microsoft.com/en-us/powershell/module/microsoft.powershell.core/about/about_functions_cmdletbindingattribute New-CaseFolder -Path E:\2026-0142 -WhatIf shows what would happen without doing it. The full version on the companion site creates Collected, Output and Notes.</a:t>
             </a:r>
           </a:p>
         </p:txBody>
@@ -3262,7 +3248,7 @@
           <a:p>
             <a:fld id="{18BDFEC3-8487-43E8-A154-7C12CBC1FFF2}" type="slidenum">
               <a:rPr lang="en-US"/>
-              <a:t>52</a:t>
+              <a:t>47</a:t>
             </a:fld>
             <a:endParaRPr lang="en-US"/>
           </a:p>
@@ -3322,7 +3308,7 @@
             </a:pPr>
             <a:r>
               <a:rPr/>
-              <a:t>Windows Server hardware requirements list a TPM as required only for certain features: https://learn.microsoft.com/en-us/windows-server/get-started/hardware-requirements Defender on Windows Server is the Windows-Defender feature: https://learn.microsoft.com/en-us/defender-endpoint/microsoft-defender-antivirus-windows-server-configure The 180-day evaluation must be activated online within its first 10 days. The unattend generator is written for Windows 10 and 11; test its output on Server 2025.</a:t>
+              <a:t>about_Modules: https://learn.microsoft.com/en-us/powershell/module/microsoft.powershell.core/about/about_modules Windows PowerShell 5.1 uses Documentsinstead. Every function on the companion site is in its own copyable block.</a:t>
             </a:r>
           </a:p>
         </p:txBody>
@@ -3344,7 +3330,7 @@
           <a:p>
             <a:fld id="{18BDFEC3-8487-43E8-A154-7C12CBC1FFF2}" type="slidenum">
               <a:rPr lang="en-US"/>
-              <a:t>53</a:t>
+              <a:t>48</a:t>
             </a:fld>
             <a:endParaRPr lang="en-US"/>
           </a:p>
@@ -3404,7 +3390,7 @@
             </a:pPr>
             <a:r>
               <a:rPr/>
-              <a:t>UAC off: EnableLUA = 0. Defender: Uninstall-WindowsFeature -Name Windows-Defender. Long paths: LongPathsEnabled = 1. All of these are options in the unattend generator. Commands are on the companion site.</a:t>
+              <a:t>Evidence arrives through the read-only Evidence shared folder; output goes to Cases. The VM stays off the internet during cases.</a:t>
             </a:r>
           </a:p>
         </p:txBody>
@@ -3426,7 +3412,7 @@
           <a:p>
             <a:fld id="{18BDFEC3-8487-43E8-A154-7C12CBC1FFF2}" type="slidenum">
               <a:rPr lang="en-US"/>
-              <a:t>54</a:t>
+              <a:t>51</a:t>
             </a:fld>
             <a:endParaRPr lang="en-US"/>
           </a:p>
@@ -3486,7 +3472,21 @@
             </a:pPr>
             <a:r>
               <a:rPr/>
-              <a:t>Claude Shannon, as recounted in M. Tribus and E. C. McIrvine, “Energy and Information,” Scientific American 225(3), 1971.</a:t>
+              <a:t>xkcd 936, “Password Strength,” by Randall Munroe: https://xkcd.com/936/ (CC BY-NC 2.5).</a:t>
+            </a:r>
+          </a:p>
+          <a:p>
+            <a:pPr lvl="0" indent="0" marL="0">
+              <a:buNone/>
+            </a:pPr>
+          </a:p>
+          <a:p>
+            <a:pPr lvl="0" indent="0" marL="0">
+              <a:buNone/>
+            </a:pPr>
+            <a:r>
+              <a:rPr/>
+              <a:t>The explanation holds when the words are randomly selected rather than chosen by a person. The comic’s guess rates are historical, not a present-day benchmark.</a:t>
             </a:r>
           </a:p>
         </p:txBody>
@@ -3508,7 +3508,7 @@
           <a:p>
             <a:fld id="{18BDFEC3-8487-43E8-A154-7C12CBC1FFF2}" type="slidenum">
               <a:rPr lang="en-US"/>
-              <a:t>7</a:t>
+              <a:t>6</a:t>
             </a:fld>
             <a:endParaRPr lang="en-US"/>
           </a:p>
@@ -3568,7 +3568,7 @@
             </a:pPr>
             <a:r>
               <a:rPr/>
-              <a:t>The full line on the companion site also installs 7-Zip, Sysinternals and PowerShell 7. KAPE, FTK Imager, Chainsaw and Hayabusa are direct downloads; Chocolatey’s “chainsaw” package is a different program. Plaso runs on Windows through Docker. KAPE and the community KapeFiles repository: https://github.com/EricZimmerman/KapeFiles Kroll’s KAPE terms distinguish free and enterprise use: https://www.kroll.com/en/kape-license-agreement</a:t>
+              <a:t>Independent non-persistent disks discard changes at power-off: https://docs.vmware.com/en/VMware-Workstation-Pro/17/com.vmware.ws.using.doc/GUID-A6792F54-2734-4AF4-9473-C8B9AD8321AF.html Workstation Pro is free for commercial, educational and personal use since November 2024: https://knowledge.broadcom.com/external/article/368667/download-and-license-vmware-desktop-hypervisor.html In the guest, shared folders are at \vmware-hostFolders.</a:t>
             </a:r>
           </a:p>
         </p:txBody>
@@ -3590,7 +3590,7 @@
           <a:p>
             <a:fld id="{18BDFEC3-8487-43E8-A154-7C12CBC1FFF2}" type="slidenum">
               <a:rPr lang="en-US"/>
-              <a:t>55</a:t>
+              <a:t>52</a:t>
             </a:fld>
             <a:endParaRPr lang="en-US"/>
           </a:p>
@@ -3650,6 +3650,252 @@
             </a:pPr>
             <a:r>
               <a:rPr/>
+              <a:t>Windows Server hardware requirements list a TPM as required only for certain features: https://learn.microsoft.com/en-us/windows-server/get-started/hardware-requirements Defender on Windows Server is the Windows-Defender feature: https://learn.microsoft.com/en-us/defender-endpoint/microsoft-defender-antivirus-windows-server-configure The 180-day evaluation must be activated online within its first 10 days. The unattend generator is written for Windows 10 and 11. For Server 2025, enter the product key (generic or real) and select the image by name or index.</a:t>
+            </a:r>
+          </a:p>
+        </p:txBody>
+      </p:sp>
+      <p:sp>
+        <p:nvSpPr>
+          <p:cNvPr id="4" name="Slide Number Placeholder 3"/>
+          <p:cNvSpPr>
+            <a:spLocks noGrp="1"/>
+          </p:cNvSpPr>
+          <p:nvPr>
+            <p:ph type="sldNum" sz="quarter" idx="10"/>
+          </p:nvPr>
+        </p:nvSpPr>
+        <p:spPr/>
+        <p:txBody>
+          <a:bodyPr/>
+          <a:lstStyle/>
+          <a:p>
+            <a:fld id="{18BDFEC3-8487-43E8-A154-7C12CBC1FFF2}" type="slidenum">
+              <a:rPr lang="en-US"/>
+              <a:t>53</a:t>
+            </a:fld>
+            <a:endParaRPr lang="en-US"/>
+          </a:p>
+        </p:txBody>
+      </p:sp>
+    </p:spTree>
+  </p:cSld>
+</p:notes>
+</file>
+
+<file path=ppt/notesSlides/notesSlide42.xml><?xml version="1.0" encoding="utf-8"?>
+<p:notes xmlns:a="http://schemas.openxmlformats.org/drawingml/2006/main" xmlns:r="http://schemas.openxmlformats.org/officeDocument/2006/relationships" xmlns:p="http://schemas.openxmlformats.org/presentationml/2006/main">
+  <p:cSld>
+    <p:spTree>
+      <p:nvGrpSpPr>
+        <p:cNvPr id="1" name=""/>
+        <p:cNvGrpSpPr/>
+        <p:nvPr/>
+      </p:nvGrpSpPr>
+      <p:grpSpPr>
+        <a:xfrm>
+          <a:off x="0" y="0"/>
+          <a:ext cx="0" cy="0"/>
+          <a:chOff x="0" y="0"/>
+          <a:chExt cx="0" cy="0"/>
+        </a:xfrm>
+      </p:grpSpPr>
+      <p:sp>
+        <p:nvSpPr>
+          <p:cNvPr id="2" name="Slide Image Placeholder 1"/>
+          <p:cNvSpPr>
+            <a:spLocks noGrp="1" noRot="1" noChangeAspect="1"/>
+          </p:cNvSpPr>
+          <p:nvPr>
+            <p:ph type="sldImg"/>
+          </p:nvPr>
+        </p:nvSpPr>
+        <p:spPr/>
+      </p:sp>
+      <p:sp>
+        <p:nvSpPr>
+          <p:cNvPr id="3" name="Notes Placeholder 2"/>
+          <p:cNvSpPr>
+            <a:spLocks noGrp="1"/>
+          </p:cNvSpPr>
+          <p:nvPr>
+            <p:ph type="body" idx="1"/>
+          </p:nvPr>
+        </p:nvSpPr>
+        <p:spPr/>
+        <p:txBody>
+          <a:bodyPr/>
+          <a:lstStyle/>
+          <a:p>
+            <a:pPr lvl="0" indent="0" marL="0">
+              <a:buNone/>
+            </a:pPr>
+            <a:r>
+              <a:rPr/>
+              <a:t>UAC off: EnableLUA = 0. Defender: Uninstall-WindowsFeature -Name Windows-Defender. Long paths: LongPathsEnabled = 1. All of these are options in the unattend generator. Commands are on the companion site.</a:t>
+            </a:r>
+          </a:p>
+        </p:txBody>
+      </p:sp>
+      <p:sp>
+        <p:nvSpPr>
+          <p:cNvPr id="4" name="Slide Number Placeholder 3"/>
+          <p:cNvSpPr>
+            <a:spLocks noGrp="1"/>
+          </p:cNvSpPr>
+          <p:nvPr>
+            <p:ph type="sldNum" sz="quarter" idx="10"/>
+          </p:nvPr>
+        </p:nvSpPr>
+        <p:spPr/>
+        <p:txBody>
+          <a:bodyPr/>
+          <a:lstStyle/>
+          <a:p>
+            <a:fld id="{18BDFEC3-8487-43E8-A154-7C12CBC1FFF2}" type="slidenum">
+              <a:rPr lang="en-US"/>
+              <a:t>54</a:t>
+            </a:fld>
+            <a:endParaRPr lang="en-US"/>
+          </a:p>
+        </p:txBody>
+      </p:sp>
+    </p:spTree>
+  </p:cSld>
+</p:notes>
+</file>
+
+<file path=ppt/notesSlides/notesSlide43.xml><?xml version="1.0" encoding="utf-8"?>
+<p:notes xmlns:a="http://schemas.openxmlformats.org/drawingml/2006/main" xmlns:r="http://schemas.openxmlformats.org/officeDocument/2006/relationships" xmlns:p="http://schemas.openxmlformats.org/presentationml/2006/main">
+  <p:cSld>
+    <p:spTree>
+      <p:nvGrpSpPr>
+        <p:cNvPr id="1" name=""/>
+        <p:cNvGrpSpPr/>
+        <p:nvPr/>
+      </p:nvGrpSpPr>
+      <p:grpSpPr>
+        <a:xfrm>
+          <a:off x="0" y="0"/>
+          <a:ext cx="0" cy="0"/>
+          <a:chOff x="0" y="0"/>
+          <a:chExt cx="0" cy="0"/>
+        </a:xfrm>
+      </p:grpSpPr>
+      <p:sp>
+        <p:nvSpPr>
+          <p:cNvPr id="2" name="Slide Image Placeholder 1"/>
+          <p:cNvSpPr>
+            <a:spLocks noGrp="1" noRot="1" noChangeAspect="1"/>
+          </p:cNvSpPr>
+          <p:nvPr>
+            <p:ph type="sldImg"/>
+          </p:nvPr>
+        </p:nvSpPr>
+        <p:spPr/>
+      </p:sp>
+      <p:sp>
+        <p:nvSpPr>
+          <p:cNvPr id="3" name="Notes Placeholder 2"/>
+          <p:cNvSpPr>
+            <a:spLocks noGrp="1"/>
+          </p:cNvSpPr>
+          <p:nvPr>
+            <p:ph type="body" idx="1"/>
+          </p:nvPr>
+        </p:nvSpPr>
+        <p:spPr/>
+        <p:txBody>
+          <a:bodyPr/>
+          <a:lstStyle/>
+          <a:p>
+            <a:pPr lvl="0" indent="0" marL="0">
+              <a:buNone/>
+            </a:pPr>
+            <a:r>
+              <a:rPr/>
+              <a:t>The full line on the companion site also installs 7-Zip, Sysinternals and PowerShell 7. KAPE, FTK Imager, Chainsaw and Hayabusa are direct downloads; Chocolatey’s “chainsaw” package is a different program. Plaso runs on Windows through Docker. KAPE and the community KapeFiles repository: https://github.com/EricZimmerman/KapeFiles KAPE is free for CRT members; commercial use needs a Kroll enterprise license: https://www.kroll.com/en/kape-license-agreement</a:t>
+            </a:r>
+          </a:p>
+        </p:txBody>
+      </p:sp>
+      <p:sp>
+        <p:nvSpPr>
+          <p:cNvPr id="4" name="Slide Number Placeholder 3"/>
+          <p:cNvSpPr>
+            <a:spLocks noGrp="1"/>
+          </p:cNvSpPr>
+          <p:nvPr>
+            <p:ph type="sldNum" sz="quarter" idx="10"/>
+          </p:nvPr>
+        </p:nvSpPr>
+        <p:spPr/>
+        <p:txBody>
+          <a:bodyPr/>
+          <a:lstStyle/>
+          <a:p>
+            <a:fld id="{18BDFEC3-8487-43E8-A154-7C12CBC1FFF2}" type="slidenum">
+              <a:rPr lang="en-US"/>
+              <a:t>55</a:t>
+            </a:fld>
+            <a:endParaRPr lang="en-US"/>
+          </a:p>
+        </p:txBody>
+      </p:sp>
+    </p:spTree>
+  </p:cSld>
+</p:notes>
+</file>
+
+<file path=ppt/notesSlides/notesSlide44.xml><?xml version="1.0" encoding="utf-8"?>
+<p:notes xmlns:a="http://schemas.openxmlformats.org/drawingml/2006/main" xmlns:r="http://schemas.openxmlformats.org/officeDocument/2006/relationships" xmlns:p="http://schemas.openxmlformats.org/presentationml/2006/main">
+  <p:cSld>
+    <p:spTree>
+      <p:nvGrpSpPr>
+        <p:cNvPr id="1" name=""/>
+        <p:cNvGrpSpPr/>
+        <p:nvPr/>
+      </p:nvGrpSpPr>
+      <p:grpSpPr>
+        <a:xfrm>
+          <a:off x="0" y="0"/>
+          <a:ext cx="0" cy="0"/>
+          <a:chOff x="0" y="0"/>
+          <a:chExt cx="0" cy="0"/>
+        </a:xfrm>
+      </p:grpSpPr>
+      <p:sp>
+        <p:nvSpPr>
+          <p:cNvPr id="2" name="Slide Image Placeholder 1"/>
+          <p:cNvSpPr>
+            <a:spLocks noGrp="1" noRot="1" noChangeAspect="1"/>
+          </p:cNvSpPr>
+          <p:nvPr>
+            <p:ph type="sldImg"/>
+          </p:nvPr>
+        </p:nvSpPr>
+        <p:spPr/>
+      </p:sp>
+      <p:sp>
+        <p:nvSpPr>
+          <p:cNvPr id="3" name="Notes Placeholder 2"/>
+          <p:cNvSpPr>
+            <a:spLocks noGrp="1"/>
+          </p:cNvSpPr>
+          <p:nvPr>
+            <p:ph type="body" idx="1"/>
+          </p:nvPr>
+        </p:nvSpPr>
+        <p:spPr/>
+        <p:txBody>
+          <a:bodyPr/>
+          <a:lstStyle/>
+          <a:p>
+            <a:pPr lvl="0" indent="0" marL="0">
+              <a:buNone/>
+            </a:pPr>
+            <a:r>
+              <a:rPr/>
               <a:t>Read from the read-only Evidence share, write to Cases. Before power-off, confirm the output is on the Cases share; after power-on, confirm the system disk is clean.</a:t>
             </a:r>
           </a:p>
@@ -3732,59 +3978,7 @@
             </a:pPr>
             <a:r>
               <a:rPr/>
-              <a:t>The alphabet/length formula assumes each character, or word, is chosen uniformly at random from the alphabet. Human-chosen passwords do not meet that assumption.</a:t>
-            </a:r>
-          </a:p>
-          <a:p>
-            <a:pPr lvl="0" indent="0" marL="0">
-              <a:buNone/>
-            </a:pPr>
-          </a:p>
-          <a:p>
-            <a:pPr lvl="0" indent="0" marL="0">
-              <a:buNone/>
-            </a:pPr>
-            <a:r>
-              <a:rPr/>
-              <a:t>Bits = log</a:t>
-            </a:r>
-            <a:r>
-              <a:rPr baseline="-25000"/>
-              <a:t>2</a:t>
-            </a:r>
-            <a:r>
-              <a:rPr/>
-              <a:t>(alphabet</a:t>
-            </a:r>
-            <a:r>
-              <a:rPr baseline="30000"/>
-              <a:t>length</a:t>
-            </a:r>
-            <a:r>
-              <a:rPr/>
-              <a:t>) = length × log</a:t>
-            </a:r>
-            <a:r>
-              <a:rPr baseline="-25000"/>
-              <a:t>2</a:t>
-            </a:r>
-            <a:r>
-              <a:rPr/>
-              <a:t>(alphabet). xkcd 936 uses 11 bits per word (2,048 words). The EFF large wordlist has 7,776 words (five dice): https://www.eff.org/dice</a:t>
-            </a:r>
-          </a:p>
-          <a:p>
-            <a:pPr lvl="0" indent="0" marL="0">
-              <a:buNone/>
-            </a:pPr>
-          </a:p>
-          <a:p>
-            <a:pPr lvl="0" indent="0" marL="0">
-              <a:buNone/>
-            </a:pPr>
-            <a:r>
-              <a:rPr/>
-              <a:t>Get-PasswordEntropy and Get-PasswordLength on the companion site calculate these.</a:t>
+              <a:t>Claude Shannon, as recounted in M. Tribus and E. C. McIrvine, “Energy and Information,” Scientific American 225(3), 1971.</a:t>
             </a:r>
           </a:p>
         </p:txBody>
@@ -3806,7 +4000,7 @@
           <a:p>
             <a:fld id="{18BDFEC3-8487-43E8-A154-7C12CBC1FFF2}" type="slidenum">
               <a:rPr lang="en-US"/>
-              <a:t>8</a:t>
+              <a:t>7</a:t>
             </a:fld>
             <a:endParaRPr lang="en-US"/>
           </a:p>
@@ -3866,7 +4060,7 @@
             </a:pPr>
             <a:r>
               <a:rPr/>
-              <a:t>Switch to the companion site for the entropy calculation: dzampino.github.io/crt-essentials-2026/passwords.html</a:t>
+              <a:t>The alphabet/length formula assumes each character, or word, is chosen uniformly at random from the alphabet. Human-chosen passwords do not meet that assumption.</a:t>
             </a:r>
           </a:p>
           <a:p>
@@ -3880,7 +4074,7 @@
             </a:pPr>
             <a:r>
               <a:rPr/>
-              <a:t>Adding a character multiplies the search space by the alphabet size (adds log</a:t>
+              <a:t>Bits = log</a:t>
             </a:r>
             <a:r>
               <a:rPr baseline="-25000"/>
@@ -3888,7 +4082,37 @@
             </a:r>
             <a:r>
               <a:rPr/>
-              <a:t>(alphabet) bits); doubling the alphabet adds only one bit per character. On average an attacker finds the secret after searching half the space, which is one bit less.</a:t>
+              <a:t>(alphabet</a:t>
+            </a:r>
+            <a:r>
+              <a:rPr baseline="30000"/>
+              <a:t>length</a:t>
+            </a:r>
+            <a:r>
+              <a:rPr/>
+              <a:t>) = length × log</a:t>
+            </a:r>
+            <a:r>
+              <a:rPr baseline="-25000"/>
+              <a:t>2</a:t>
+            </a:r>
+            <a:r>
+              <a:rPr/>
+              <a:t>(alphabet). xkcd 936 uses 11 bits per word (2,048 words). The EFF large wordlist has 7,776 words (five dice): https://www.eff.org/dice</a:t>
+            </a:r>
+          </a:p>
+          <a:p>
+            <a:pPr lvl="0" indent="0" marL="0">
+              <a:buNone/>
+            </a:pPr>
+          </a:p>
+          <a:p>
+            <a:pPr lvl="0" indent="0" marL="0">
+              <a:buNone/>
+            </a:pPr>
+            <a:r>
+              <a:rPr/>
+              <a:t>Get-PasswordEntropy and Get-PasswordLength on the companion site calculate these.</a:t>
             </a:r>
           </a:p>
         </p:txBody>
@@ -3910,7 +4134,7 @@
           <a:p>
             <a:fld id="{18BDFEC3-8487-43E8-A154-7C12CBC1FFF2}" type="slidenum">
               <a:rPr lang="en-US"/>
-              <a:t>9</a:t>
+              <a:t>8</a:t>
             </a:fld>
             <a:endParaRPr lang="en-US"/>
           </a:p>
@@ -3970,15 +4194,7 @@
             </a:pPr>
             <a:r>
               <a:rPr/>
-              <a:t>Rates: hashcat v6.2.6 benchmark, RTX 5090 Founders Edition, Chick3nman, February 2025: https://gist.github.com/Chick3nman/09bac0775e6393468c2925c1e1363d5c Average time = (95</a:t>
-            </a:r>
-            <a:r>
-              <a:rPr baseline="30000"/>
-              <a:t>8</a:t>
-            </a:r>
-            <a:r>
-              <a:rPr/>
-              <a:t> / 2) / rate, a full brute force with no wordlist. Real attacks start with wordlists and rules, so human-chosen passwords fall much faster.</a:t>
+              <a:t>Switch to the companion site for the entropy calculation: dzampino.github.io/crt-essentials-2026/passwords.html</a:t>
             </a:r>
           </a:p>
           <a:p>
@@ -3992,35 +4208,15 @@
             </a:pPr>
             <a:r>
               <a:rPr/>
-              <a:t>Each RTX 5090 draws up to 575 W, all of which becomes heat: about 1,960 BTU/h, or 0.16 tons of cooling per card. The companion site works out power and cooling for each threat level.</a:t>
-            </a:r>
-          </a:p>
-          <a:p>
-            <a:pPr lvl="0" indent="0" marL="0">
-              <a:buNone/>
-            </a:pPr>
-          </a:p>
-          <a:p>
-            <a:pPr lvl="0" indent="0" marL="0">
-              <a:buNone/>
-            </a:pPr>
-            <a:r>
-              <a:rPr/>
-              <a:t>A stored Windows NT hash and an NTLM protocol exchange (NetNTLMv2, 16.0 G/s on the same card) are different things.</a:t>
-            </a:r>
-          </a:p>
-          <a:p>
-            <a:pPr lvl="0" indent="0" marL="0">
-              <a:buNone/>
-            </a:pPr>
-          </a:p>
-          <a:p>
-            <a:pPr lvl="0" indent="0" marL="0">
-              <a:buNone/>
-            </a:pPr>
-            <a:r>
-              <a:rPr/>
-              <a:t>OWASP Password Storage Cheat Sheet: https://cheatsheetseries.owasp.org/cheatsheets/Password_Storage_Cheat_Sheet.html Microsoft, Passwords technical overview: https://learn.microsoft.com/en-us/windows-server/security/kerberos/passwords-technical-overview</a:t>
+              <a:t>Adding a character multiplies the search space by the alphabet size (adds log</a:t>
+            </a:r>
+            <a:r>
+              <a:rPr baseline="-25000"/>
+              <a:t>2</a:t>
+            </a:r>
+            <a:r>
+              <a:rPr/>
+              <a:t>(alphabet) bits); doubling the alphabet adds only one bit per character. On average an attacker finds the secret after searching half the space, which is one bit less.</a:t>
             </a:r>
           </a:p>
         </p:txBody>
@@ -4042,7 +4238,7 @@
           <a:p>
             <a:fld id="{18BDFEC3-8487-43E8-A154-7C12CBC1FFF2}" type="slidenum">
               <a:rPr lang="en-US"/>
-              <a:t>10</a:t>
+              <a:t>9</a:t>
             </a:fld>
             <a:endParaRPr lang="en-US"/>
           </a:p>
@@ -4102,7 +4298,57 @@
             </a:pPr>
             <a:r>
               <a:rPr/>
-              <a:t>NIST SP 800-63B-4 section 3.2.2: rate limiting SHALL limit consecutive failed attempts on an account to no more than 100. Section 3.1.1.2: passwords SHALL be salted (at least 32 bits) and hashed with a suitable password hashing scheme; the cost factor SHOULD be as high as practical. https://pages.nist.gov/800-63-4/sp800-63b.html</a:t>
+              <a:t>Rates: hashcat v6.2.6 benchmark, RTX 5090 Founders Edition, Chick3nman, February 2025: https://gist.github.com/Chick3nman/09bac0775e6393468c2925c1e1363d5c Average time = (95</a:t>
+            </a:r>
+            <a:r>
+              <a:rPr baseline="30000"/>
+              <a:t>8</a:t>
+            </a:r>
+            <a:r>
+              <a:rPr/>
+              <a:t> / 2) / rate, a full brute force with no wordlist. Real attacks start with wordlists and rules, so human-chosen passwords fall much faster.</a:t>
+            </a:r>
+          </a:p>
+          <a:p>
+            <a:pPr lvl="0" indent="0" marL="0">
+              <a:buNone/>
+            </a:pPr>
+          </a:p>
+          <a:p>
+            <a:pPr lvl="0" indent="0" marL="0">
+              <a:buNone/>
+            </a:pPr>
+            <a:r>
+              <a:rPr/>
+              <a:t>Each RTX 5090 draws up to 575 W, all of which becomes heat: about 1,960 BTU/h, or 0.16 tons of cooling per card. The companion site works out power and cooling for each threat level.</a:t>
+            </a:r>
+          </a:p>
+          <a:p>
+            <a:pPr lvl="0" indent="0" marL="0">
+              <a:buNone/>
+            </a:pPr>
+          </a:p>
+          <a:p>
+            <a:pPr lvl="0" indent="0" marL="0">
+              <a:buNone/>
+            </a:pPr>
+            <a:r>
+              <a:rPr/>
+              <a:t>A stored Windows NT hash and an NTLM protocol exchange (NetNTLMv2, 16.0 G/s on the same card) are different things.</a:t>
+            </a:r>
+          </a:p>
+          <a:p>
+            <a:pPr lvl="0" indent="0" marL="0">
+              <a:buNone/>
+            </a:pPr>
+          </a:p>
+          <a:p>
+            <a:pPr lvl="0" indent="0" marL="0">
+              <a:buNone/>
+            </a:pPr>
+            <a:r>
+              <a:rPr/>
+              <a:t>OWASP Password Storage Cheat Sheet: https://cheatsheetseries.owasp.org/cheatsheets/Password_Storage_Cheat_Sheet.html Microsoft, Passwords technical overview: https://learn.microsoft.com/en-us/windows-server/security/kerberos/passwords-technical-overview</a:t>
             </a:r>
           </a:p>
         </p:txBody>
@@ -4124,7 +4370,7 @@
           <a:p>
             <a:fld id="{18BDFEC3-8487-43E8-A154-7C12CBC1FFF2}" type="slidenum">
               <a:rPr lang="en-US"/>
-              <a:t>11</a:t>
+              <a:t>10</a:t>
             </a:fld>
             <a:endParaRPr lang="en-US"/>
           </a:p>
@@ -4184,7 +4430,7 @@
             </a:pPr>
             <a:r>
               <a:rPr/>
-              <a:t>NIST SP 800-63B-4 section 3.1.1.2: minimum 15 characters when a password is used as a single-factor authenticator, 8 when used only as part of MFA; support at least 64 characters; compare against a blocklist; SHALL NOT impose other composition rules; SHALL NOT require periodic changes, but force a change on evidence of compromise. https://pages.nist.gov/800-63-4/sp800-63b.html Have I Been Pwned, Pwned Passwords: https://haveibeenpwned.com/Passwords</a:t>
+              <a:t>NIST SP 800-63B-4 section 3.2.2: rate limiting SHALL limit consecutive failed attempts on an account to no more than 100. Section 3.1.1.2: passwords SHALL be salted (at least 32 bits) and hashed with a suitable password hashing scheme; the cost factor SHOULD be as high as practical. https://pages.nist.gov/800-63-4/sp800-63b.html</a:t>
             </a:r>
           </a:p>
         </p:txBody>
@@ -4206,7 +4452,7 @@
           <a:p>
             <a:fld id="{18BDFEC3-8487-43E8-A154-7C12CBC1FFF2}" type="slidenum">
               <a:rPr lang="en-US"/>
-              <a:t>12</a:t>
+              <a:t>11</a:t>
             </a:fld>
             <a:endParaRPr lang="en-US"/>
           </a:p>
@@ -8870,7 +9116,7 @@
       </p:sp>
       <p:pic>
         <p:nvPicPr>
-          <p:cNvPr descr="../assets/diagrams/certificate-chain.png" id="0" name="Picture 1"/>
+          <p:cNvPr descr="Certificate chain: the self-signed root CA signs the intermediate CA, which signs the leaf. The client supplies the trust anchor from its certificate store; the server presents the leaf and intermediates and proves possession of the leaf private key" id="0" name="Picture 1"/>
           <p:cNvPicPr>
             <a:picLocks noGrp="1" noChangeAspect="1"/>
           </p:cNvPicPr>
@@ -9452,48 +9698,14 @@
             </a:pPr>
             <a:r>
               <a:rPr/>
-              <a:t>Companion site</a:t>
-            </a:r>
-          </a:p>
-        </p:txBody>
-      </p:sp>
-      <p:sp>
-        <p:nvSpPr>
-          <p:cNvPr id="4" name="Text Placeholder 4"/>
-          <p:cNvSpPr>
-            <a:spLocks noGrp="1"/>
-          </p:cNvSpPr>
-          <p:nvPr>
-            <p:ph idx="2" sz="half" type="body"/>
-          </p:nvPr>
-        </p:nvSpPr>
-        <p:spPr/>
-        <p:txBody>
-          <a:bodyPr/>
-          <a:lstStyle/>
-          <a:p>
-            <a:pPr lvl="0" indent="0" marL="0">
-              <a:buNone/>
-            </a:pPr>
-            <a:r>
-              <a:rPr b="1"/>
               <a:t>dzampino.github.io/crt-essentials-2026</a:t>
-            </a:r>
-          </a:p>
-          <a:p>
-            <a:pPr lvl="0" indent="0" marL="0">
-              <a:buNone/>
-            </a:pPr>
-            <a:r>
-              <a:rPr/>
-              <a:t>Calculators, sample files, commands, a PowerShell module and references for everything in this session</a:t>
             </a:r>
           </a:p>
         </p:txBody>
       </p:sp>
       <p:pic>
         <p:nvPicPr>
-          <p:cNvPr descr="../assets/site-qr.png" id="0" name="Picture 1"/>
+          <p:cNvPr descr="QR code linking to dzampino.github.io/crt-essentials-2026" id="0" name="Picture 1"/>
           <p:cNvPicPr>
             <a:picLocks noGrp="1" noChangeAspect="1"/>
           </p:cNvPicPr>
@@ -9507,7 +9719,7 @@
         </p:blipFill>
         <p:spPr bwMode="auto">
           <a:xfrm>
-            <a:off x="5753100" y="1435100"/>
+            <a:off x="3784600" y="1435100"/>
             <a:ext cx="4597400" cy="4597400"/>
           </a:xfrm>
           <a:prstGeom prst="rect">
@@ -9523,7 +9735,7 @@
       </p:pic>
       <p:sp>
         <p:nvSpPr>
-          <p:cNvPr id="5" name="Footer Placeholder"/>
+          <p:cNvPr id="4" name="Footer Placeholder"/>
           <p:cNvSpPr>
             <a:spLocks noGrp="1"/>
           </p:cNvSpPr>
@@ -9565,7 +9777,7 @@
       </p:sp>
       <p:sp>
         <p:nvSpPr>
-          <p:cNvPr id="6" name="Slide Number Placeholder"/>
+          <p:cNvPr id="5" name="Slide Number Placeholder"/>
           <p:cNvSpPr>
             <a:spLocks noGrp="1"/>
           </p:cNvSpPr>
@@ -11107,7 +11319,7 @@
       </p:sp>
       <p:pic>
         <p:nvPicPr>
-          <p:cNvPr descr="../assets/diagrams/email-flow.png" id="0" name="Picture 1"/>
+          <p:cNvPr descr="Email flow: the author client (MUA) submits to the MSA, which relays to the sending MTA. The sending MTA finds the receiving MTA through DNS MX records and sends by SMTP; the receiving MTA looks up SPF, DKIM and DMARC policy and delivers to the MDA, which the recipient client reads. Each hop adds a Received header" id="0" name="Picture 1"/>
           <p:cNvPicPr>
             <a:picLocks noGrp="1" noChangeAspect="1"/>
           </p:cNvPicPr>
@@ -20903,7 +21115,7 @@
       </p:sp>
       <p:pic>
         <p:nvPicPr>
-          <p:cNvPr descr="../assets/xkcd-936.png" id="0" name="Picture 1"/>
+          <p:cNvPr descr="xkcd 936 comic: Tr0ub4dor&amp;3 is hard to remember and has about 28 bits of entropy; correct horse battery staple, four random common words, is easy to remember and has about 44 bits" id="0" name="Picture 1"/>
           <p:cNvPicPr>
             <a:picLocks noGrp="1" noChangeAspect="1"/>
           </p:cNvPicPr>

</xml_diff>

<commit_message>
Entropy chart follows the chosen length; DFIR unattend usage, ISO rebuild and UTC clock
- Chart axes end at the chosen length (x steps of 1 up to 12) and grow with
  length and alphabet
- DFIR: using the answer file (second ISO or rebuilt Windows ISO with oscdimg),
  install steps, cached answer file cleanup; UTC time zone or a second UTC clock
- Deck: clock bullet and unattend note; outline and references updated

Co-Authored-By: Claude Opus 5.5 <noreply@anthropic.com>
</commit_message>
<xml_diff>
--- a/docs/files/crt-essentials.pptx
+++ b/docs/files/crt-essentials.pptx
@@ -3650,7 +3650,7 @@
             </a:pPr>
             <a:r>
               <a:rPr/>
-              <a:t>Windows Server hardware requirements list a TPM as required only for certain features: https://learn.microsoft.com/en-us/windows-server/get-started/hardware-requirements Defender on Windows Server is the Windows-Defender feature: https://learn.microsoft.com/en-us/defender-endpoint/microsoft-defender-antivirus-windows-server-configure The 180-day evaluation must be activated online within its first 10 days. The unattend generator is written for Windows 10 and 11. For Server 2025, enter the product key (generic or real) and select the image by name or index.</a:t>
+              <a:t>Windows Server hardware requirements list a TPM as required only for certain features: https://learn.microsoft.com/en-us/windows-server/get-started/hardware-requirements Defender on Windows Server is the Windows-Defender feature: https://learn.microsoft.com/en-us/defender-endpoint/microsoft-defender-antivirus-windows-server-configure The 180-day evaluation must be activated online within its first 10 days. The unattend generator is written for Windows 10 and 11. For Server 2025, enter the product key (generic or real) and select the image by name or index. Setup finds Autounattend.xml at the root of removable media: a second small ISO, or the Windows ISO rebuilt with oscdimg. Steps are on the companion site.</a:t>
             </a:r>
           </a:p>
         </p:txBody>
@@ -20025,6 +20025,13 @@
             <a:r>
               <a:rPr/>
               <a:t>File extensions and hidden files shown</a:t>
+            </a:r>
+          </a:p>
+          <a:p>
+            <a:pPr lvl="0"/>
+            <a:r>
+              <a:rPr/>
+              <a:t>Clock: UTC, or a second clock set to UTC</a:t>
             </a:r>
           </a:p>
         </p:txBody>

</xml_diff>

<commit_message>
DFIR: WSL 1 inside Workstation, full suggested tool list
- WSL section: WSL 2 needs nested virtualization, which Workstation refused on
  a host running VBS (tested); WSL 1 install commands
- Tool table grouped by job with the common DFIR distribution tools, Chocolatey
  packages checked; plaso in WSL from the GIFT PPA
- Deck: Suggested tool list slide; outline updated

Co-Authored-By: Claude Opus 5.5 <noreply@anthropic.com>
</commit_message>
<xml_diff>
--- a/docs/files/crt-essentials.pptx
+++ b/docs/files/crt-essentials.pptx
@@ -5,7 +5,7 @@
     <p:sldMasterId id="2147483648" r:id="rId1"/>
   </p:sldMasterIdLst>
   <p:notesMasterIdLst>
-    <p:notesMasterId r:id="rId63"/>
+    <p:notesMasterId r:id="rId64"/>
   </p:notesMasterIdLst>
   <p:sldIdLst>
     <p:sldId id="256" r:id="rId2"/>
@@ -69,6 +69,7 @@
     <p:sldId id="314" r:id="rId60"/>
     <p:sldId id="315" r:id="rId61"/>
     <p:sldId id="316" r:id="rId62"/>
+    <p:sldId id="317" r:id="rId63"/>
   </p:sldIdLst>
   <p:sldSz cx="12192000" cy="6858000"/>
   <p:notesSz cx="6858000" cy="9144000"/>
@@ -3814,7 +3815,7 @@
             </a:pPr>
             <a:r>
               <a:rPr/>
-              <a:t>The full line on the companion site also installs 7-Zip, Sysinternals and PowerShell 7. KAPE, FTK Imager, Chainsaw and Hayabusa are direct downloads; Chocolatey’s “chainsaw” package is a different program. Plaso runs on Windows through Docker. KAPE and the community KapeFiles repository: https://github.com/EricZimmerman/KapeFiles KAPE is free for CRT members; commercial use needs a Kroll enterprise license: https://www.kroll.com/en/kape-license-agreement</a:t>
+              <a:t>The full line on the companion site also installs 7-Zip, Sysinternals and PowerShell 7. KAPE, FTK Imager, Chainsaw and Hayabusa are direct downloads; Chocolatey’s “chainsaw” package is a different program. Plaso runs in WSL (Ubuntu, GIFT PPA). KAPE and the community KapeFiles repository: https://github.com/EricZimmerman/KapeFiles KAPE is free for CRT members; commercial use needs a Kroll enterprise license: https://www.kroll.com/en/kape-license-agreement</a:t>
             </a:r>
           </a:p>
         </p:txBody>
@@ -3896,7 +3897,7 @@
             </a:pPr>
             <a:r>
               <a:rPr/>
-              <a:t>Read from the read-only Evidence share, write to Cases. Before power-off, confirm the output is on the Cases share; after power-on, confirm the system disk is clean.</a:t>
+              <a:t>The common Windows tools from DFIR distributions such as FLARE-VM and the SIFT Workstation. Install commands are on the companion site. WSL 2 needs nested virtualization, which VMware Workstation cannot provide while the host runs Hyper-V or virtualization-based security (Broadcom KB 389469). WSL 1 does not use virtualization: wsl.exe –install –enable-wsl1 –no-distribution, then wsl.exe –set-default-version 1.</a:t>
             </a:r>
           </a:p>
         </p:txBody>
@@ -3919,6 +3920,88 @@
             <a:fld id="{18BDFEC3-8487-43E8-A154-7C12CBC1FFF2}" type="slidenum">
               <a:rPr lang="en-US"/>
               <a:t>56</a:t>
+            </a:fld>
+            <a:endParaRPr lang="en-US"/>
+          </a:p>
+        </p:txBody>
+      </p:sp>
+    </p:spTree>
+  </p:cSld>
+</p:notes>
+</file>
+
+<file path=ppt/notesSlides/notesSlide45.xml><?xml version="1.0" encoding="utf-8"?>
+<p:notes xmlns:a="http://schemas.openxmlformats.org/drawingml/2006/main" xmlns:r="http://schemas.openxmlformats.org/officeDocument/2006/relationships" xmlns:p="http://schemas.openxmlformats.org/presentationml/2006/main">
+  <p:cSld>
+    <p:spTree>
+      <p:nvGrpSpPr>
+        <p:cNvPr id="1" name=""/>
+        <p:cNvGrpSpPr/>
+        <p:nvPr/>
+      </p:nvGrpSpPr>
+      <p:grpSpPr>
+        <a:xfrm>
+          <a:off x="0" y="0"/>
+          <a:ext cx="0" cy="0"/>
+          <a:chOff x="0" y="0"/>
+          <a:chExt cx="0" cy="0"/>
+        </a:xfrm>
+      </p:grpSpPr>
+      <p:sp>
+        <p:nvSpPr>
+          <p:cNvPr id="2" name="Slide Image Placeholder 1"/>
+          <p:cNvSpPr>
+            <a:spLocks noGrp="1" noRot="1" noChangeAspect="1"/>
+          </p:cNvSpPr>
+          <p:nvPr>
+            <p:ph type="sldImg"/>
+          </p:nvPr>
+        </p:nvSpPr>
+        <p:spPr/>
+      </p:sp>
+      <p:sp>
+        <p:nvSpPr>
+          <p:cNvPr id="3" name="Notes Placeholder 2"/>
+          <p:cNvSpPr>
+            <a:spLocks noGrp="1"/>
+          </p:cNvSpPr>
+          <p:nvPr>
+            <p:ph type="body" idx="1"/>
+          </p:nvPr>
+        </p:nvSpPr>
+        <p:spPr/>
+        <p:txBody>
+          <a:bodyPr/>
+          <a:lstStyle/>
+          <a:p>
+            <a:pPr lvl="0" indent="0" marL="0">
+              <a:buNone/>
+            </a:pPr>
+            <a:r>
+              <a:rPr/>
+              <a:t>Read from the read-only Evidence share, write to Cases. Before power-off, confirm the output is on the Cases share; after power-on, confirm the system disk is clean.</a:t>
+            </a:r>
+          </a:p>
+        </p:txBody>
+      </p:sp>
+      <p:sp>
+        <p:nvSpPr>
+          <p:cNvPr id="4" name="Slide Number Placeholder 3"/>
+          <p:cNvSpPr>
+            <a:spLocks noGrp="1"/>
+          </p:cNvSpPr>
+          <p:nvPr>
+            <p:ph type="sldNum" sz="quarter" idx="10"/>
+          </p:nvPr>
+        </p:nvSpPr>
+        <p:spPr/>
+        <p:txBody>
+          <a:bodyPr/>
+          <a:lstStyle/>
+          <a:p>
+            <a:fld id="{18BDFEC3-8487-43E8-A154-7C12CBC1FFF2}" type="slidenum">
+              <a:rPr lang="en-US"/>
+              <a:t>57</a:t>
             </a:fld>
             <a:endParaRPr lang="en-US"/>
           </a:p>
@@ -20401,7 +20484,7 @@
             </a:pPr>
             <a:r>
               <a:rPr/>
-              <a:t>Using and resetting the box</a:t>
+              <a:t>Suggested tool list</a:t>
             </a:r>
           </a:p>
         </p:txBody>
@@ -20424,21 +20507,35 @@
             <a:pPr lvl="0"/>
             <a:r>
               <a:rPr/>
-              <a:t>Run tools against existing artifacts</a:t>
+              <a:t>Parsing and timelines: Eric Zimmerman’s tools, KAPE, Chainsaw, Hayabusa, plaso</a:t>
             </a:r>
           </a:p>
           <a:p>
             <a:pPr lvl="0"/>
             <a:r>
               <a:rPr/>
-              <a:t>Retain the results and relevant logs</a:t>
+              <a:t>Disk images and memory: FTK Imager, Arsenal Image Mounter, Autopsy, Volatility 3</a:t>
             </a:r>
           </a:p>
           <a:p>
             <a:pPr lvl="0"/>
             <a:r>
               <a:rPr/>
-              <a:t>Verify the environment and reset it for the next case</a:t>
+              <a:t>Files, documents and network: CyberChef, ExifTool, pestudio, oletools, Wireshark</a:t>
+            </a:r>
+          </a:p>
+          <a:p>
+            <a:pPr lvl="0"/>
+            <a:r>
+              <a:rPr/>
+              <a:t>Basics: 7-Zip, Sysinternals, VS Code, PowerShell 7, Office if licensed</a:t>
+            </a:r>
+          </a:p>
+          <a:p>
+            <a:pPr lvl="0"/>
+            <a:r>
+              <a:rPr/>
+              <a:t>Linux tools: WSL 1</a:t>
             </a:r>
           </a:p>
         </p:txBody>
@@ -20562,8 +20659,8 @@
         </p:nvSpPr>
         <p:spPr>
           <a:xfrm>
-            <a:off x="548640" y="1828800"/>
-            <a:ext cx="6766560" cy="2377440"/>
+            <a:off x="548640" y="347472"/>
+            <a:ext cx="11094720" cy="841248"/>
           </a:xfrm>
           <a:prstGeom prst="rect">
             <a:avLst/>
@@ -20578,14 +20675,51 @@
             </a:pPr>
             <a:r>
               <a:rPr/>
-              <a:t>Questions?</a:t>
-            </a:r>
-          </a:p>
-        </p:txBody>
-      </p:sp>
-      <p:sp>
-        <p:nvSpPr>
-          <p:cNvPr id="5" name="Footer Placeholder"/>
+              <a:t>Using and resetting the box</a:t>
+            </a:r>
+          </a:p>
+        </p:txBody>
+      </p:sp>
+      <p:sp>
+        <p:nvSpPr>
+          <p:cNvPr id="3" name="Content Placeholder 3"/>
+          <p:cNvSpPr>
+            <a:spLocks noGrp="1"/>
+          </p:cNvSpPr>
+          <p:nvPr>
+            <p:ph idx="1"/>
+          </p:nvPr>
+        </p:nvSpPr>
+        <p:spPr/>
+        <p:txBody>
+          <a:bodyPr/>
+          <a:lstStyle/>
+          <a:p>
+            <a:pPr lvl="0"/>
+            <a:r>
+              <a:rPr/>
+              <a:t>Run tools against existing artifacts</a:t>
+            </a:r>
+          </a:p>
+          <a:p>
+            <a:pPr lvl="0"/>
+            <a:r>
+              <a:rPr/>
+              <a:t>Retain the results and relevant logs</a:t>
+            </a:r>
+          </a:p>
+          <a:p>
+            <a:pPr lvl="0"/>
+            <a:r>
+              <a:rPr/>
+              <a:t>Verify the environment and reset it for the next case</a:t>
+            </a:r>
+          </a:p>
+        </p:txBody>
+      </p:sp>
+      <p:sp>
+        <p:nvSpPr>
+          <p:cNvPr id="4" name="Footer Placeholder"/>
           <p:cNvSpPr>
             <a:spLocks noGrp="1"/>
           </p:cNvSpPr>
@@ -20611,7 +20745,7 @@
               <a:buNone/>
               <a:defRPr spc="10" sz="1000">
                 <a:solidFill>
-                  <a:srgbClr val="8DA2BE"/>
+                  <a:srgbClr val="5A6472"/>
                 </a:solidFill>
                 <a:latin typeface="+mn-lt"/>
               </a:defRPr>
@@ -20627,7 +20761,7 @@
       </p:sp>
       <p:sp>
         <p:nvSpPr>
-          <p:cNvPr id="6" name="Slide Number Placeholder"/>
+          <p:cNvPr id="5" name="Slide Number Placeholder"/>
           <p:cNvSpPr>
             <a:spLocks noGrp="1"/>
           </p:cNvSpPr>
@@ -20653,7 +20787,7 @@
               <a:buNone/>
               <a:defRPr spc="10" sz="1000">
                 <a:solidFill>
-                  <a:srgbClr val="8DA2BE"/>
+                  <a:srgbClr val="5A6472"/>
                 </a:solidFill>
                 <a:latin typeface="+mn-lt"/>
               </a:defRPr>
@@ -20718,7 +20852,7 @@
             </a:pPr>
             <a:r>
               <a:rPr/>
-              <a:t>Wrap-Up</a:t>
+              <a:t>Questions?</a:t>
             </a:r>
           </a:p>
         </p:txBody>
@@ -20842,8 +20976,8 @@
         </p:nvSpPr>
         <p:spPr>
           <a:xfrm>
-            <a:off x="548640" y="347472"/>
-            <a:ext cx="11094720" cy="841248"/>
+            <a:off x="548640" y="1828800"/>
+            <a:ext cx="6766560" cy="2377440"/>
           </a:xfrm>
           <a:prstGeom prst="rect">
             <a:avLst/>
@@ -20858,95 +20992,14 @@
             </a:pPr>
             <a:r>
               <a:rPr/>
-              <a:t>Key takeaways</a:t>
-            </a:r>
-          </a:p>
-        </p:txBody>
-      </p:sp>
-      <p:sp>
-        <p:nvSpPr>
-          <p:cNvPr id="3" name="Content Placeholder 3"/>
-          <p:cNvSpPr>
-            <a:spLocks noGrp="1"/>
-          </p:cNvSpPr>
-          <p:nvPr>
-            <p:ph idx="1"/>
-          </p:nvPr>
-        </p:nvSpPr>
-        <p:spPr/>
-        <p:txBody>
-          <a:bodyPr/>
-          <a:lstStyle/>
-          <a:p>
-            <a:pPr lvl="0"/>
-            <a:r>
-              <a:rPr b="1"/>
-              <a:t>Passwords:</a:t>
-            </a:r>
-            <a:r>
-              <a:rPr/>
-              <a:t> unique, long, checked against breaches, with MFA</a:t>
-            </a:r>
-          </a:p>
-          <a:p>
-            <a:pPr lvl="0"/>
-            <a:r>
-              <a:rPr b="1"/>
-              <a:t>PKI:</a:t>
-            </a:r>
-            <a:r>
-              <a:rPr/>
-              <a:t> a certificate binds a key to a name; validation checks name, dates, chain, trust and usage</a:t>
-            </a:r>
-          </a:p>
-          <a:p>
-            <a:pPr lvl="0"/>
-            <a:r>
-              <a:rPr b="1"/>
-              <a:t>Email:</a:t>
-            </a:r>
-            <a:r>
-              <a:rPr/>
-              <a:t> DMARC starts with the </a:t>
-            </a:r>
-            <a:r>
-              <a:rPr>
-                <a:latin typeface="Consolas"/>
-              </a:rPr>
-              <a:t>From</a:t>
-            </a:r>
-            <a:r>
-              <a:rPr/>
-              <a:t> domain and needs an aligned pass</a:t>
-            </a:r>
-          </a:p>
-          <a:p>
-            <a:pPr lvl="0"/>
-            <a:r>
-              <a:rPr b="1"/>
-              <a:t>PowerShell:</a:t>
-            </a:r>
-            <a:r>
-              <a:rPr/>
-              <a:t> objects in a pipeline turn a task into something repeatable</a:t>
-            </a:r>
-          </a:p>
-          <a:p>
-            <a:pPr lvl="0"/>
-            <a:r>
-              <a:rPr b="1"/>
-              <a:t>DFIR box:</a:t>
-            </a:r>
-            <a:r>
-              <a:rPr/>
-              <a:t> a disposable analysis VM with case data kept elsewhere</a:t>
-            </a:r>
-          </a:p>
-        </p:txBody>
-      </p:sp>
-      <p:sp>
-        <p:nvSpPr>
-          <p:cNvPr id="4" name="Footer Placeholder"/>
+              <a:t>Wrap-Up</a:t>
+            </a:r>
+          </a:p>
+        </p:txBody>
+      </p:sp>
+      <p:sp>
+        <p:nvSpPr>
+          <p:cNvPr id="5" name="Footer Placeholder"/>
           <p:cNvSpPr>
             <a:spLocks noGrp="1"/>
           </p:cNvSpPr>
@@ -20972,7 +21025,7 @@
               <a:buNone/>
               <a:defRPr spc="10" sz="1000">
                 <a:solidFill>
-                  <a:srgbClr val="5A6472"/>
+                  <a:srgbClr val="8DA2BE"/>
                 </a:solidFill>
                 <a:latin typeface="+mn-lt"/>
               </a:defRPr>
@@ -20988,7 +21041,7 @@
       </p:sp>
       <p:sp>
         <p:nvSpPr>
-          <p:cNvPr id="5" name="Slide Number Placeholder"/>
+          <p:cNvPr id="6" name="Slide Number Placeholder"/>
           <p:cNvSpPr>
             <a:spLocks noGrp="1"/>
           </p:cNvSpPr>
@@ -21014,7 +21067,7 @@
               <a:buNone/>
               <a:defRPr spc="10" sz="1000">
                 <a:solidFill>
-                  <a:srgbClr val="5A6472"/>
+                  <a:srgbClr val="8DA2BE"/>
                 </a:solidFill>
                 <a:latin typeface="+mn-lt"/>
               </a:defRPr>
@@ -21285,7 +21338,7 @@
             </a:pPr>
             <a:r>
               <a:rPr/>
-              <a:t>References</a:t>
+              <a:t>Key takeaways</a:t>
             </a:r>
           </a:p>
         </p:txBody>
@@ -21307,45 +21360,66 @@
           <a:p>
             <a:pPr lvl="0"/>
             <a:r>
-              <a:rPr/>
-              <a:t>NIST SP 800-63B-4: pages.nist.gov/800-63-4/sp800-63b.html</a:t>
+              <a:rPr b="1"/>
+              <a:t>Passwords:</a:t>
+            </a:r>
+            <a:r>
+              <a:rPr/>
+              <a:t> unique, long, checked against breaches, with MFA</a:t>
             </a:r>
           </a:p>
           <a:p>
             <a:pPr lvl="0"/>
             <a:r>
-              <a:rPr/>
-              <a:t>RFC 5280, RFC 9525, RFC 2986, RFC 8555 (PKI)</a:t>
+              <a:rPr b="1"/>
+              <a:t>PKI:</a:t>
+            </a:r>
+            <a:r>
+              <a:rPr/>
+              <a:t> a certificate binds a key to a name; validation checks name, dates, chain, trust and usage</a:t>
             </a:r>
           </a:p>
           <a:p>
             <a:pPr lvl="0"/>
             <a:r>
-              <a:rPr/>
-              <a:t>RFC 5321, RFC 6409, RFC 5322, RFC 7208, RFC 6376, RFC 9989, RFC 9990, RFC 9991 (email)</a:t>
+              <a:rPr b="1"/>
+              <a:t>Email:</a:t>
+            </a:r>
+            <a:r>
+              <a:rPr/>
+              <a:t> DMARC starts with the </a:t>
+            </a:r>
+            <a:r>
+              <a:rPr>
+                <a:latin typeface="Consolas"/>
+              </a:rPr>
+              <a:t>From</a:t>
+            </a:r>
+            <a:r>
+              <a:rPr/>
+              <a:t> domain and needs an aligned pass</a:t>
             </a:r>
           </a:p>
           <a:p>
             <a:pPr lvl="0"/>
             <a:r>
-              <a:rPr/>
-              <a:t>Microsoft Learn: about_Pipelines, about_Modules, Get-WinEvent, Export-Csv</a:t>
+              <a:rPr b="1"/>
+              <a:t>PowerShell:</a:t>
+            </a:r>
+            <a:r>
+              <a:rPr/>
+              <a:t> objects in a pipeline turn a task into something repeatable</a:t>
             </a:r>
           </a:p>
           <a:p>
             <a:pPr lvl="0"/>
             <a:r>
-              <a:rPr/>
-              <a:t>Full list with links on the companion site</a:t>
-            </a:r>
-          </a:p>
-          <a:p>
-            <a:pPr lvl="0" indent="0" marL="0">
-              <a:buNone/>
-            </a:pPr>
-            <a:r>
               <a:rPr b="1"/>
-              <a:t>dzampino.github.io/crt-essentials-2026</a:t>
+              <a:t>DFIR box:</a:t>
+            </a:r>
+            <a:r>
+              <a:rPr/>
+              <a:t> a disposable analysis VM with case data kept elsewhere</a:t>
             </a:r>
           </a:p>
         </p:txBody>
@@ -21441,6 +21515,206 @@
 </file>
 
 <file path=ppt/slides/slide61.xml><?xml version="1.0" encoding="utf-8"?>
+<p:sld xmlns:a="http://schemas.openxmlformats.org/drawingml/2006/main" xmlns:r="http://schemas.openxmlformats.org/officeDocument/2006/relationships" xmlns:p="http://schemas.openxmlformats.org/presentationml/2006/main">
+  <p:cSld>
+    <p:spTree>
+      <p:nvGrpSpPr>
+        <p:cNvPr id="1" name=""/>
+        <p:cNvGrpSpPr/>
+        <p:nvPr/>
+      </p:nvGrpSpPr>
+      <p:grpSpPr>
+        <a:xfrm>
+          <a:off x="0" y="0"/>
+          <a:ext cx="0" cy="0"/>
+          <a:chOff x="0" y="0"/>
+          <a:chExt cx="0" cy="0"/>
+        </a:xfrm>
+      </p:grpSpPr>
+      <p:sp>
+        <p:nvSpPr>
+          <p:cNvPr id="2" name="Title 1"/>
+          <p:cNvSpPr>
+            <a:spLocks noGrp="1"/>
+          </p:cNvSpPr>
+          <p:nvPr>
+            <p:ph type="title"/>
+          </p:nvPr>
+        </p:nvSpPr>
+        <p:spPr>
+          <a:xfrm>
+            <a:off x="548640" y="347472"/>
+            <a:ext cx="11094720" cy="841248"/>
+          </a:xfrm>
+          <a:prstGeom prst="rect">
+            <a:avLst/>
+          </a:prstGeom>
+        </p:spPr>
+        <p:txBody>
+          <a:bodyPr/>
+          <a:lstStyle/>
+          <a:p>
+            <a:pPr lvl="0" indent="0" marL="0">
+              <a:buNone/>
+            </a:pPr>
+            <a:r>
+              <a:rPr/>
+              <a:t>References</a:t>
+            </a:r>
+          </a:p>
+        </p:txBody>
+      </p:sp>
+      <p:sp>
+        <p:nvSpPr>
+          <p:cNvPr id="3" name="Content Placeholder 3"/>
+          <p:cNvSpPr>
+            <a:spLocks noGrp="1"/>
+          </p:cNvSpPr>
+          <p:nvPr>
+            <p:ph idx="1"/>
+          </p:nvPr>
+        </p:nvSpPr>
+        <p:spPr/>
+        <p:txBody>
+          <a:bodyPr/>
+          <a:lstStyle/>
+          <a:p>
+            <a:pPr lvl="0"/>
+            <a:r>
+              <a:rPr/>
+              <a:t>NIST SP 800-63B-4: pages.nist.gov/800-63-4/sp800-63b.html</a:t>
+            </a:r>
+          </a:p>
+          <a:p>
+            <a:pPr lvl="0"/>
+            <a:r>
+              <a:rPr/>
+              <a:t>RFC 5280, RFC 9525, RFC 2986, RFC 8555 (PKI)</a:t>
+            </a:r>
+          </a:p>
+          <a:p>
+            <a:pPr lvl="0"/>
+            <a:r>
+              <a:rPr/>
+              <a:t>RFC 5321, RFC 6409, RFC 5322, RFC 7208, RFC 6376, RFC 9989, RFC 9990, RFC 9991 (email)</a:t>
+            </a:r>
+          </a:p>
+          <a:p>
+            <a:pPr lvl="0"/>
+            <a:r>
+              <a:rPr/>
+              <a:t>Microsoft Learn: about_Pipelines, about_Modules, Get-WinEvent, Export-Csv</a:t>
+            </a:r>
+          </a:p>
+          <a:p>
+            <a:pPr lvl="0"/>
+            <a:r>
+              <a:rPr/>
+              <a:t>Full list with links on the companion site</a:t>
+            </a:r>
+          </a:p>
+          <a:p>
+            <a:pPr lvl="0" indent="0" marL="0">
+              <a:buNone/>
+            </a:pPr>
+            <a:r>
+              <a:rPr b="1"/>
+              <a:t>dzampino.github.io/crt-essentials-2026</a:t>
+            </a:r>
+          </a:p>
+        </p:txBody>
+      </p:sp>
+      <p:sp>
+        <p:nvSpPr>
+          <p:cNvPr id="4" name="Footer Placeholder"/>
+          <p:cNvSpPr>
+            <a:spLocks noGrp="1"/>
+          </p:cNvSpPr>
+          <p:nvPr>
+            <p:ph idx="11" sz="quarter" type="ftr"/>
+          </p:nvPr>
+        </p:nvSpPr>
+        <p:spPr>
+          <a:xfrm>
+            <a:off x="1005840" y="6345936"/>
+            <a:ext cx="6949440" cy="274320"/>
+          </a:xfrm>
+          <a:prstGeom prst="rect">
+            <a:avLst/>
+          </a:prstGeom>
+        </p:spPr>
+        <p:txBody>
+          <a:bodyPr anchor="ctr" bIns="0" lIns="0" rIns="0" rtlCol="0" tIns="0" vert="horz" wrap="square">
+            <a:noAutofit/>
+          </a:bodyPr>
+          <a:lstStyle>
+            <a:lvl1pPr algn="l" indent="0" marL="0">
+              <a:buNone/>
+              <a:defRPr spc="10" sz="1000">
+                <a:solidFill>
+                  <a:srgbClr val="5A6472"/>
+                </a:solidFill>
+                <a:latin typeface="+mn-lt"/>
+              </a:defRPr>
+            </a:lvl1pPr>
+          </a:lstStyle>
+          <a:p>
+            <a:r>
+              <a:rPr lang="en-US"/>
+              <a:t>CRT Annual Training Conference 2026</a:t>
+            </a:r>
+          </a:p>
+        </p:txBody>
+      </p:sp>
+      <p:sp>
+        <p:nvSpPr>
+          <p:cNvPr id="5" name="Slide Number Placeholder"/>
+          <p:cNvSpPr>
+            <a:spLocks noGrp="1"/>
+          </p:cNvSpPr>
+          <p:nvPr>
+            <p:ph idx="12" sz="quarter" type="sldNum"/>
+          </p:nvPr>
+        </p:nvSpPr>
+        <p:spPr>
+          <a:xfrm>
+            <a:off x="11186160" y="6345936"/>
+            <a:ext cx="457200" cy="274320"/>
+          </a:xfrm>
+          <a:prstGeom prst="rect">
+            <a:avLst/>
+          </a:prstGeom>
+        </p:spPr>
+        <p:txBody>
+          <a:bodyPr anchor="ctr" bIns="0" lIns="0" rIns="0" rtlCol="0" tIns="0" vert="horz" wrap="square">
+            <a:noAutofit/>
+          </a:bodyPr>
+          <a:lstStyle>
+            <a:lvl1pPr algn="r" indent="0" marL="0">
+              <a:buNone/>
+              <a:defRPr spc="10" sz="1000">
+                <a:solidFill>
+                  <a:srgbClr val="5A6472"/>
+                </a:solidFill>
+                <a:latin typeface="+mn-lt"/>
+              </a:defRPr>
+            </a:lvl1pPr>
+          </a:lstStyle>
+          <a:p>
+            <a:fld id="{8A1C2F2E-3D4B-4C6E-9F10-2B7A5C9E1D01}" type="slidenum">
+              <a:rPr lang="en-US"/>
+              <a:t>‹#›</a:t>
+            </a:fld>
+            <a:endParaRPr lang="en-US"/>
+          </a:p>
+        </p:txBody>
+      </p:sp>
+    </p:spTree>
+  </p:cSld>
+</p:sld>
+</file>
+
+<file path=ppt/slides/slide62.xml><?xml version="1.0" encoding="utf-8"?>
 <p:sld xmlns:a="http://schemas.openxmlformats.org/drawingml/2006/main" xmlns:r="http://schemas.openxmlformats.org/officeDocument/2006/relationships" xmlns:p="http://schemas.openxmlformats.org/presentationml/2006/main">
   <p:cSld>
     <p:spTree>

</xml_diff>

<commit_message>
Deck: agenda first, linked GitHub address in the footer
- Agenda moves ahead of the companion site slide
- Template footer adds github.com/dzampino/crt-essentials-2026 as a link in the
  footer's text color (quarto/add_footer_link.py); build.ps1 adds the link
  target Pandoc leaves out of each slide

Co-Authored-By: Claude Opus 5.5 <noreply@anthropic.com>
</commit_message>
<xml_diff>
--- a/docs/files/crt-essentials.pptx
+++ b/docs/files/crt-essentials.pptx
@@ -589,7 +589,7 @@
             </a:pPr>
             <a:r>
               <a:rPr/>
-              <a:t>https://dzampino.github.io/crt-essentials-2026/</a:t>
+              <a:t>Timing: introduction 5 minutes, passwords 20, PKI 25, email security 30, PowerShell 20, DFIR box 15, questions and wrap-up 5.</a:t>
             </a:r>
           </a:p>
         </p:txBody>
@@ -1631,7 +1631,7 @@
             </a:pPr>
             <a:r>
               <a:rPr/>
-              <a:t>Timing: introduction 5 minutes, passwords 20, PKI 25, email security 30, PowerShell 20, DFIR box 15, questions and wrap-up 5.</a:t>
+              <a:t>https://dzampino.github.io/crt-essentials-2026/</a:t>
             </a:r>
           </a:p>
         </p:txBody>
@@ -5439,6 +5439,22 @@
               <a:rPr lang="en-US"/>
               <a:t>CRT Annual Training Conference 2026</a:t>
             </a:r>
+            <a:r>
+              <a:rPr lang="en-US"/>
+              <a:t>  ·  </a:t>
+            </a:r>
+            <a:r>
+              <a:rPr lang="en-US">
+                <a:hlinkClick r:id="rIdGitHubFooter">
+                  <a:extLst>
+                    <a:ext uri="{A12FA001-AC4F-418D-AE19-62706E023703}">
+                      <ahyp:hlinkClr xmlns:ahyp="http://schemas.microsoft.com/office/drawing/2018/hyperlinkcolor" val="tx"/>
+                    </a:ext>
+                  </a:extLst>
+                </a:hlinkClick>
+              </a:rPr>
+              <a:t>github.com/dzampino/crt-essentials-2026</a:t>
+            </a:r>
           </a:p>
         </p:txBody>
       </p:sp>
@@ -5616,6 +5632,22 @@
               <a:rPr lang="en-US"/>
               <a:t>CRT Annual Training Conference 2026</a:t>
             </a:r>
+            <a:r>
+              <a:rPr lang="en-US"/>
+              <a:t>  ·  </a:t>
+            </a:r>
+            <a:r>
+              <a:rPr lang="en-US">
+                <a:hlinkClick r:id="rIdGitHubFooter">
+                  <a:extLst>
+                    <a:ext uri="{A12FA001-AC4F-418D-AE19-62706E023703}">
+                      <ahyp:hlinkClr xmlns:ahyp="http://schemas.microsoft.com/office/drawing/2018/hyperlinkcolor" val="tx"/>
+                    </a:ext>
+                  </a:extLst>
+                </a:hlinkClick>
+              </a:rPr>
+              <a:t>github.com/dzampino/crt-essentials-2026</a:t>
+            </a:r>
           </a:p>
         </p:txBody>
       </p:sp>
@@ -5799,6 +5831,22 @@
             <a:r>
               <a:rPr lang="en-US"/>
               <a:t>CRT Annual Training Conference 2026</a:t>
+            </a:r>
+            <a:r>
+              <a:rPr lang="en-US"/>
+              <a:t>  ·  </a:t>
+            </a:r>
+            <a:r>
+              <a:rPr lang="en-US">
+                <a:hlinkClick r:id="rIdGitHubFooter">
+                  <a:extLst>
+                    <a:ext uri="{A12FA001-AC4F-418D-AE19-62706E023703}">
+                      <ahyp:hlinkClr xmlns:ahyp="http://schemas.microsoft.com/office/drawing/2018/hyperlinkcolor" val="tx"/>
+                    </a:ext>
+                  </a:extLst>
+                </a:hlinkClick>
+              </a:rPr>
+              <a:t>github.com/dzampino/crt-essentials-2026</a:t>
             </a:r>
           </a:p>
         </p:txBody>
@@ -6059,6 +6107,22 @@
               <a:rPr lang="en-US"/>
               <a:t>CRT Annual Training Conference 2026</a:t>
             </a:r>
+            <a:r>
+              <a:rPr lang="en-US"/>
+              <a:t>  ·  </a:t>
+            </a:r>
+            <a:r>
+              <a:rPr lang="en-US">
+                <a:hlinkClick r:id="rIdGitHubFooter">
+                  <a:extLst>
+                    <a:ext uri="{A12FA001-AC4F-418D-AE19-62706E023703}">
+                      <ahyp:hlinkClr xmlns:ahyp="http://schemas.microsoft.com/office/drawing/2018/hyperlinkcolor" val="tx"/>
+                    </a:ext>
+                  </a:extLst>
+                </a:hlinkClick>
+              </a:rPr>
+              <a:t>github.com/dzampino/crt-essentials-2026</a:t>
+            </a:r>
           </a:p>
         </p:txBody>
       </p:sp>
@@ -6283,6 +6347,22 @@
               <a:rPr lang="en-US"/>
               <a:t>CRT Annual Training Conference 2026</a:t>
             </a:r>
+            <a:r>
+              <a:rPr lang="en-US"/>
+              <a:t>  ·  </a:t>
+            </a:r>
+            <a:r>
+              <a:rPr lang="en-US">
+                <a:hlinkClick r:id="rIdGitHubFooter">
+                  <a:extLst>
+                    <a:ext uri="{A12FA001-AC4F-418D-AE19-62706E023703}">
+                      <ahyp:hlinkClr xmlns:ahyp="http://schemas.microsoft.com/office/drawing/2018/hyperlinkcolor" val="tx"/>
+                    </a:ext>
+                  </a:extLst>
+                </a:hlinkClick>
+              </a:rPr>
+              <a:t>github.com/dzampino/crt-essentials-2026</a:t>
+            </a:r>
           </a:p>
         </p:txBody>
       </p:sp>
@@ -6599,6 +6679,22 @@
               <a:rPr lang="en-US"/>
               <a:t>CRT Annual Training Conference 2026</a:t>
             </a:r>
+            <a:r>
+              <a:rPr lang="en-US"/>
+              <a:t>  ·  </a:t>
+            </a:r>
+            <a:r>
+              <a:rPr lang="en-US">
+                <a:hlinkClick r:id="rIdGitHubFooter">
+                  <a:extLst>
+                    <a:ext uri="{A12FA001-AC4F-418D-AE19-62706E023703}">
+                      <ahyp:hlinkClr xmlns:ahyp="http://schemas.microsoft.com/office/drawing/2018/hyperlinkcolor" val="tx"/>
+                    </a:ext>
+                  </a:extLst>
+                </a:hlinkClick>
+              </a:rPr>
+              <a:t>github.com/dzampino/crt-essentials-2026</a:t>
+            </a:r>
           </a:p>
         </p:txBody>
       </p:sp>
@@ -6743,6 +6839,22 @@
               <a:rPr lang="en-US"/>
               <a:t>CRT Annual Training Conference 2026</a:t>
             </a:r>
+            <a:r>
+              <a:rPr lang="en-US"/>
+              <a:t>  ·  </a:t>
+            </a:r>
+            <a:r>
+              <a:rPr lang="en-US">
+                <a:hlinkClick r:id="rIdGitHubFooter">
+                  <a:extLst>
+                    <a:ext uri="{A12FA001-AC4F-418D-AE19-62706E023703}">
+                      <ahyp:hlinkClr xmlns:ahyp="http://schemas.microsoft.com/office/drawing/2018/hyperlinkcolor" val="tx"/>
+                    </a:ext>
+                  </a:extLst>
+                </a:hlinkClick>
+              </a:rPr>
+              <a:t>github.com/dzampino/crt-essentials-2026</a:t>
+            </a:r>
           </a:p>
         </p:txBody>
       </p:sp>
@@ -6854,6 +6966,22 @@
               <a:rPr lang="en-US"/>
               <a:t>CRT Annual Training Conference 2026</a:t>
             </a:r>
+            <a:r>
+              <a:rPr lang="en-US"/>
+              <a:t>  ·  </a:t>
+            </a:r>
+            <a:r>
+              <a:rPr lang="en-US">
+                <a:hlinkClick r:id="rIdGitHubFooter">
+                  <a:extLst>
+                    <a:ext uri="{A12FA001-AC4F-418D-AE19-62706E023703}">
+                      <ahyp:hlinkClr xmlns:ahyp="http://schemas.microsoft.com/office/drawing/2018/hyperlinkcolor" val="tx"/>
+                    </a:ext>
+                  </a:extLst>
+                </a:hlinkClick>
+              </a:rPr>
+              <a:t>github.com/dzampino/crt-essentials-2026</a:t>
+            </a:r>
           </a:p>
         </p:txBody>
       </p:sp>
@@ -7086,6 +7214,22 @@
               <a:rPr lang="en-US"/>
               <a:t>CRT Annual Training Conference 2026</a:t>
             </a:r>
+            <a:r>
+              <a:rPr lang="en-US"/>
+              <a:t>  ·  </a:t>
+            </a:r>
+            <a:r>
+              <a:rPr lang="en-US">
+                <a:hlinkClick r:id="rIdGitHubFooter">
+                  <a:extLst>
+                    <a:ext uri="{A12FA001-AC4F-418D-AE19-62706E023703}">
+                      <ahyp:hlinkClr xmlns:ahyp="http://schemas.microsoft.com/office/drawing/2018/hyperlinkcolor" val="tx"/>
+                    </a:ext>
+                  </a:extLst>
+                </a:hlinkClick>
+              </a:rPr>
+              <a:t>github.com/dzampino/crt-essentials-2026</a:t>
+            </a:r>
           </a:p>
         </p:txBody>
       </p:sp>
@@ -7315,6 +7459,22 @@
             <a:r>
               <a:rPr lang="en-US"/>
               <a:t>CRT Annual Training Conference 2026</a:t>
+            </a:r>
+            <a:r>
+              <a:rPr lang="en-US"/>
+              <a:t>  ·  </a:t>
+            </a:r>
+            <a:r>
+              <a:rPr lang="en-US">
+                <a:hlinkClick r:id="rIdGitHubFooter">
+                  <a:extLst>
+                    <a:ext uri="{A12FA001-AC4F-418D-AE19-62706E023703}">
+                      <ahyp:hlinkClr xmlns:ahyp="http://schemas.microsoft.com/office/drawing/2018/hyperlinkcolor" val="tx"/>
+                    </a:ext>
+                  </a:extLst>
+                </a:hlinkClick>
+              </a:rPr>
+              <a:t>github.com/dzampino/crt-essentials-2026</a:t>
             </a:r>
           </a:p>
         </p:txBody>
@@ -7571,6 +7731,22 @@
             <a:r>
               <a:rPr lang="en-US"/>
               <a:t>CRT Annual Training Conference 2026</a:t>
+            </a:r>
+            <a:r>
+              <a:rPr lang="en-US"/>
+              <a:t>  ·  </a:t>
+            </a:r>
+            <a:r>
+              <a:rPr lang="en-US">
+                <a:hlinkClick r:id="rIdGitHubFooter">
+                  <a:extLst>
+                    <a:ext uri="{A12FA001-AC4F-418D-AE19-62706E023703}">
+                      <ahyp:hlinkClr xmlns:ahyp="http://schemas.microsoft.com/office/drawing/2018/hyperlinkcolor" val="tx"/>
+                    </a:ext>
+                  </a:extLst>
+                </a:hlinkClick>
+              </a:rPr>
+              <a:t>github.com/dzampino/crt-essentials-2026</a:t>
             </a:r>
           </a:p>
         </p:txBody>
@@ -8364,6 +8540,22 @@
               <a:rPr lang="en-US"/>
               <a:t>CRT Annual Training Conference 2026</a:t>
             </a:r>
+            <a:r>
+              <a:rPr lang="en-US"/>
+              <a:t>  ·  </a:t>
+            </a:r>
+            <a:r>
+              <a:rPr lang="en-US">
+                <a:hlinkClick r:id="rIdGitHubFooter">
+                  <a:extLst>
+                    <a:ext uri="{A12FA001-AC4F-418D-AE19-62706E023703}">
+                      <ahyp:hlinkClr xmlns:ahyp="http://schemas.microsoft.com/office/drawing/2018/hyperlinkcolor" val="tx"/>
+                    </a:ext>
+                  </a:extLst>
+                </a:hlinkClick>
+              </a:rPr>
+              <a:t>github.com/dzampino/crt-essentials-2026</a:t>
+            </a:r>
           </a:p>
         </p:txBody>
       </p:sp>
@@ -8541,6 +8733,22 @@
               <a:rPr lang="en-US"/>
               <a:t>CRT Annual Training Conference 2026</a:t>
             </a:r>
+            <a:r>
+              <a:rPr lang="en-US"/>
+              <a:t>  ·  </a:t>
+            </a:r>
+            <a:r>
+              <a:rPr lang="en-US">
+                <a:hlinkClick r:id="rIdGitHubFooter">
+                  <a:extLst>
+                    <a:ext uri="{A12FA001-AC4F-418D-AE19-62706E023703}">
+                      <ahyp:hlinkClr xmlns:ahyp="http://schemas.microsoft.com/office/drawing/2018/hyperlinkcolor" val="tx"/>
+                    </a:ext>
+                  </a:extLst>
+                </a:hlinkClick>
+              </a:rPr>
+              <a:t>github.com/dzampino/crt-essentials-2026</a:t>
+            </a:r>
           </a:p>
         </p:txBody>
       </p:sp>
@@ -8725,6 +8933,22 @@
               <a:rPr lang="en-US"/>
               <a:t>CRT Annual Training Conference 2026</a:t>
             </a:r>
+            <a:r>
+              <a:rPr lang="en-US"/>
+              <a:t>  ·  </a:t>
+            </a:r>
+            <a:r>
+              <a:rPr lang="en-US">
+                <a:hlinkClick r:id="rIdGitHubFooter">
+                  <a:extLst>
+                    <a:ext uri="{A12FA001-AC4F-418D-AE19-62706E023703}">
+                      <ahyp:hlinkClr xmlns:ahyp="http://schemas.microsoft.com/office/drawing/2018/hyperlinkcolor" val="tx"/>
+                    </a:ext>
+                  </a:extLst>
+                </a:hlinkClick>
+              </a:rPr>
+              <a:t>github.com/dzampino/crt-essentials-2026</a:t>
+            </a:r>
           </a:p>
         </p:txBody>
       </p:sp>
@@ -8865,6 +9089,22 @@
               <a:rPr lang="en-US"/>
               <a:t>CRT Annual Training Conference 2026</a:t>
             </a:r>
+            <a:r>
+              <a:rPr lang="en-US"/>
+              <a:t>  ·  </a:t>
+            </a:r>
+            <a:r>
+              <a:rPr lang="en-US">
+                <a:hlinkClick r:id="rIdGitHubFooter">
+                  <a:extLst>
+                    <a:ext uri="{A12FA001-AC4F-418D-AE19-62706E023703}">
+                      <ahyp:hlinkClr xmlns:ahyp="http://schemas.microsoft.com/office/drawing/2018/hyperlinkcolor" val="tx"/>
+                    </a:ext>
+                  </a:extLst>
+                </a:hlinkClick>
+              </a:rPr>
+              <a:t>github.com/dzampino/crt-essentials-2026</a:t>
+            </a:r>
           </a:p>
         </p:txBody>
       </p:sp>
@@ -9005,6 +9245,22 @@
               <a:rPr lang="en-US"/>
               <a:t>CRT Annual Training Conference 2026</a:t>
             </a:r>
+            <a:r>
+              <a:rPr lang="en-US"/>
+              <a:t>  ·  </a:t>
+            </a:r>
+            <a:r>
+              <a:rPr lang="en-US">
+                <a:hlinkClick r:id="rIdGitHubFooter">
+                  <a:extLst>
+                    <a:ext uri="{A12FA001-AC4F-418D-AE19-62706E023703}">
+                      <ahyp:hlinkClr xmlns:ahyp="http://schemas.microsoft.com/office/drawing/2018/hyperlinkcolor" val="tx"/>
+                    </a:ext>
+                  </a:extLst>
+                </a:hlinkClick>
+              </a:rPr>
+              <a:t>github.com/dzampino/crt-essentials-2026</a:t>
+            </a:r>
           </a:p>
         </p:txBody>
       </p:sp>
@@ -9217,6 +9473,22 @@
               <a:rPr lang="en-US"/>
               <a:t>CRT Annual Training Conference 2026</a:t>
             </a:r>
+            <a:r>
+              <a:rPr lang="en-US"/>
+              <a:t>  ·  </a:t>
+            </a:r>
+            <a:r>
+              <a:rPr lang="en-US">
+                <a:hlinkClick r:id="rIdGitHubFooter">
+                  <a:extLst>
+                    <a:ext uri="{A12FA001-AC4F-418D-AE19-62706E023703}">
+                      <ahyp:hlinkClr xmlns:ahyp="http://schemas.microsoft.com/office/drawing/2018/hyperlinkcolor" val="tx"/>
+                    </a:ext>
+                  </a:extLst>
+                </a:hlinkClick>
+              </a:rPr>
+              <a:t>github.com/dzampino/crt-essentials-2026</a:t>
+            </a:r>
           </a:p>
         </p:txBody>
       </p:sp>
@@ -9463,6 +9735,22 @@
               <a:rPr lang="en-US"/>
               <a:t>CRT Annual Training Conference 2026</a:t>
             </a:r>
+            <a:r>
+              <a:rPr lang="en-US"/>
+              <a:t>  ·  </a:t>
+            </a:r>
+            <a:r>
+              <a:rPr lang="en-US">
+                <a:hlinkClick r:id="rIdGitHubFooter">
+                  <a:extLst>
+                    <a:ext uri="{A12FA001-AC4F-418D-AE19-62706E023703}">
+                      <ahyp:hlinkClr xmlns:ahyp="http://schemas.microsoft.com/office/drawing/2018/hyperlinkcolor" val="tx"/>
+                    </a:ext>
+                  </a:extLst>
+                </a:hlinkClick>
+              </a:rPr>
+              <a:t>github.com/dzampino/crt-essentials-2026</a:t>
+            </a:r>
           </a:p>
         </p:txBody>
       </p:sp>
@@ -9636,6 +9924,22 @@
             <a:r>
               <a:rPr lang="en-US"/>
               <a:t>CRT Annual Training Conference 2026</a:t>
+            </a:r>
+            <a:r>
+              <a:rPr lang="en-US"/>
+              <a:t>  ·  </a:t>
+            </a:r>
+            <a:r>
+              <a:rPr lang="en-US">
+                <a:hlinkClick r:id="rIdGitHubFooter">
+                  <a:extLst>
+                    <a:ext uri="{A12FA001-AC4F-418D-AE19-62706E023703}">
+                      <ahyp:hlinkClr xmlns:ahyp="http://schemas.microsoft.com/office/drawing/2018/hyperlinkcolor" val="tx"/>
+                    </a:ext>
+                  </a:extLst>
+                </a:hlinkClick>
+              </a:rPr>
+              <a:t>github.com/dzampino/crt-essentials-2026</a:t>
             </a:r>
           </a:p>
         </p:txBody>
@@ -9843,6 +10147,22 @@
             <a:r>
               <a:rPr lang="en-US"/>
               <a:t>CRT Annual Training Conference 2026</a:t>
+            </a:r>
+            <a:r>
+              <a:rPr lang="en-US"/>
+              <a:t>  ·  </a:t>
+            </a:r>
+            <a:r>
+              <a:rPr lang="en-US">
+                <a:hlinkClick r:id="rIdGitHubFooter">
+                  <a:extLst>
+                    <a:ext uri="{A12FA001-AC4F-418D-AE19-62706E023703}">
+                      <ahyp:hlinkClr xmlns:ahyp="http://schemas.microsoft.com/office/drawing/2018/hyperlinkcolor" val="tx"/>
+                    </a:ext>
+                  </a:extLst>
+                </a:hlinkClick>
+              </a:rPr>
+              <a:t>github.com/dzampino/crt-essentials-2026</a:t>
             </a:r>
           </a:p>
         </p:txBody>
@@ -10263,6 +10583,22 @@
               <a:rPr lang="en-US"/>
               <a:t>CRT Annual Training Conference 2026</a:t>
             </a:r>
+            <a:r>
+              <a:rPr lang="en-US"/>
+              <a:t>  ·  </a:t>
+            </a:r>
+            <a:r>
+              <a:rPr lang="en-US">
+                <a:hlinkClick r:id="rIdGitHubFooter">
+                  <a:extLst>
+                    <a:ext uri="{A12FA001-AC4F-418D-AE19-62706E023703}">
+                      <ahyp:hlinkClr xmlns:ahyp="http://schemas.microsoft.com/office/drawing/2018/hyperlinkcolor" val="tx"/>
+                    </a:ext>
+                  </a:extLst>
+                </a:hlinkClick>
+              </a:rPr>
+              <a:t>github.com/dzampino/crt-essentials-2026</a:t>
+            </a:r>
           </a:p>
         </p:txBody>
       </p:sp>
@@ -10359,41 +10695,72 @@
             </a:pPr>
             <a:r>
               <a:rPr/>
-              <a:t>dzampino.github.io/crt-essentials-2026</a:t>
-            </a:r>
-          </a:p>
-        </p:txBody>
-      </p:sp>
-      <p:pic>
-        <p:nvPicPr>
-          <p:cNvPr descr="QR code linking to dzampino.github.io/crt-essentials-2026" id="0" name="Picture 1"/>
-          <p:cNvPicPr>
-            <a:picLocks noGrp="1" noChangeAspect="1"/>
-          </p:cNvPicPr>
-          <p:nvPr/>
-        </p:nvPicPr>
-        <p:blipFill>
-          <a:blip r:embed="rId3"/>
-          <a:stretch>
-            <a:fillRect/>
-          </a:stretch>
-        </p:blipFill>
-        <p:spPr bwMode="auto">
-          <a:xfrm>
-            <a:off x="3784600" y="1435100"/>
-            <a:ext cx="4597400" cy="4597400"/>
-          </a:xfrm>
-          <a:prstGeom prst="rect">
-            <a:avLst/>
-          </a:prstGeom>
-          <a:noFill/>
-          <a:ln w="9525">
-            <a:noFill/>
-            <a:headEnd/>
-            <a:tailEnd/>
-          </a:ln>
-        </p:spPr>
-      </p:pic>
+              <a:t>Agenda</a:t>
+            </a:r>
+          </a:p>
+        </p:txBody>
+      </p:sp>
+      <p:sp>
+        <p:nvSpPr>
+          <p:cNvPr id="3" name="Content Placeholder 3"/>
+          <p:cNvSpPr>
+            <a:spLocks noGrp="1"/>
+          </p:cNvSpPr>
+          <p:nvPr>
+            <p:ph idx="1"/>
+          </p:nvPr>
+        </p:nvSpPr>
+        <p:spPr/>
+        <p:txBody>
+          <a:bodyPr/>
+          <a:lstStyle/>
+          <a:p>
+            <a:pPr lvl="0">
+              <a:buAutoNum type="arabicPeriod"/>
+            </a:pPr>
+            <a:r>
+              <a:rPr/>
+              <a:t>Passwords</a:t>
+            </a:r>
+          </a:p>
+          <a:p>
+            <a:pPr lvl="0">
+              <a:buAutoNum type="arabicPeriod"/>
+            </a:pPr>
+            <a:r>
+              <a:rPr/>
+              <a:t>PKI</a:t>
+            </a:r>
+          </a:p>
+          <a:p>
+            <a:pPr lvl="0">
+              <a:buAutoNum type="arabicPeriod"/>
+            </a:pPr>
+            <a:r>
+              <a:rPr/>
+              <a:t>Email security</a:t>
+            </a:r>
+          </a:p>
+          <a:p>
+            <a:pPr lvl="0">
+              <a:buAutoNum type="arabicPeriod"/>
+            </a:pPr>
+            <a:r>
+              <a:rPr/>
+              <a:t>PowerShell</a:t>
+            </a:r>
+          </a:p>
+          <a:p>
+            <a:pPr lvl="0">
+              <a:buAutoNum type="arabicPeriod"/>
+            </a:pPr>
+            <a:r>
+              <a:rPr/>
+              <a:t>Building a Windows DFIR box</a:t>
+            </a:r>
+          </a:p>
+        </p:txBody>
+      </p:sp>
       <p:sp>
         <p:nvSpPr>
           <p:cNvPr id="4" name="Footer Placeholder"/>
@@ -10432,6 +10799,22 @@
             <a:r>
               <a:rPr lang="en-US"/>
               <a:t>CRT Annual Training Conference 2026</a:t>
+            </a:r>
+            <a:r>
+              <a:rPr lang="en-US"/>
+              <a:t>  ·  </a:t>
+            </a:r>
+            <a:r>
+              <a:rPr lang="en-US">
+                <a:hlinkClick r:id="rIdGitHubFooter">
+                  <a:extLst>
+                    <a:ext uri="{A12FA001-AC4F-418D-AE19-62706E023703}">
+                      <ahyp:hlinkClr xmlns:ahyp="http://schemas.microsoft.com/office/drawing/2018/hyperlinkcolor" val="tx"/>
+                    </a:ext>
+                  </a:extLst>
+                </a:hlinkClick>
+              </a:rPr>
+              <a:t>github.com/dzampino/crt-essentials-2026</a:t>
             </a:r>
           </a:p>
         </p:txBody>
@@ -10660,6 +11043,22 @@
               <a:rPr lang="en-US"/>
               <a:t>CRT Annual Training Conference 2026</a:t>
             </a:r>
+            <a:r>
+              <a:rPr lang="en-US"/>
+              <a:t>  ·  </a:t>
+            </a:r>
+            <a:r>
+              <a:rPr lang="en-US">
+                <a:hlinkClick r:id="rIdGitHubFooter">
+                  <a:extLst>
+                    <a:ext uri="{A12FA001-AC4F-418D-AE19-62706E023703}">
+                      <ahyp:hlinkClr xmlns:ahyp="http://schemas.microsoft.com/office/drawing/2018/hyperlinkcolor" val="tx"/>
+                    </a:ext>
+                  </a:extLst>
+                </a:hlinkClick>
+              </a:rPr>
+              <a:t>github.com/dzampino/crt-essentials-2026</a:t>
+            </a:r>
           </a:p>
         </p:txBody>
       </p:sp>
@@ -10857,6 +11256,22 @@
             <a:r>
               <a:rPr lang="en-US"/>
               <a:t>CRT Annual Training Conference 2026</a:t>
+            </a:r>
+            <a:r>
+              <a:rPr lang="en-US"/>
+              <a:t>  ·  </a:t>
+            </a:r>
+            <a:r>
+              <a:rPr lang="en-US">
+                <a:hlinkClick r:id="rIdGitHubFooter">
+                  <a:extLst>
+                    <a:ext uri="{A12FA001-AC4F-418D-AE19-62706E023703}">
+                      <ahyp:hlinkClr xmlns:ahyp="http://schemas.microsoft.com/office/drawing/2018/hyperlinkcolor" val="tx"/>
+                    </a:ext>
+                  </a:extLst>
+                </a:hlinkClick>
+              </a:rPr>
+              <a:t>github.com/dzampino/crt-essentials-2026</a:t>
             </a:r>
           </a:p>
         </p:txBody>
@@ -11225,6 +11640,22 @@
               <a:rPr lang="en-US"/>
               <a:t>CRT Annual Training Conference 2026</a:t>
             </a:r>
+            <a:r>
+              <a:rPr lang="en-US"/>
+              <a:t>  ·  </a:t>
+            </a:r>
+            <a:r>
+              <a:rPr lang="en-US">
+                <a:hlinkClick r:id="rIdGitHubFooter">
+                  <a:extLst>
+                    <a:ext uri="{A12FA001-AC4F-418D-AE19-62706E023703}">
+                      <ahyp:hlinkClr xmlns:ahyp="http://schemas.microsoft.com/office/drawing/2018/hyperlinkcolor" val="tx"/>
+                    </a:ext>
+                  </a:extLst>
+                </a:hlinkClick>
+              </a:rPr>
+              <a:t>github.com/dzampino/crt-essentials-2026</a:t>
+            </a:r>
           </a:p>
         </p:txBody>
       </p:sp>
@@ -11560,6 +11991,22 @@
               <a:rPr lang="en-US"/>
               <a:t>CRT Annual Training Conference 2026</a:t>
             </a:r>
+            <a:r>
+              <a:rPr lang="en-US"/>
+              <a:t>  ·  </a:t>
+            </a:r>
+            <a:r>
+              <a:rPr lang="en-US">
+                <a:hlinkClick r:id="rIdGitHubFooter">
+                  <a:extLst>
+                    <a:ext uri="{A12FA001-AC4F-418D-AE19-62706E023703}">
+                      <ahyp:hlinkClr xmlns:ahyp="http://schemas.microsoft.com/office/drawing/2018/hyperlinkcolor" val="tx"/>
+                    </a:ext>
+                  </a:extLst>
+                </a:hlinkClick>
+              </a:rPr>
+              <a:t>github.com/dzampino/crt-essentials-2026</a:t>
+            </a:r>
           </a:p>
         </p:txBody>
       </p:sp>
@@ -11700,6 +12147,22 @@
               <a:rPr lang="en-US"/>
               <a:t>CRT Annual Training Conference 2026</a:t>
             </a:r>
+            <a:r>
+              <a:rPr lang="en-US"/>
+              <a:t>  ·  </a:t>
+            </a:r>
+            <a:r>
+              <a:rPr lang="en-US">
+                <a:hlinkClick r:id="rIdGitHubFooter">
+                  <a:extLst>
+                    <a:ext uri="{A12FA001-AC4F-418D-AE19-62706E023703}">
+                      <ahyp:hlinkClr xmlns:ahyp="http://schemas.microsoft.com/office/drawing/2018/hyperlinkcolor" val="tx"/>
+                    </a:ext>
+                  </a:extLst>
+                </a:hlinkClick>
+              </a:rPr>
+              <a:t>github.com/dzampino/crt-essentials-2026</a:t>
+            </a:r>
           </a:p>
         </p:txBody>
       </p:sp>
@@ -11839,6 +12302,22 @@
             <a:r>
               <a:rPr lang="en-US"/>
               <a:t>CRT Annual Training Conference 2026</a:t>
+            </a:r>
+            <a:r>
+              <a:rPr lang="en-US"/>
+              <a:t>  ·  </a:t>
+            </a:r>
+            <a:r>
+              <a:rPr lang="en-US">
+                <a:hlinkClick r:id="rIdGitHubFooter">
+                  <a:extLst>
+                    <a:ext uri="{A12FA001-AC4F-418D-AE19-62706E023703}">
+                      <ahyp:hlinkClr xmlns:ahyp="http://schemas.microsoft.com/office/drawing/2018/hyperlinkcolor" val="tx"/>
+                    </a:ext>
+                  </a:extLst>
+                </a:hlinkClick>
+              </a:rPr>
+              <a:t>github.com/dzampino/crt-essentials-2026</a:t>
             </a:r>
           </a:p>
         </p:txBody>
@@ -12047,6 +12526,22 @@
               <a:rPr lang="en-US"/>
               <a:t>CRT Annual Training Conference 2026</a:t>
             </a:r>
+            <a:r>
+              <a:rPr lang="en-US"/>
+              <a:t>  ·  </a:t>
+            </a:r>
+            <a:r>
+              <a:rPr lang="en-US">
+                <a:hlinkClick r:id="rIdGitHubFooter">
+                  <a:extLst>
+                    <a:ext uri="{A12FA001-AC4F-418D-AE19-62706E023703}">
+                      <ahyp:hlinkClr xmlns:ahyp="http://schemas.microsoft.com/office/drawing/2018/hyperlinkcolor" val="tx"/>
+                    </a:ext>
+                  </a:extLst>
+                </a:hlinkClick>
+              </a:rPr>
+              <a:t>github.com/dzampino/crt-essentials-2026</a:t>
+            </a:r>
           </a:p>
         </p:txBody>
       </p:sp>
@@ -12342,6 +12837,22 @@
               <a:rPr lang="en-US"/>
               <a:t>CRT Annual Training Conference 2026</a:t>
             </a:r>
+            <a:r>
+              <a:rPr lang="en-US"/>
+              <a:t>  ·  </a:t>
+            </a:r>
+            <a:r>
+              <a:rPr lang="en-US">
+                <a:hlinkClick r:id="rIdGitHubFooter">
+                  <a:extLst>
+                    <a:ext uri="{A12FA001-AC4F-418D-AE19-62706E023703}">
+                      <ahyp:hlinkClr xmlns:ahyp="http://schemas.microsoft.com/office/drawing/2018/hyperlinkcolor" val="tx"/>
+                    </a:ext>
+                  </a:extLst>
+                </a:hlinkClick>
+              </a:rPr>
+              <a:t>github.com/dzampino/crt-essentials-2026</a:t>
+            </a:r>
           </a:p>
         </p:txBody>
       </p:sp>
@@ -12559,6 +13070,22 @@
               <a:rPr lang="en-US"/>
               <a:t>CRT Annual Training Conference 2026</a:t>
             </a:r>
+            <a:r>
+              <a:rPr lang="en-US"/>
+              <a:t>  ·  </a:t>
+            </a:r>
+            <a:r>
+              <a:rPr lang="en-US">
+                <a:hlinkClick r:id="rIdGitHubFooter">
+                  <a:extLst>
+                    <a:ext uri="{A12FA001-AC4F-418D-AE19-62706E023703}">
+                      <ahyp:hlinkClr xmlns:ahyp="http://schemas.microsoft.com/office/drawing/2018/hyperlinkcolor" val="tx"/>
+                    </a:ext>
+                  </a:extLst>
+                </a:hlinkClick>
+              </a:rPr>
+              <a:t>github.com/dzampino/crt-essentials-2026</a:t>
+            </a:r>
           </a:p>
         </p:txBody>
       </p:sp>
@@ -12747,6 +13274,22 @@
               <a:rPr lang="en-US"/>
               <a:t>CRT Annual Training Conference 2026</a:t>
             </a:r>
+            <a:r>
+              <a:rPr lang="en-US"/>
+              <a:t>  ·  </a:t>
+            </a:r>
+            <a:r>
+              <a:rPr lang="en-US">
+                <a:hlinkClick r:id="rIdGitHubFooter">
+                  <a:extLst>
+                    <a:ext uri="{A12FA001-AC4F-418D-AE19-62706E023703}">
+                      <ahyp:hlinkClr xmlns:ahyp="http://schemas.microsoft.com/office/drawing/2018/hyperlinkcolor" val="tx"/>
+                    </a:ext>
+                  </a:extLst>
+                </a:hlinkClick>
+              </a:rPr>
+              <a:t>github.com/dzampino/crt-essentials-2026</a:t>
+            </a:r>
           </a:p>
         </p:txBody>
       </p:sp>
@@ -12843,72 +13386,41 @@
             </a:pPr>
             <a:r>
               <a:rPr/>
-              <a:t>Agenda</a:t>
-            </a:r>
-          </a:p>
-        </p:txBody>
-      </p:sp>
-      <p:sp>
-        <p:nvSpPr>
-          <p:cNvPr id="3" name="Content Placeholder 3"/>
-          <p:cNvSpPr>
-            <a:spLocks noGrp="1"/>
-          </p:cNvSpPr>
-          <p:nvPr>
-            <p:ph idx="1"/>
-          </p:nvPr>
-        </p:nvSpPr>
-        <p:spPr/>
-        <p:txBody>
-          <a:bodyPr/>
-          <a:lstStyle/>
-          <a:p>
-            <a:pPr lvl="0">
-              <a:buAutoNum type="arabicPeriod"/>
-            </a:pPr>
-            <a:r>
-              <a:rPr/>
-              <a:t>Passwords</a:t>
-            </a:r>
-          </a:p>
-          <a:p>
-            <a:pPr lvl="0">
-              <a:buAutoNum type="arabicPeriod"/>
-            </a:pPr>
-            <a:r>
-              <a:rPr/>
-              <a:t>PKI</a:t>
-            </a:r>
-          </a:p>
-          <a:p>
-            <a:pPr lvl="0">
-              <a:buAutoNum type="arabicPeriod"/>
-            </a:pPr>
-            <a:r>
-              <a:rPr/>
-              <a:t>Email security</a:t>
-            </a:r>
-          </a:p>
-          <a:p>
-            <a:pPr lvl="0">
-              <a:buAutoNum type="arabicPeriod"/>
-            </a:pPr>
-            <a:r>
-              <a:rPr/>
-              <a:t>PowerShell</a:t>
-            </a:r>
-          </a:p>
-          <a:p>
-            <a:pPr lvl="0">
-              <a:buAutoNum type="arabicPeriod"/>
-            </a:pPr>
-            <a:r>
-              <a:rPr/>
-              <a:t>Building a Windows DFIR box</a:t>
-            </a:r>
-          </a:p>
-        </p:txBody>
-      </p:sp>
+              <a:t>dzampino.github.io/crt-essentials-2026</a:t>
+            </a:r>
+          </a:p>
+        </p:txBody>
+      </p:sp>
+      <p:pic>
+        <p:nvPicPr>
+          <p:cNvPr descr="QR code linking to dzampino.github.io/crt-essentials-2026" id="0" name="Picture 1"/>
+          <p:cNvPicPr>
+            <a:picLocks noGrp="1" noChangeAspect="1"/>
+          </p:cNvPicPr>
+          <p:nvPr/>
+        </p:nvPicPr>
+        <p:blipFill>
+          <a:blip r:embed="rId3"/>
+          <a:stretch>
+            <a:fillRect/>
+          </a:stretch>
+        </p:blipFill>
+        <p:spPr bwMode="auto">
+          <a:xfrm>
+            <a:off x="3784600" y="1435100"/>
+            <a:ext cx="4597400" cy="4597400"/>
+          </a:xfrm>
+          <a:prstGeom prst="rect">
+            <a:avLst/>
+          </a:prstGeom>
+          <a:noFill/>
+          <a:ln w="9525">
+            <a:noFill/>
+            <a:headEnd/>
+            <a:tailEnd/>
+          </a:ln>
+        </p:spPr>
+      </p:pic>
       <p:sp>
         <p:nvSpPr>
           <p:cNvPr id="4" name="Footer Placeholder"/>
@@ -12947,6 +13459,22 @@
             <a:r>
               <a:rPr lang="en-US"/>
               <a:t>CRT Annual Training Conference 2026</a:t>
+            </a:r>
+            <a:r>
+              <a:rPr lang="en-US"/>
+              <a:t>  ·  </a:t>
+            </a:r>
+            <a:r>
+              <a:rPr lang="en-US">
+                <a:hlinkClick r:id="rIdGitHubFooter">
+                  <a:extLst>
+                    <a:ext uri="{A12FA001-AC4F-418D-AE19-62706E023703}">
+                      <ahyp:hlinkClr xmlns:ahyp="http://schemas.microsoft.com/office/drawing/2018/hyperlinkcolor" val="tx"/>
+                    </a:ext>
+                  </a:extLst>
+                </a:hlinkClick>
+              </a:rPr>
+              <a:t>github.com/dzampino/crt-essentials-2026</a:t>
             </a:r>
           </a:p>
         </p:txBody>
@@ -13438,6 +13966,22 @@
               <a:rPr lang="en-US"/>
               <a:t>CRT Annual Training Conference 2026</a:t>
             </a:r>
+            <a:r>
+              <a:rPr lang="en-US"/>
+              <a:t>  ·  </a:t>
+            </a:r>
+            <a:r>
+              <a:rPr lang="en-US">
+                <a:hlinkClick r:id="rIdGitHubFooter">
+                  <a:extLst>
+                    <a:ext uri="{A12FA001-AC4F-418D-AE19-62706E023703}">
+                      <ahyp:hlinkClr xmlns:ahyp="http://schemas.microsoft.com/office/drawing/2018/hyperlinkcolor" val="tx"/>
+                    </a:ext>
+                  </a:extLst>
+                </a:hlinkClick>
+              </a:rPr>
+              <a:t>github.com/dzampino/crt-essentials-2026</a:t>
+            </a:r>
           </a:p>
         </p:txBody>
       </p:sp>
@@ -13647,6 +14191,22 @@
             <a:r>
               <a:rPr lang="en-US"/>
               <a:t>CRT Annual Training Conference 2026</a:t>
+            </a:r>
+            <a:r>
+              <a:rPr lang="en-US"/>
+              <a:t>  ·  </a:t>
+            </a:r>
+            <a:r>
+              <a:rPr lang="en-US">
+                <a:hlinkClick r:id="rIdGitHubFooter">
+                  <a:extLst>
+                    <a:ext uri="{A12FA001-AC4F-418D-AE19-62706E023703}">
+                      <ahyp:hlinkClr xmlns:ahyp="http://schemas.microsoft.com/office/drawing/2018/hyperlinkcolor" val="tx"/>
+                    </a:ext>
+                  </a:extLst>
+                </a:hlinkClick>
+              </a:rPr>
+              <a:t>github.com/dzampino/crt-essentials-2026</a:t>
             </a:r>
           </a:p>
         </p:txBody>
@@ -14190,6 +14750,22 @@
               <a:rPr lang="en-US"/>
               <a:t>CRT Annual Training Conference 2026</a:t>
             </a:r>
+            <a:r>
+              <a:rPr lang="en-US"/>
+              <a:t>  ·  </a:t>
+            </a:r>
+            <a:r>
+              <a:rPr lang="en-US">
+                <a:hlinkClick r:id="rIdGitHubFooter">
+                  <a:extLst>
+                    <a:ext uri="{A12FA001-AC4F-418D-AE19-62706E023703}">
+                      <ahyp:hlinkClr xmlns:ahyp="http://schemas.microsoft.com/office/drawing/2018/hyperlinkcolor" val="tx"/>
+                    </a:ext>
+                  </a:extLst>
+                </a:hlinkClick>
+              </a:rPr>
+              <a:t>github.com/dzampino/crt-essentials-2026</a:t>
+            </a:r>
           </a:p>
         </p:txBody>
       </p:sp>
@@ -14421,6 +14997,22 @@
             <a:r>
               <a:rPr lang="en-US"/>
               <a:t>CRT Annual Training Conference 2026</a:t>
+            </a:r>
+            <a:r>
+              <a:rPr lang="en-US"/>
+              <a:t>  ·  </a:t>
+            </a:r>
+            <a:r>
+              <a:rPr lang="en-US">
+                <a:hlinkClick r:id="rIdGitHubFooter">
+                  <a:extLst>
+                    <a:ext uri="{A12FA001-AC4F-418D-AE19-62706E023703}">
+                      <ahyp:hlinkClr xmlns:ahyp="http://schemas.microsoft.com/office/drawing/2018/hyperlinkcolor" val="tx"/>
+                    </a:ext>
+                  </a:extLst>
+                </a:hlinkClick>
+              </a:rPr>
+              <a:t>github.com/dzampino/crt-essentials-2026</a:t>
             </a:r>
           </a:p>
         </p:txBody>
@@ -15181,6 +15773,22 @@
               <a:rPr lang="en-US"/>
               <a:t>CRT Annual Training Conference 2026</a:t>
             </a:r>
+            <a:r>
+              <a:rPr lang="en-US"/>
+              <a:t>  ·  </a:t>
+            </a:r>
+            <a:r>
+              <a:rPr lang="en-US">
+                <a:hlinkClick r:id="rIdGitHubFooter">
+                  <a:extLst>
+                    <a:ext uri="{A12FA001-AC4F-418D-AE19-62706E023703}">
+                      <ahyp:hlinkClr xmlns:ahyp="http://schemas.microsoft.com/office/drawing/2018/hyperlinkcolor" val="tx"/>
+                    </a:ext>
+                  </a:extLst>
+                </a:hlinkClick>
+              </a:rPr>
+              <a:t>github.com/dzampino/crt-essentials-2026</a:t>
+            </a:r>
           </a:p>
         </p:txBody>
       </p:sp>
@@ -15441,6 +16049,22 @@
               <a:rPr lang="en-US"/>
               <a:t>CRT Annual Training Conference 2026</a:t>
             </a:r>
+            <a:r>
+              <a:rPr lang="en-US"/>
+              <a:t>  ·  </a:t>
+            </a:r>
+            <a:r>
+              <a:rPr lang="en-US">
+                <a:hlinkClick r:id="rIdGitHubFooter">
+                  <a:extLst>
+                    <a:ext uri="{A12FA001-AC4F-418D-AE19-62706E023703}">
+                      <ahyp:hlinkClr xmlns:ahyp="http://schemas.microsoft.com/office/drawing/2018/hyperlinkcolor" val="tx"/>
+                    </a:ext>
+                  </a:extLst>
+                </a:hlinkClick>
+              </a:rPr>
+              <a:t>github.com/dzampino/crt-essentials-2026</a:t>
+            </a:r>
           </a:p>
         </p:txBody>
       </p:sp>
@@ -15707,6 +16331,22 @@
               <a:rPr lang="en-US"/>
               <a:t>CRT Annual Training Conference 2026</a:t>
             </a:r>
+            <a:r>
+              <a:rPr lang="en-US"/>
+              <a:t>  ·  </a:t>
+            </a:r>
+            <a:r>
+              <a:rPr lang="en-US">
+                <a:hlinkClick r:id="rIdGitHubFooter">
+                  <a:extLst>
+                    <a:ext uri="{A12FA001-AC4F-418D-AE19-62706E023703}">
+                      <ahyp:hlinkClr xmlns:ahyp="http://schemas.microsoft.com/office/drawing/2018/hyperlinkcolor" val="tx"/>
+                    </a:ext>
+                  </a:extLst>
+                </a:hlinkClick>
+              </a:rPr>
+              <a:t>github.com/dzampino/crt-essentials-2026</a:t>
+            </a:r>
           </a:p>
         </p:txBody>
       </p:sp>
@@ -15967,6 +16607,22 @@
               <a:rPr lang="en-US"/>
               <a:t>CRT Annual Training Conference 2026</a:t>
             </a:r>
+            <a:r>
+              <a:rPr lang="en-US"/>
+              <a:t>  ·  </a:t>
+            </a:r>
+            <a:r>
+              <a:rPr lang="en-US">
+                <a:hlinkClick r:id="rIdGitHubFooter">
+                  <a:extLst>
+                    <a:ext uri="{A12FA001-AC4F-418D-AE19-62706E023703}">
+                      <ahyp:hlinkClr xmlns:ahyp="http://schemas.microsoft.com/office/drawing/2018/hyperlinkcolor" val="tx"/>
+                    </a:ext>
+                  </a:extLst>
+                </a:hlinkClick>
+              </a:rPr>
+              <a:t>github.com/dzampino/crt-essentials-2026</a:t>
+            </a:r>
           </a:p>
         </p:txBody>
       </p:sp>
@@ -16193,6 +16849,22 @@
               <a:rPr lang="en-US"/>
               <a:t>CRT Annual Training Conference 2026</a:t>
             </a:r>
+            <a:r>
+              <a:rPr lang="en-US"/>
+              <a:t>  ·  </a:t>
+            </a:r>
+            <a:r>
+              <a:rPr lang="en-US">
+                <a:hlinkClick r:id="rIdGitHubFooter">
+                  <a:extLst>
+                    <a:ext uri="{A12FA001-AC4F-418D-AE19-62706E023703}">
+                      <ahyp:hlinkClr xmlns:ahyp="http://schemas.microsoft.com/office/drawing/2018/hyperlinkcolor" val="tx"/>
+                    </a:ext>
+                  </a:extLst>
+                </a:hlinkClick>
+              </a:rPr>
+              <a:t>github.com/dzampino/crt-essentials-2026</a:t>
+            </a:r>
           </a:p>
         </p:txBody>
       </p:sp>
@@ -16453,6 +17125,22 @@
               <a:rPr lang="en-US"/>
               <a:t>CRT Annual Training Conference 2026</a:t>
             </a:r>
+            <a:r>
+              <a:rPr lang="en-US"/>
+              <a:t>  ·  </a:t>
+            </a:r>
+            <a:r>
+              <a:rPr lang="en-US">
+                <a:hlinkClick r:id="rIdGitHubFooter">
+                  <a:extLst>
+                    <a:ext uri="{A12FA001-AC4F-418D-AE19-62706E023703}">
+                      <ahyp:hlinkClr xmlns:ahyp="http://schemas.microsoft.com/office/drawing/2018/hyperlinkcolor" val="tx"/>
+                    </a:ext>
+                  </a:extLst>
+                </a:hlinkClick>
+              </a:rPr>
+              <a:t>github.com/dzampino/crt-essentials-2026</a:t>
+            </a:r>
           </a:p>
         </p:txBody>
       </p:sp>
@@ -16593,6 +17281,22 @@
               <a:rPr lang="en-US"/>
               <a:t>CRT Annual Training Conference 2026</a:t>
             </a:r>
+            <a:r>
+              <a:rPr lang="en-US"/>
+              <a:t>  ·  </a:t>
+            </a:r>
+            <a:r>
+              <a:rPr lang="en-US">
+                <a:hlinkClick r:id="rIdGitHubFooter">
+                  <a:extLst>
+                    <a:ext uri="{A12FA001-AC4F-418D-AE19-62706E023703}">
+                      <ahyp:hlinkClr xmlns:ahyp="http://schemas.microsoft.com/office/drawing/2018/hyperlinkcolor" val="tx"/>
+                    </a:ext>
+                  </a:extLst>
+                </a:hlinkClick>
+              </a:rPr>
+              <a:t>github.com/dzampino/crt-essentials-2026</a:t>
+            </a:r>
           </a:p>
         </p:txBody>
       </p:sp>
@@ -16835,6 +17539,22 @@
               <a:rPr lang="en-US"/>
               <a:t>CRT Annual Training Conference 2026</a:t>
             </a:r>
+            <a:r>
+              <a:rPr lang="en-US"/>
+              <a:t>  ·  </a:t>
+            </a:r>
+            <a:r>
+              <a:rPr lang="en-US">
+                <a:hlinkClick r:id="rIdGitHubFooter">
+                  <a:extLst>
+                    <a:ext uri="{A12FA001-AC4F-418D-AE19-62706E023703}">
+                      <ahyp:hlinkClr xmlns:ahyp="http://schemas.microsoft.com/office/drawing/2018/hyperlinkcolor" val="tx"/>
+                    </a:ext>
+                  </a:extLst>
+                </a:hlinkClick>
+              </a:rPr>
+              <a:t>github.com/dzampino/crt-essentials-2026</a:t>
+            </a:r>
           </a:p>
         </p:txBody>
       </p:sp>
@@ -17026,6 +17746,22 @@
               <a:rPr lang="en-US"/>
               <a:t>CRT Annual Training Conference 2026</a:t>
             </a:r>
+            <a:r>
+              <a:rPr lang="en-US"/>
+              <a:t>  ·  </a:t>
+            </a:r>
+            <a:r>
+              <a:rPr lang="en-US">
+                <a:hlinkClick r:id="rIdGitHubFooter">
+                  <a:extLst>
+                    <a:ext uri="{A12FA001-AC4F-418D-AE19-62706E023703}">
+                      <ahyp:hlinkClr xmlns:ahyp="http://schemas.microsoft.com/office/drawing/2018/hyperlinkcolor" val="tx"/>
+                    </a:ext>
+                  </a:extLst>
+                </a:hlinkClick>
+              </a:rPr>
+              <a:t>github.com/dzampino/crt-essentials-2026</a:t>
+            </a:r>
           </a:p>
         </p:txBody>
       </p:sp>
@@ -17166,6 +17902,22 @@
               <a:rPr lang="en-US"/>
               <a:t>CRT Annual Training Conference 2026</a:t>
             </a:r>
+            <a:r>
+              <a:rPr lang="en-US"/>
+              <a:t>  ·  </a:t>
+            </a:r>
+            <a:r>
+              <a:rPr lang="en-US">
+                <a:hlinkClick r:id="rIdGitHubFooter">
+                  <a:extLst>
+                    <a:ext uri="{A12FA001-AC4F-418D-AE19-62706E023703}">
+                      <ahyp:hlinkClr xmlns:ahyp="http://schemas.microsoft.com/office/drawing/2018/hyperlinkcolor" val="tx"/>
+                    </a:ext>
+                  </a:extLst>
+                </a:hlinkClick>
+              </a:rPr>
+              <a:t>github.com/dzampino/crt-essentials-2026</a:t>
+            </a:r>
           </a:p>
         </p:txBody>
       </p:sp>
@@ -17306,6 +18058,22 @@
               <a:rPr lang="en-US"/>
               <a:t>CRT Annual Training Conference 2026</a:t>
             </a:r>
+            <a:r>
+              <a:rPr lang="en-US"/>
+              <a:t>  ·  </a:t>
+            </a:r>
+            <a:r>
+              <a:rPr lang="en-US">
+                <a:hlinkClick r:id="rIdGitHubFooter">
+                  <a:extLst>
+                    <a:ext uri="{A12FA001-AC4F-418D-AE19-62706E023703}">
+                      <ahyp:hlinkClr xmlns:ahyp="http://schemas.microsoft.com/office/drawing/2018/hyperlinkcolor" val="tx"/>
+                    </a:ext>
+                  </a:extLst>
+                </a:hlinkClick>
+              </a:rPr>
+              <a:t>github.com/dzampino/crt-essentials-2026</a:t>
+            </a:r>
           </a:p>
         </p:txBody>
       </p:sp>
@@ -17483,6 +18251,22 @@
               <a:rPr lang="en-US"/>
               <a:t>CRT Annual Training Conference 2026</a:t>
             </a:r>
+            <a:r>
+              <a:rPr lang="en-US"/>
+              <a:t>  ·  </a:t>
+            </a:r>
+            <a:r>
+              <a:rPr lang="en-US">
+                <a:hlinkClick r:id="rIdGitHubFooter">
+                  <a:extLst>
+                    <a:ext uri="{A12FA001-AC4F-418D-AE19-62706E023703}">
+                      <ahyp:hlinkClr xmlns:ahyp="http://schemas.microsoft.com/office/drawing/2018/hyperlinkcolor" val="tx"/>
+                    </a:ext>
+                  </a:extLst>
+                </a:hlinkClick>
+              </a:rPr>
+              <a:t>github.com/dzampino/crt-essentials-2026</a:t>
+            </a:r>
           </a:p>
         </p:txBody>
       </p:sp>
@@ -17887,6 +18671,22 @@
               <a:rPr lang="en-US"/>
               <a:t>CRT Annual Training Conference 2026</a:t>
             </a:r>
+            <a:r>
+              <a:rPr lang="en-US"/>
+              <a:t>  ·  </a:t>
+            </a:r>
+            <a:r>
+              <a:rPr lang="en-US">
+                <a:hlinkClick r:id="rIdGitHubFooter">
+                  <a:extLst>
+                    <a:ext uri="{A12FA001-AC4F-418D-AE19-62706E023703}">
+                      <ahyp:hlinkClr xmlns:ahyp="http://schemas.microsoft.com/office/drawing/2018/hyperlinkcolor" val="tx"/>
+                    </a:ext>
+                  </a:extLst>
+                </a:hlinkClick>
+              </a:rPr>
+              <a:t>github.com/dzampino/crt-essentials-2026</a:t>
+            </a:r>
           </a:p>
         </p:txBody>
       </p:sp>
@@ -18401,6 +19201,22 @@
             <a:r>
               <a:rPr lang="en-US"/>
               <a:t>CRT Annual Training Conference 2026</a:t>
+            </a:r>
+            <a:r>
+              <a:rPr lang="en-US"/>
+              <a:t>  ·  </a:t>
+            </a:r>
+            <a:r>
+              <a:rPr lang="en-US">
+                <a:hlinkClick r:id="rIdGitHubFooter">
+                  <a:extLst>
+                    <a:ext uri="{A12FA001-AC4F-418D-AE19-62706E023703}">
+                      <ahyp:hlinkClr xmlns:ahyp="http://schemas.microsoft.com/office/drawing/2018/hyperlinkcolor" val="tx"/>
+                    </a:ext>
+                  </a:extLst>
+                </a:hlinkClick>
+              </a:rPr>
+              <a:t>github.com/dzampino/crt-essentials-2026</a:t>
             </a:r>
           </a:p>
         </p:txBody>
@@ -18864,6 +19680,22 @@
               <a:rPr lang="en-US"/>
               <a:t>CRT Annual Training Conference 2026</a:t>
             </a:r>
+            <a:r>
+              <a:rPr lang="en-US"/>
+              <a:t>  ·  </a:t>
+            </a:r>
+            <a:r>
+              <a:rPr lang="en-US">
+                <a:hlinkClick r:id="rIdGitHubFooter">
+                  <a:extLst>
+                    <a:ext uri="{A12FA001-AC4F-418D-AE19-62706E023703}">
+                      <ahyp:hlinkClr xmlns:ahyp="http://schemas.microsoft.com/office/drawing/2018/hyperlinkcolor" val="tx"/>
+                    </a:ext>
+                  </a:extLst>
+                </a:hlinkClick>
+              </a:rPr>
+              <a:t>github.com/dzampino/crt-essentials-2026</a:t>
+            </a:r>
           </a:p>
         </p:txBody>
       </p:sp>
@@ -19229,6 +20061,22 @@
               <a:rPr lang="en-US"/>
               <a:t>CRT Annual Training Conference 2026</a:t>
             </a:r>
+            <a:r>
+              <a:rPr lang="en-US"/>
+              <a:t>  ·  </a:t>
+            </a:r>
+            <a:r>
+              <a:rPr lang="en-US">
+                <a:hlinkClick r:id="rIdGitHubFooter">
+                  <a:extLst>
+                    <a:ext uri="{A12FA001-AC4F-418D-AE19-62706E023703}">
+                      <ahyp:hlinkClr xmlns:ahyp="http://schemas.microsoft.com/office/drawing/2018/hyperlinkcolor" val="tx"/>
+                    </a:ext>
+                  </a:extLst>
+                </a:hlinkClick>
+              </a:rPr>
+              <a:t>github.com/dzampino/crt-essentials-2026</a:t>
+            </a:r>
           </a:p>
         </p:txBody>
       </p:sp>
@@ -19590,6 +20438,22 @@
               <a:rPr lang="en-US"/>
               <a:t>CRT Annual Training Conference 2026</a:t>
             </a:r>
+            <a:r>
+              <a:rPr lang="en-US"/>
+              <a:t>  ·  </a:t>
+            </a:r>
+            <a:r>
+              <a:rPr lang="en-US">
+                <a:hlinkClick r:id="rIdGitHubFooter">
+                  <a:extLst>
+                    <a:ext uri="{A12FA001-AC4F-418D-AE19-62706E023703}">
+                      <ahyp:hlinkClr xmlns:ahyp="http://schemas.microsoft.com/office/drawing/2018/hyperlinkcolor" val="tx"/>
+                    </a:ext>
+                  </a:extLst>
+                </a:hlinkClick>
+              </a:rPr>
+              <a:t>github.com/dzampino/crt-essentials-2026</a:t>
+            </a:r>
           </a:p>
         </p:txBody>
       </p:sp>
@@ -19789,6 +20653,22 @@
               <a:rPr lang="en-US"/>
               <a:t>CRT Annual Training Conference 2026</a:t>
             </a:r>
+            <a:r>
+              <a:rPr lang="en-US"/>
+              <a:t>  ·  </a:t>
+            </a:r>
+            <a:r>
+              <a:rPr lang="en-US">
+                <a:hlinkClick r:id="rIdGitHubFooter">
+                  <a:extLst>
+                    <a:ext uri="{A12FA001-AC4F-418D-AE19-62706E023703}">
+                      <ahyp:hlinkClr xmlns:ahyp="http://schemas.microsoft.com/office/drawing/2018/hyperlinkcolor" val="tx"/>
+                    </a:ext>
+                  </a:extLst>
+                </a:hlinkClick>
+              </a:rPr>
+              <a:t>github.com/dzampino/crt-essentials-2026</a:t>
+            </a:r>
           </a:p>
         </p:txBody>
       </p:sp>
@@ -20255,6 +21135,22 @@
               <a:rPr lang="en-US"/>
               <a:t>CRT Annual Training Conference 2026</a:t>
             </a:r>
+            <a:r>
+              <a:rPr lang="en-US"/>
+              <a:t>  ·  </a:t>
+            </a:r>
+            <a:r>
+              <a:rPr lang="en-US">
+                <a:hlinkClick r:id="rIdGitHubFooter">
+                  <a:extLst>
+                    <a:ext uri="{A12FA001-AC4F-418D-AE19-62706E023703}">
+                      <ahyp:hlinkClr xmlns:ahyp="http://schemas.microsoft.com/office/drawing/2018/hyperlinkcolor" val="tx"/>
+                    </a:ext>
+                  </a:extLst>
+                </a:hlinkClick>
+              </a:rPr>
+              <a:t>github.com/dzampino/crt-essentials-2026</a:t>
+            </a:r>
           </a:p>
         </p:txBody>
       </p:sp>
@@ -20825,6 +21721,22 @@
               <a:rPr lang="en-US"/>
               <a:t>CRT Annual Training Conference 2026</a:t>
             </a:r>
+            <a:r>
+              <a:rPr lang="en-US"/>
+              <a:t>  ·  </a:t>
+            </a:r>
+            <a:r>
+              <a:rPr lang="en-US">
+                <a:hlinkClick r:id="rIdGitHubFooter">
+                  <a:extLst>
+                    <a:ext uri="{A12FA001-AC4F-418D-AE19-62706E023703}">
+                      <ahyp:hlinkClr xmlns:ahyp="http://schemas.microsoft.com/office/drawing/2018/hyperlinkcolor" val="tx"/>
+                    </a:ext>
+                  </a:extLst>
+                </a:hlinkClick>
+              </a:rPr>
+              <a:t>github.com/dzampino/crt-essentials-2026</a:t>
+            </a:r>
           </a:p>
         </p:txBody>
       </p:sp>
@@ -21507,6 +22419,22 @@
               <a:rPr lang="en-US"/>
               <a:t>CRT Annual Training Conference 2026</a:t>
             </a:r>
+            <a:r>
+              <a:rPr lang="en-US"/>
+              <a:t>  ·  </a:t>
+            </a:r>
+            <a:r>
+              <a:rPr lang="en-US">
+                <a:hlinkClick r:id="rIdGitHubFooter">
+                  <a:extLst>
+                    <a:ext uri="{A12FA001-AC4F-418D-AE19-62706E023703}">
+                      <ahyp:hlinkClr xmlns:ahyp="http://schemas.microsoft.com/office/drawing/2018/hyperlinkcolor" val="tx"/>
+                    </a:ext>
+                  </a:extLst>
+                </a:hlinkClick>
+              </a:rPr>
+              <a:t>github.com/dzampino/crt-essentials-2026</a:t>
+            </a:r>
           </a:p>
         </p:txBody>
       </p:sp>
@@ -21955,6 +22883,22 @@
               <a:rPr lang="en-US"/>
               <a:t>CRT Annual Training Conference 2026</a:t>
             </a:r>
+            <a:r>
+              <a:rPr lang="en-US"/>
+              <a:t>  ·  </a:t>
+            </a:r>
+            <a:r>
+              <a:rPr lang="en-US">
+                <a:hlinkClick r:id="rIdGitHubFooter">
+                  <a:extLst>
+                    <a:ext uri="{A12FA001-AC4F-418D-AE19-62706E023703}">
+                      <ahyp:hlinkClr xmlns:ahyp="http://schemas.microsoft.com/office/drawing/2018/hyperlinkcolor" val="tx"/>
+                    </a:ext>
+                  </a:extLst>
+                </a:hlinkClick>
+              </a:rPr>
+              <a:t>github.com/dzampino/crt-essentials-2026</a:t>
+            </a:r>
           </a:p>
         </p:txBody>
       </p:sp>
@@ -22686,6 +23630,22 @@
               <a:rPr lang="en-US"/>
               <a:t>CRT Annual Training Conference 2026</a:t>
             </a:r>
+            <a:r>
+              <a:rPr lang="en-US"/>
+              <a:t>  ·  </a:t>
+            </a:r>
+            <a:r>
+              <a:rPr lang="en-US">
+                <a:hlinkClick r:id="rIdGitHubFooter">
+                  <a:extLst>
+                    <a:ext uri="{A12FA001-AC4F-418D-AE19-62706E023703}">
+                      <ahyp:hlinkClr xmlns:ahyp="http://schemas.microsoft.com/office/drawing/2018/hyperlinkcolor" val="tx"/>
+                    </a:ext>
+                  </a:extLst>
+                </a:hlinkClick>
+              </a:rPr>
+              <a:t>github.com/dzampino/crt-essentials-2026</a:t>
+            </a:r>
           </a:p>
         </p:txBody>
       </p:sp>
@@ -22894,6 +23854,22 @@
               <a:rPr lang="en-US"/>
               <a:t>CRT Annual Training Conference 2026</a:t>
             </a:r>
+            <a:r>
+              <a:rPr lang="en-US"/>
+              <a:t>  ·  </a:t>
+            </a:r>
+            <a:r>
+              <a:rPr lang="en-US">
+                <a:hlinkClick r:id="rIdGitHubFooter">
+                  <a:extLst>
+                    <a:ext uri="{A12FA001-AC4F-418D-AE19-62706E023703}">
+                      <ahyp:hlinkClr xmlns:ahyp="http://schemas.microsoft.com/office/drawing/2018/hyperlinkcolor" val="tx"/>
+                    </a:ext>
+                  </a:extLst>
+                </a:hlinkClick>
+              </a:rPr>
+              <a:t>github.com/dzampino/crt-essentials-2026</a:t>
+            </a:r>
           </a:p>
         </p:txBody>
       </p:sp>
@@ -23034,6 +24010,22 @@
               <a:rPr lang="en-US"/>
               <a:t>CRT Annual Training Conference 2026</a:t>
             </a:r>
+            <a:r>
+              <a:rPr lang="en-US"/>
+              <a:t>  ·  </a:t>
+            </a:r>
+            <a:r>
+              <a:rPr lang="en-US">
+                <a:hlinkClick r:id="rIdGitHubFooter">
+                  <a:extLst>
+                    <a:ext uri="{A12FA001-AC4F-418D-AE19-62706E023703}">
+                      <ahyp:hlinkClr xmlns:ahyp="http://schemas.microsoft.com/office/drawing/2018/hyperlinkcolor" val="tx"/>
+                    </a:ext>
+                  </a:extLst>
+                </a:hlinkClick>
+              </a:rPr>
+              <a:t>github.com/dzampino/crt-essentials-2026</a:t>
+            </a:r>
           </a:p>
         </p:txBody>
       </p:sp>
@@ -23174,6 +24166,22 @@
               <a:rPr lang="en-US"/>
               <a:t>CRT Annual Training Conference 2026</a:t>
             </a:r>
+            <a:r>
+              <a:rPr lang="en-US"/>
+              <a:t>  ·  </a:t>
+            </a:r>
+            <a:r>
+              <a:rPr lang="en-US">
+                <a:hlinkClick r:id="rIdGitHubFooter">
+                  <a:extLst>
+                    <a:ext uri="{A12FA001-AC4F-418D-AE19-62706E023703}">
+                      <ahyp:hlinkClr xmlns:ahyp="http://schemas.microsoft.com/office/drawing/2018/hyperlinkcolor" val="tx"/>
+                    </a:ext>
+                  </a:extLst>
+                </a:hlinkClick>
+              </a:rPr>
+              <a:t>github.com/dzampino/crt-essentials-2026</a:t>
+            </a:r>
           </a:p>
         </p:txBody>
       </p:sp>
@@ -23372,6 +24380,22 @@
               <a:rPr lang="en-US"/>
               <a:t>CRT Annual Training Conference 2026</a:t>
             </a:r>
+            <a:r>
+              <a:rPr lang="en-US"/>
+              <a:t>  ·  </a:t>
+            </a:r>
+            <a:r>
+              <a:rPr lang="en-US">
+                <a:hlinkClick r:id="rIdGitHubFooter">
+                  <a:extLst>
+                    <a:ext uri="{A12FA001-AC4F-418D-AE19-62706E023703}">
+                      <ahyp:hlinkClr xmlns:ahyp="http://schemas.microsoft.com/office/drawing/2018/hyperlinkcolor" val="tx"/>
+                    </a:ext>
+                  </a:extLst>
+                </a:hlinkClick>
+              </a:rPr>
+              <a:t>github.com/dzampino/crt-essentials-2026</a:t>
+            </a:r>
           </a:p>
         </p:txBody>
       </p:sp>
@@ -23603,6 +24627,22 @@
             <a:r>
               <a:rPr lang="en-US"/>
               <a:t>CRT Annual Training Conference 2026</a:t>
+            </a:r>
+            <a:r>
+              <a:rPr lang="en-US"/>
+              <a:t>  ·  </a:t>
+            </a:r>
+            <a:r>
+              <a:rPr lang="en-US">
+                <a:hlinkClick r:id="rIdGitHubFooter">
+                  <a:extLst>
+                    <a:ext uri="{A12FA001-AC4F-418D-AE19-62706E023703}">
+                      <ahyp:hlinkClr xmlns:ahyp="http://schemas.microsoft.com/office/drawing/2018/hyperlinkcolor" val="tx"/>
+                    </a:ext>
+                  </a:extLst>
+                </a:hlinkClick>
+              </a:rPr>
+              <a:t>github.com/dzampino/crt-essentials-2026</a:t>
             </a:r>
           </a:p>
         </p:txBody>
@@ -23810,6 +24850,22 @@
               <a:rPr lang="en-US"/>
               <a:t>CRT Annual Training Conference 2026</a:t>
             </a:r>
+            <a:r>
+              <a:rPr lang="en-US"/>
+              <a:t>  ·  </a:t>
+            </a:r>
+            <a:r>
+              <a:rPr lang="en-US">
+                <a:hlinkClick r:id="rIdGitHubFooter">
+                  <a:extLst>
+                    <a:ext uri="{A12FA001-AC4F-418D-AE19-62706E023703}">
+                      <ahyp:hlinkClr xmlns:ahyp="http://schemas.microsoft.com/office/drawing/2018/hyperlinkcolor" val="tx"/>
+                    </a:ext>
+                  </a:extLst>
+                </a:hlinkClick>
+              </a:rPr>
+              <a:t>github.com/dzampino/crt-essentials-2026</a:t>
+            </a:r>
           </a:p>
         </p:txBody>
       </p:sp>
@@ -23994,6 +25050,22 @@
               <a:rPr lang="en-US"/>
               <a:t>CRT Annual Training Conference 2026</a:t>
             </a:r>
+            <a:r>
+              <a:rPr lang="en-US"/>
+              <a:t>  ·  </a:t>
+            </a:r>
+            <a:r>
+              <a:rPr lang="en-US">
+                <a:hlinkClick r:id="rIdGitHubFooter">
+                  <a:extLst>
+                    <a:ext uri="{A12FA001-AC4F-418D-AE19-62706E023703}">
+                      <ahyp:hlinkClr xmlns:ahyp="http://schemas.microsoft.com/office/drawing/2018/hyperlinkcolor" val="tx"/>
+                    </a:ext>
+                  </a:extLst>
+                </a:hlinkClick>
+              </a:rPr>
+              <a:t>github.com/dzampino/crt-essentials-2026</a:t>
+            </a:r>
           </a:p>
         </p:txBody>
       </p:sp>
@@ -24206,6 +25278,22 @@
               <a:rPr lang="en-US"/>
               <a:t>CRT Annual Training Conference 2026</a:t>
             </a:r>
+            <a:r>
+              <a:rPr lang="en-US"/>
+              <a:t>  ·  </a:t>
+            </a:r>
+            <a:r>
+              <a:rPr lang="en-US">
+                <a:hlinkClick r:id="rIdGitHubFooter">
+                  <a:extLst>
+                    <a:ext uri="{A12FA001-AC4F-418D-AE19-62706E023703}">
+                      <ahyp:hlinkClr xmlns:ahyp="http://schemas.microsoft.com/office/drawing/2018/hyperlinkcolor" val="tx"/>
+                    </a:ext>
+                  </a:extLst>
+                </a:hlinkClick>
+              </a:rPr>
+              <a:t>github.com/dzampino/crt-essentials-2026</a:t>
+            </a:r>
           </a:p>
         </p:txBody>
       </p:sp>
@@ -24436,6 +25524,22 @@
               <a:rPr lang="en-US"/>
               <a:t>CRT Annual Training Conference 2026</a:t>
             </a:r>
+            <a:r>
+              <a:rPr lang="en-US"/>
+              <a:t>  ·  </a:t>
+            </a:r>
+            <a:r>
+              <a:rPr lang="en-US">
+                <a:hlinkClick r:id="rIdGitHubFooter">
+                  <a:extLst>
+                    <a:ext uri="{A12FA001-AC4F-418D-AE19-62706E023703}">
+                      <ahyp:hlinkClr xmlns:ahyp="http://schemas.microsoft.com/office/drawing/2018/hyperlinkcolor" val="tx"/>
+                    </a:ext>
+                  </a:extLst>
+                </a:hlinkClick>
+              </a:rPr>
+              <a:t>github.com/dzampino/crt-essentials-2026</a:t>
+            </a:r>
           </a:p>
         </p:txBody>
       </p:sp>
@@ -24627,6 +25731,22 @@
               <a:rPr lang="en-US"/>
               <a:t>CRT Annual Training Conference 2026</a:t>
             </a:r>
+            <a:r>
+              <a:rPr lang="en-US"/>
+              <a:t>  ·  </a:t>
+            </a:r>
+            <a:r>
+              <a:rPr lang="en-US">
+                <a:hlinkClick r:id="rIdGitHubFooter">
+                  <a:extLst>
+                    <a:ext uri="{A12FA001-AC4F-418D-AE19-62706E023703}">
+                      <ahyp:hlinkClr xmlns:ahyp="http://schemas.microsoft.com/office/drawing/2018/hyperlinkcolor" val="tx"/>
+                    </a:ext>
+                  </a:extLst>
+                </a:hlinkClick>
+              </a:rPr>
+              <a:t>github.com/dzampino/crt-essentials-2026</a:t>
+            </a:r>
           </a:p>
         </p:txBody>
       </p:sp>
@@ -24804,6 +25924,22 @@
               <a:rPr lang="en-US"/>
               <a:t>CRT Annual Training Conference 2026</a:t>
             </a:r>
+            <a:r>
+              <a:rPr lang="en-US"/>
+              <a:t>  ·  </a:t>
+            </a:r>
+            <a:r>
+              <a:rPr lang="en-US">
+                <a:hlinkClick r:id="rIdGitHubFooter">
+                  <a:extLst>
+                    <a:ext uri="{A12FA001-AC4F-418D-AE19-62706E023703}">
+                      <ahyp:hlinkClr xmlns:ahyp="http://schemas.microsoft.com/office/drawing/2018/hyperlinkcolor" val="tx"/>
+                    </a:ext>
+                  </a:extLst>
+                </a:hlinkClick>
+              </a:rPr>
+              <a:t>github.com/dzampino/crt-essentials-2026</a:t>
+            </a:r>
           </a:p>
         </p:txBody>
       </p:sp>
@@ -24944,6 +26080,22 @@
               <a:rPr lang="en-US"/>
               <a:t>CRT Annual Training Conference 2026</a:t>
             </a:r>
+            <a:r>
+              <a:rPr lang="en-US"/>
+              <a:t>  ·  </a:t>
+            </a:r>
+            <a:r>
+              <a:rPr lang="en-US">
+                <a:hlinkClick r:id="rIdGitHubFooter">
+                  <a:extLst>
+                    <a:ext uri="{A12FA001-AC4F-418D-AE19-62706E023703}">
+                      <ahyp:hlinkClr xmlns:ahyp="http://schemas.microsoft.com/office/drawing/2018/hyperlinkcolor" val="tx"/>
+                    </a:ext>
+                  </a:extLst>
+                </a:hlinkClick>
+              </a:rPr>
+              <a:t>github.com/dzampino/crt-essentials-2026</a:t>
+            </a:r>
           </a:p>
         </p:txBody>
       </p:sp>
@@ -25084,6 +26236,22 @@
               <a:rPr lang="en-US"/>
               <a:t>CRT Annual Training Conference 2026</a:t>
             </a:r>
+            <a:r>
+              <a:rPr lang="en-US"/>
+              <a:t>  ·  </a:t>
+            </a:r>
+            <a:r>
+              <a:rPr lang="en-US">
+                <a:hlinkClick r:id="rIdGitHubFooter">
+                  <a:extLst>
+                    <a:ext uri="{A12FA001-AC4F-418D-AE19-62706E023703}">
+                      <ahyp:hlinkClr xmlns:ahyp="http://schemas.microsoft.com/office/drawing/2018/hyperlinkcolor" val="tx"/>
+                    </a:ext>
+                  </a:extLst>
+                </a:hlinkClick>
+              </a:rPr>
+              <a:t>github.com/dzampino/crt-essentials-2026</a:t>
+            </a:r>
           </a:p>
         </p:txBody>
       </p:sp>
@@ -25257,6 +26425,22 @@
             <a:r>
               <a:rPr lang="en-US"/>
               <a:t>CRT Annual Training Conference 2026</a:t>
+            </a:r>
+            <a:r>
+              <a:rPr lang="en-US"/>
+              <a:t>  ·  </a:t>
+            </a:r>
+            <a:r>
+              <a:rPr lang="en-US">
+                <a:hlinkClick r:id="rIdGitHubFooter">
+                  <a:extLst>
+                    <a:ext uri="{A12FA001-AC4F-418D-AE19-62706E023703}">
+                      <ahyp:hlinkClr xmlns:ahyp="http://schemas.microsoft.com/office/drawing/2018/hyperlinkcolor" val="tx"/>
+                    </a:ext>
+                  </a:extLst>
+                </a:hlinkClick>
+              </a:rPr>
+              <a:t>github.com/dzampino/crt-essentials-2026</a:t>
             </a:r>
           </a:p>
         </p:txBody>
@@ -25908,6 +27092,22 @@
               <a:rPr lang="en-US"/>
               <a:t>CRT Annual Training Conference 2026</a:t>
             </a:r>
+            <a:r>
+              <a:rPr lang="en-US"/>
+              <a:t>  ·  </a:t>
+            </a:r>
+            <a:r>
+              <a:rPr lang="en-US">
+                <a:hlinkClick r:id="rIdGitHubFooter">
+                  <a:extLst>
+                    <a:ext uri="{A12FA001-AC4F-418D-AE19-62706E023703}">
+                      <ahyp:hlinkClr xmlns:ahyp="http://schemas.microsoft.com/office/drawing/2018/hyperlinkcolor" val="tx"/>
+                    </a:ext>
+                  </a:extLst>
+                </a:hlinkClick>
+              </a:rPr>
+              <a:t>github.com/dzampino/crt-essentials-2026</a:t>
+            </a:r>
           </a:p>
         </p:txBody>
       </p:sp>
@@ -26084,6 +27284,22 @@
             <a:r>
               <a:rPr lang="en-US"/>
               <a:t>CRT Annual Training Conference 2026</a:t>
+            </a:r>
+            <a:r>
+              <a:rPr lang="en-US"/>
+              <a:t>  ·  </a:t>
+            </a:r>
+            <a:r>
+              <a:rPr lang="en-US">
+                <a:hlinkClick r:id="rIdGitHubFooter">
+                  <a:extLst>
+                    <a:ext uri="{A12FA001-AC4F-418D-AE19-62706E023703}">
+                      <ahyp:hlinkClr xmlns:ahyp="http://schemas.microsoft.com/office/drawing/2018/hyperlinkcolor" val="tx"/>
+                    </a:ext>
+                  </a:extLst>
+                </a:hlinkClick>
+              </a:rPr>
+              <a:t>github.com/dzampino/crt-essentials-2026</a:t>
             </a:r>
           </a:p>
         </p:txBody>

</xml_diff>

<commit_message>
Deck: SPF slide says where the IP and the domain come from
Co-Authored-By: Claude Opus 5.5 <noreply@anthropic.com>
</commit_message>
<xml_diff>
--- a/docs/files/crt-essentials.pptx
+++ b/docs/files/crt-essentials.pptx
@@ -1987,7 +1987,7 @@
             </a:pPr>
             <a:r>
               <a:rPr/>
-              <a:t>RFC 7208: SPF checks the MAIL FROM domain (or the HELO domain when MAIL FROM is empty), not the From header. https://www.rfc-editor.org/rfc/rfc7208.html</a:t>
+              <a:t>RFC 7208: SPF checks the MAIL FROM domain (or the HELO domain when MAIL FROM is empty), not the From header. https://www.rfc-editor.org/rfc/rfc7208.html Section 4.1: the IP is “the IP address of the SMTP client that is emitting the mail”. Section 2.3 also recommends checking the HELO identity on its own; section 2.4 covers the empty MAIL FROM of bounces, where the check uses postmaster@ the HELO name.</a:t>
             </a:r>
           </a:p>
           <a:p>
@@ -13206,6 +13206,60 @@
             <a:r>
               <a:rPr/>
               <a:t>What SPF checks: is this IP allowed to send for the envelope domain?</a:t>
+            </a:r>
+          </a:p>
+          <a:p>
+            <a:pPr lvl="1"/>
+            <a:r>
+              <a:rPr/>
+              <a:t>The IP: the server connecting to the receiver, not anything in the message</a:t>
+            </a:r>
+          </a:p>
+          <a:p>
+            <a:pPr lvl="1"/>
+            <a:r>
+              <a:rPr/>
+              <a:t>The domain: </a:t>
+            </a:r>
+            <a:r>
+              <a:rPr>
+                <a:latin typeface="Consolas"/>
+              </a:rPr>
+              <a:t>MAIL FROM</a:t>
+            </a:r>
+            <a:r>
+              <a:rPr/>
+              <a:t>, or the </a:t>
+            </a:r>
+            <a:r>
+              <a:rPr>
+                <a:latin typeface="Consolas"/>
+              </a:rPr>
+              <a:t>HELO</a:t>
+            </a:r>
+            <a:r>
+              <a:rPr/>
+              <a:t>/</a:t>
+            </a:r>
+            <a:r>
+              <a:rPr>
+                <a:latin typeface="Consolas"/>
+              </a:rPr>
+              <a:t>EHLO</a:t>
+            </a:r>
+            <a:r>
+              <a:rPr/>
+              <a:t> name when </a:t>
+            </a:r>
+            <a:r>
+              <a:rPr>
+                <a:latin typeface="Consolas"/>
+              </a:rPr>
+              <a:t>MAIL FROM</a:t>
+            </a:r>
+            <a:r>
+              <a:rPr/>
+              <a:t> is empty</a:t>
             </a:r>
           </a:p>
           <a:p>

</xml_diff>

<commit_message>
Deck: wildcard example on the Verb-Noun slide
Co-Authored-By: Claude Opus 5.5 <noreply@anthropic.com>
</commit_message>
<xml_diff>
--- a/docs/files/crt-essentials.pptx
+++ b/docs/files/crt-essentials.pptx
@@ -18654,6 +18654,52 @@
                 </a:solidFill>
                 <a:latin typeface="Consolas"/>
               </a:rPr>
+              <a:t>Get-Command</a:t>
+            </a:r>
+            <a:r>
+              <a:rPr>
+                <a:solidFill>
+                  <a:srgbClr val="1A1D23"/>
+                </a:solidFill>
+                <a:latin typeface="Consolas"/>
+              </a:rPr>
+              <a:t> Get-</a:t>
+            </a:r>
+            <a:r>
+              <a:rPr>
+                <a:solidFill>
+                  <a:srgbClr val="5A6472"/>
+                </a:solidFill>
+                <a:latin typeface="Consolas"/>
+              </a:rPr>
+              <a:t>*</a:t>
+            </a:r>
+            <a:r>
+              <a:rPr>
+                <a:solidFill>
+                  <a:srgbClr val="1A1D23"/>
+                </a:solidFill>
+                <a:latin typeface="Consolas"/>
+              </a:rPr>
+              <a:t>Event         </a:t>
+            </a:r>
+            <a:r>
+              <a:rPr i="1">
+                <a:solidFill>
+                  <a:srgbClr val="6B7480"/>
+                </a:solidFill>
+                <a:latin typeface="Consolas"/>
+              </a:rPr>
+              <a:t># * matches anything: Get-Event, Get-WinEvent</a:t>
+            </a:r>
+            <a:br/>
+            <a:r>
+              <a:rPr>
+                <a:solidFill>
+                  <a:srgbClr val="034BAB"/>
+                </a:solidFill>
+                <a:latin typeface="Consolas"/>
+              </a:rPr>
               <a:t>Get-Service</a:t>
             </a:r>
             <a:r>

</xml_diff>